<commit_message>
update slides for 2026
</commit_message>
<xml_diff>
--- a/UnitTestingSlides.pptx
+++ b/UnitTestingSlides.pptx
@@ -5,36 +5,37 @@
     <p:sldMasterId id="2147483648" r:id="rId1"/>
   </p:sldMasterIdLst>
   <p:notesMasterIdLst>
-    <p:notesMasterId r:id="rId29"/>
+    <p:notesMasterId r:id="rId30"/>
   </p:notesMasterIdLst>
   <p:sldIdLst>
     <p:sldId id="256" r:id="rId2"/>
     <p:sldId id="273" r:id="rId3"/>
     <p:sldId id="257" r:id="rId4"/>
-    <p:sldId id="258" r:id="rId5"/>
-    <p:sldId id="282" r:id="rId6"/>
-    <p:sldId id="259" r:id="rId7"/>
-    <p:sldId id="260" r:id="rId8"/>
-    <p:sldId id="261" r:id="rId9"/>
-    <p:sldId id="263" r:id="rId10"/>
-    <p:sldId id="277" r:id="rId11"/>
-    <p:sldId id="280" r:id="rId12"/>
-    <p:sldId id="272" r:id="rId13"/>
-    <p:sldId id="278" r:id="rId14"/>
-    <p:sldId id="265" r:id="rId15"/>
-    <p:sldId id="279" r:id="rId16"/>
-    <p:sldId id="266" r:id="rId17"/>
-    <p:sldId id="267" r:id="rId18"/>
-    <p:sldId id="268" r:id="rId19"/>
-    <p:sldId id="262" r:id="rId20"/>
-    <p:sldId id="276" r:id="rId21"/>
-    <p:sldId id="274" r:id="rId22"/>
-    <p:sldId id="271" r:id="rId23"/>
-    <p:sldId id="264" r:id="rId24"/>
-    <p:sldId id="275" r:id="rId25"/>
-    <p:sldId id="281" r:id="rId26"/>
-    <p:sldId id="269" r:id="rId27"/>
-    <p:sldId id="270" r:id="rId28"/>
+    <p:sldId id="283" r:id="rId5"/>
+    <p:sldId id="258" r:id="rId6"/>
+    <p:sldId id="282" r:id="rId7"/>
+    <p:sldId id="259" r:id="rId8"/>
+    <p:sldId id="260" r:id="rId9"/>
+    <p:sldId id="261" r:id="rId10"/>
+    <p:sldId id="263" r:id="rId11"/>
+    <p:sldId id="277" r:id="rId12"/>
+    <p:sldId id="280" r:id="rId13"/>
+    <p:sldId id="272" r:id="rId14"/>
+    <p:sldId id="278" r:id="rId15"/>
+    <p:sldId id="265" r:id="rId16"/>
+    <p:sldId id="279" r:id="rId17"/>
+    <p:sldId id="266" r:id="rId18"/>
+    <p:sldId id="267" r:id="rId19"/>
+    <p:sldId id="268" r:id="rId20"/>
+    <p:sldId id="262" r:id="rId21"/>
+    <p:sldId id="276" r:id="rId22"/>
+    <p:sldId id="274" r:id="rId23"/>
+    <p:sldId id="271" r:id="rId24"/>
+    <p:sldId id="264" r:id="rId25"/>
+    <p:sldId id="275" r:id="rId26"/>
+    <p:sldId id="281" r:id="rId27"/>
+    <p:sldId id="269" r:id="rId28"/>
+    <p:sldId id="270" r:id="rId29"/>
   </p:sldIdLst>
   <p:sldSz cx="12192000" cy="6858000"/>
   <p:notesSz cx="6858000" cy="9144000"/>
@@ -223,7 +224,7 @@
           <a:p>
             <a:fld id="{EF6A6A60-C693-BC49-85A7-98B318EF45A1}" type="datetimeFigureOut">
               <a:rPr lang="en-US" smtClean="0"/>
-              <a:t>1/20/25</a:t>
+              <a:t>1/10/26</a:t>
             </a:fld>
             <a:endParaRPr lang="en-US"/>
           </a:p>
@@ -723,7 +724,7 @@
           <a:p>
             <a:fld id="{36CD89F0-D00C-704A-A77B-5E0A27D974ED}" type="slidenum">
               <a:rPr lang="en-US" smtClean="0"/>
-              <a:t>4</a:t>
+              <a:t>5</a:t>
             </a:fld>
             <a:endParaRPr lang="en-US"/>
           </a:p>
@@ -807,7 +808,7 @@
           <a:p>
             <a:fld id="{36CD89F0-D00C-704A-A77B-5E0A27D974ED}" type="slidenum">
               <a:rPr lang="en-US" smtClean="0"/>
-              <a:t>6</a:t>
+              <a:t>7</a:t>
             </a:fld>
             <a:endParaRPr lang="en-US"/>
           </a:p>
@@ -891,7 +892,7 @@
           <a:p>
             <a:fld id="{36CD89F0-D00C-704A-A77B-5E0A27D974ED}" type="slidenum">
               <a:rPr lang="en-US" smtClean="0"/>
-              <a:t>7</a:t>
+              <a:t>8</a:t>
             </a:fld>
             <a:endParaRPr lang="en-US"/>
           </a:p>
@@ -975,7 +976,7 @@
           <a:p>
             <a:fld id="{36CD89F0-D00C-704A-A77B-5E0A27D974ED}" type="slidenum">
               <a:rPr lang="en-US" smtClean="0"/>
-              <a:t>8</a:t>
+              <a:t>9</a:t>
             </a:fld>
             <a:endParaRPr lang="en-US"/>
           </a:p>
@@ -1059,7 +1060,7 @@
           <a:p>
             <a:fld id="{36CD89F0-D00C-704A-A77B-5E0A27D974ED}" type="slidenum">
               <a:rPr lang="en-US" smtClean="0"/>
-              <a:t>12</a:t>
+              <a:t>13</a:t>
             </a:fld>
             <a:endParaRPr lang="en-US"/>
           </a:p>
@@ -1143,7 +1144,7 @@
           <a:p>
             <a:fld id="{36CD89F0-D00C-704A-A77B-5E0A27D974ED}" type="slidenum">
               <a:rPr lang="en-US" smtClean="0"/>
-              <a:t>15</a:t>
+              <a:t>16</a:t>
             </a:fld>
             <a:endParaRPr lang="en-US"/>
           </a:p>
@@ -1279,6 +1280,13 @@
             <a:schemeClr val="lt1"/>
           </a:fontRef>
         </p:style>
+        <p:txBody>
+          <a:bodyPr/>
+          <a:lstStyle/>
+          <a:p>
+            <a:endParaRPr lang="en-US"/>
+          </a:p>
+        </p:txBody>
       </p:sp>
       <p:sp>
         <p:nvSpPr>
@@ -1317,6 +1325,13 @@
             <a:schemeClr val="lt1"/>
           </a:fontRef>
         </p:style>
+        <p:txBody>
+          <a:bodyPr/>
+          <a:lstStyle/>
+          <a:p>
+            <a:endParaRPr lang="en-US"/>
+          </a:p>
+        </p:txBody>
       </p:sp>
       <p:sp>
         <p:nvSpPr>
@@ -1436,7 +1451,7 @@
           <a:p>
             <a:fld id="{78ABE3C1-DBE1-495D-B57B-2849774B866A}" type="datetimeFigureOut">
               <a:rPr lang="en-US" dirty="0"/>
-              <a:t>1/20/25</a:t>
+              <a:t>1/10/26</a:t>
             </a:fld>
             <a:endParaRPr lang="en-US" dirty="0"/>
           </a:p>
@@ -1845,7 +1860,7 @@
           <a:p>
             <a:fld id="{446C117F-5CCF-4837-BE5F-2B92066CAFAF}" type="datetimeFigureOut">
               <a:rPr lang="en-US" dirty="0"/>
-              <a:t>1/20/25</a:t>
+              <a:t>1/10/26</a:t>
             </a:fld>
             <a:endParaRPr lang="en-US" dirty="0"/>
           </a:p>
@@ -2176,7 +2191,7 @@
           <a:p>
             <a:fld id="{84EB90BD-B6CE-46B7-997F-7313B992CCDC}" type="datetimeFigureOut">
               <a:rPr lang="en-US" dirty="0"/>
-              <a:t>1/20/25</a:t>
+              <a:t>1/10/26</a:t>
             </a:fld>
             <a:endParaRPr lang="en-US" dirty="0"/>
           </a:p>
@@ -2576,7 +2591,7 @@
           <a:p>
             <a:fld id="{CDB9D11F-B188-461D-B23F-39381795C052}" type="datetimeFigureOut">
               <a:rPr lang="en-US" dirty="0"/>
-              <a:t>1/20/25</a:t>
+              <a:t>1/10/26</a:t>
             </a:fld>
             <a:endParaRPr lang="en-US" dirty="0"/>
           </a:p>
@@ -3139,7 +3154,7 @@
           <a:p>
             <a:fld id="{52E6D8D9-55A2-4063-B0F3-121F44549695}" type="datetimeFigureOut">
               <a:rPr lang="en-US" dirty="0"/>
-              <a:t>1/20/25</a:t>
+              <a:t>1/10/26</a:t>
             </a:fld>
             <a:endParaRPr lang="en-US" dirty="0"/>
           </a:p>
@@ -3815,7 +3830,7 @@
           <a:p>
             <a:fld id="{D4B24536-994D-4021-A283-9F449C0DB509}" type="datetimeFigureOut">
               <a:rPr lang="en-US" dirty="0"/>
-              <a:t>1/20/25</a:t>
+              <a:t>1/10/26</a:t>
             </a:fld>
             <a:endParaRPr lang="en-US" dirty="0"/>
           </a:p>
@@ -4723,7 +4738,7 @@
           <a:p>
             <a:fld id="{3CBBBB78-C96F-47B7-AB17-D852CA960AC9}" type="datetimeFigureOut">
               <a:rPr lang="en-US" dirty="0"/>
-              <a:t>1/20/25</a:t>
+              <a:t>1/10/26</a:t>
             </a:fld>
             <a:endParaRPr lang="en-US" dirty="0"/>
           </a:p>
@@ -5031,7 +5046,7 @@
           <a:p>
             <a:fld id="{1FA3F48C-C7C6-4055-9F49-3777875E72AE}" type="datetimeFigureOut">
               <a:rPr lang="en-US" dirty="0"/>
-              <a:t>1/20/25</a:t>
+              <a:t>1/10/26</a:t>
             </a:fld>
             <a:endParaRPr lang="en-US" dirty="0"/>
           </a:p>
@@ -5290,7 +5305,7 @@
           <a:p>
             <a:fld id="{6178E61D-D431-422C-9764-11DAFE33AB63}" type="datetimeFigureOut">
               <a:rPr lang="en-US" dirty="0"/>
-              <a:t>1/20/25</a:t>
+              <a:t>1/10/26</a:t>
             </a:fld>
             <a:endParaRPr lang="en-US" dirty="0"/>
           </a:p>
@@ -5609,7 +5624,7 @@
           <a:p>
             <a:fld id="{12DE42F4-6EEF-4EF7-8ED4-2208F0F89A08}" type="datetimeFigureOut">
               <a:rPr lang="en-US" dirty="0"/>
-              <a:t>1/20/25</a:t>
+              <a:t>1/10/26</a:t>
             </a:fld>
             <a:endParaRPr lang="en-US" dirty="0"/>
           </a:p>
@@ -5993,7 +6008,7 @@
           <a:p>
             <a:fld id="{30578ACC-22D6-47C1-A373-4FD133E34F3C}" type="datetimeFigureOut">
               <a:rPr lang="en-US" dirty="0"/>
-              <a:t>1/20/25</a:t>
+              <a:t>1/10/26</a:t>
             </a:fld>
             <a:endParaRPr lang="en-US" dirty="0"/>
           </a:p>
@@ -6364,7 +6379,7 @@
           <a:p>
             <a:fld id="{4E5A6C69-6797-4E8A-BF37-F2C3751466E9}" type="datetimeFigureOut">
               <a:rPr lang="en-US" dirty="0"/>
-              <a:t>1/20/25</a:t>
+              <a:t>1/10/26</a:t>
             </a:fld>
             <a:endParaRPr lang="en-US" dirty="0"/>
           </a:p>
@@ -6865,7 +6880,7 @@
           <a:p>
             <a:fld id="{D82014A1-A632-4878-A0D3-F52BA7563730}" type="datetimeFigureOut">
               <a:rPr lang="en-US" dirty="0"/>
-              <a:t>1/20/25</a:t>
+              <a:t>1/10/26</a:t>
             </a:fld>
             <a:endParaRPr lang="en-US" dirty="0"/>
           </a:p>
@@ -7117,7 +7132,7 @@
           <a:p>
             <a:fld id="{CE99F462-093F-4566-844B-4C71F2739DA5}" type="datetimeFigureOut">
               <a:rPr lang="en-US" dirty="0"/>
-              <a:t>1/20/25</a:t>
+              <a:t>1/10/26</a:t>
             </a:fld>
             <a:endParaRPr lang="en-US" dirty="0"/>
           </a:p>
@@ -7275,7 +7290,7 @@
           <a:p>
             <a:fld id="{3D24A7AC-904D-4781-85BA-7D10C17ED021}" type="datetimeFigureOut">
               <a:rPr lang="en-US" dirty="0"/>
-              <a:t>1/20/25</a:t>
+              <a:t>1/10/26</a:t>
             </a:fld>
             <a:endParaRPr lang="en-US" dirty="0"/>
           </a:p>
@@ -7660,7 +7675,7 @@
           <a:p>
             <a:fld id="{E331444B-B92B-4E27-8C94-BB93EAF5CB18}" type="datetimeFigureOut">
               <a:rPr lang="en-US" dirty="0"/>
-              <a:t>1/20/25</a:t>
+              <a:t>1/10/26</a:t>
             </a:fld>
             <a:endParaRPr lang="en-US" dirty="0"/>
           </a:p>
@@ -8064,7 +8079,7 @@
           <a:p>
             <a:fld id="{363EFA5E-FA76-400D-B3DC-F0BA90E6D107}" type="datetimeFigureOut">
               <a:rPr lang="en-US" dirty="0"/>
-              <a:t>1/20/25</a:t>
+              <a:t>1/10/26</a:t>
             </a:fld>
             <a:endParaRPr lang="en-US" dirty="0"/>
           </a:p>
@@ -8303,7 +8318,7 @@
           <a:p>
             <a:fld id="{9D6E9DEC-419B-4CC5-A080-3B06BD5A8291}" type="datetimeFigureOut">
               <a:rPr lang="en-US" dirty="0"/>
-              <a:t>1/20/25</a:t>
+              <a:t>1/10/26</a:t>
             </a:fld>
             <a:endParaRPr lang="en-US" dirty="0"/>
           </a:p>
@@ -8781,7 +8796,7 @@
             </a:r>
             <a:r>
               <a:rPr lang="en-US" dirty="0"/>
-              <a:t> 2025</a:t>
+              <a:t> 2026</a:t>
             </a:r>
           </a:p>
           <a:p>
@@ -8907,7 +8922,7 @@
         <p:spPr>
           <a:xfrm>
             <a:off x="338484" y="5865670"/>
-            <a:ext cx="10501593" cy="1107996"/>
+            <a:ext cx="10873489" cy="1107996"/>
           </a:xfrm>
           <a:prstGeom prst="rect">
             <a:avLst/>
@@ -8941,7 +8956,7 @@
                 <a:effectLst/>
                 <a:latin typeface="Menlo" panose="020B0609030804020204" pitchFamily="49" charset="0"/>
               </a:rPr>
-              <a:t>source /scratch/environments/</a:t>
+              <a:t>source /scratch/network/wh3248/</a:t>
             </a:r>
             <a:r>
               <a:rPr lang="en-US" sz="2400" b="0" dirty="0" err="1">
@@ -8977,6 +8992,546 @@
 </file>
 
 <file path=ppt/slides/slide10.xml><?xml version="1.0" encoding="utf-8"?>
+<p:sld xmlns:a="http://schemas.openxmlformats.org/drawingml/2006/main" xmlns:r="http://schemas.openxmlformats.org/officeDocument/2006/relationships" xmlns:p="http://schemas.openxmlformats.org/presentationml/2006/main">
+  <p:cSld>
+    <p:spTree>
+      <p:nvGrpSpPr>
+        <p:cNvPr id="1" name=""/>
+        <p:cNvGrpSpPr/>
+        <p:nvPr/>
+      </p:nvGrpSpPr>
+      <p:grpSpPr>
+        <a:xfrm>
+          <a:off x="0" y="0"/>
+          <a:ext cx="0" cy="0"/>
+          <a:chOff x="0" y="0"/>
+          <a:chExt cx="0" cy="0"/>
+        </a:xfrm>
+      </p:grpSpPr>
+      <p:sp>
+        <p:nvSpPr>
+          <p:cNvPr id="2" name="Title 1">
+            <a:extLst>
+              <a:ext uri="{FF2B5EF4-FFF2-40B4-BE49-F238E27FC236}">
+                <a16:creationId xmlns:a16="http://schemas.microsoft.com/office/drawing/2014/main" id="{7B1BC8CA-23DC-00F6-9485-97991DED6A35}"/>
+              </a:ext>
+            </a:extLst>
+          </p:cNvPr>
+          <p:cNvSpPr>
+            <a:spLocks noGrp="1"/>
+          </p:cNvSpPr>
+          <p:nvPr>
+            <p:ph type="title"/>
+          </p:nvPr>
+        </p:nvSpPr>
+        <p:spPr/>
+        <p:txBody>
+          <a:bodyPr/>
+          <a:lstStyle/>
+          <a:p>
+            <a:r>
+              <a:rPr lang="en-US" dirty="0"/>
+              <a:t>02 </a:t>
+            </a:r>
+            <a:r>
+              <a:rPr lang="en-US" dirty="0" err="1"/>
+              <a:t>PyTest</a:t>
+            </a:r>
+            <a:endParaRPr lang="en-US" dirty="0"/>
+          </a:p>
+        </p:txBody>
+      </p:sp>
+      <p:sp>
+        <p:nvSpPr>
+          <p:cNvPr id="3" name="Content Placeholder 2">
+            <a:extLst>
+              <a:ext uri="{FF2B5EF4-FFF2-40B4-BE49-F238E27FC236}">
+                <a16:creationId xmlns:a16="http://schemas.microsoft.com/office/drawing/2014/main" id="{D133F77E-93E8-297B-19D0-2CEFDBCB06FD}"/>
+              </a:ext>
+            </a:extLst>
+          </p:cNvPr>
+          <p:cNvSpPr>
+            <a:spLocks noGrp="1"/>
+          </p:cNvSpPr>
+          <p:nvPr>
+            <p:ph idx="1"/>
+          </p:nvPr>
+        </p:nvSpPr>
+        <p:spPr>
+          <a:xfrm>
+            <a:off x="680321" y="2184472"/>
+            <a:ext cx="10402718" cy="4673528"/>
+          </a:xfrm>
+        </p:spPr>
+        <p:txBody>
+          <a:bodyPr>
+            <a:normAutofit/>
+          </a:bodyPr>
+          <a:lstStyle/>
+          <a:p>
+            <a:pPr marL="0" indent="0">
+              <a:buNone/>
+            </a:pPr>
+            <a:r>
+              <a:rPr lang="en-US" dirty="0"/>
+              <a:t>Requires “pip install </a:t>
+            </a:r>
+            <a:r>
+              <a:rPr lang="en-US" dirty="0" err="1"/>
+              <a:t>pytest</a:t>
+            </a:r>
+            <a:r>
+              <a:rPr lang="en-US" dirty="0"/>
+              <a:t>”</a:t>
+            </a:r>
+          </a:p>
+          <a:p>
+            <a:pPr marL="0" indent="0">
+              <a:buNone/>
+            </a:pPr>
+            <a:r>
+              <a:rPr lang="en-US" dirty="0"/>
+              <a:t>(See example 02_pytest/examples/</a:t>
+            </a:r>
+            <a:r>
+              <a:rPr lang="en-US" dirty="0" err="1"/>
+              <a:t>test_geometric_area.py</a:t>
+            </a:r>
+            <a:r>
+              <a:rPr lang="en-US" dirty="0"/>
+              <a:t>)</a:t>
+            </a:r>
+          </a:p>
+          <a:p>
+            <a:pPr marL="0" indent="0">
+              <a:buNone/>
+            </a:pPr>
+            <a:br>
+              <a:rPr lang="en-US" dirty="0"/>
+            </a:br>
+            <a:endParaRPr lang="en-US" dirty="0"/>
+          </a:p>
+          <a:p>
+            <a:endParaRPr lang="en-US" dirty="0"/>
+          </a:p>
+          <a:p>
+            <a:endParaRPr lang="en-US" dirty="0"/>
+          </a:p>
+          <a:p>
+            <a:endParaRPr lang="en-US" dirty="0"/>
+          </a:p>
+          <a:p>
+            <a:endParaRPr lang="en-US" dirty="0"/>
+          </a:p>
+          <a:p>
+            <a:r>
+              <a:rPr lang="en-US" dirty="0"/>
+              <a:t>Execute with </a:t>
+            </a:r>
+            <a:r>
+              <a:rPr lang="en-US" dirty="0" err="1"/>
+              <a:t>pytest</a:t>
+            </a:r>
+            <a:r>
+              <a:rPr lang="en-US" dirty="0"/>
+              <a:t> command (in directory 02_pytest/examples):</a:t>
+            </a:r>
+          </a:p>
+          <a:p>
+            <a:pPr marL="457200" lvl="1" indent="0">
+              <a:buNone/>
+            </a:pPr>
+            <a:r>
+              <a:rPr lang="en-US" dirty="0"/>
+              <a:t>  </a:t>
+            </a:r>
+            <a:r>
+              <a:rPr lang="en-US" sz="2400" dirty="0" err="1"/>
+              <a:t>pytest</a:t>
+            </a:r>
+            <a:r>
+              <a:rPr lang="en-US" sz="2400" dirty="0"/>
+              <a:t> </a:t>
+            </a:r>
+            <a:r>
+              <a:rPr lang="en-US" sz="2400" dirty="0" err="1"/>
+              <a:t>test_geometric_area.py</a:t>
+            </a:r>
+            <a:endParaRPr lang="en-US" sz="2400" dirty="0"/>
+          </a:p>
+        </p:txBody>
+      </p:sp>
+      <p:sp>
+        <p:nvSpPr>
+          <p:cNvPr id="4" name="TextBox 3">
+            <a:extLst>
+              <a:ext uri="{FF2B5EF4-FFF2-40B4-BE49-F238E27FC236}">
+                <a16:creationId xmlns:a16="http://schemas.microsoft.com/office/drawing/2014/main" id="{E07ED173-C2F9-18B9-8090-CCB1DFE7FA10}"/>
+              </a:ext>
+            </a:extLst>
+          </p:cNvPr>
+          <p:cNvSpPr txBox="1"/>
+          <p:nvPr/>
+        </p:nvSpPr>
+        <p:spPr>
+          <a:xfrm>
+            <a:off x="1469178" y="3323915"/>
+            <a:ext cx="9613861" cy="2677656"/>
+          </a:xfrm>
+          <a:prstGeom prst="rect">
+            <a:avLst/>
+          </a:prstGeom>
+          <a:noFill/>
+        </p:spPr>
+        <p:txBody>
+          <a:bodyPr wrap="square" rtlCol="0">
+            <a:spAutoFit/>
+          </a:bodyPr>
+          <a:lstStyle/>
+          <a:p>
+            <a:pPr marL="0" indent="0">
+              <a:buNone/>
+            </a:pPr>
+            <a:r>
+              <a:rPr lang="en-US" sz="2400" dirty="0">
+                <a:latin typeface="Courier" pitchFamily="2" charset="0"/>
+              </a:rPr>
+              <a:t>import math</a:t>
+            </a:r>
+          </a:p>
+          <a:p>
+            <a:pPr marL="0" indent="0">
+              <a:buNone/>
+            </a:pPr>
+            <a:r>
+              <a:rPr lang="en-US" sz="2400" dirty="0">
+                <a:latin typeface="Courier" pitchFamily="2" charset="0"/>
+              </a:rPr>
+              <a:t>import </a:t>
+            </a:r>
+            <a:r>
+              <a:rPr lang="en-US" sz="2400" dirty="0" err="1">
+                <a:latin typeface="Courier" pitchFamily="2" charset="0"/>
+              </a:rPr>
+              <a:t>geometric_area</a:t>
+            </a:r>
+            <a:endParaRPr lang="en-US" sz="2400" dirty="0">
+              <a:latin typeface="Courier" pitchFamily="2" charset="0"/>
+            </a:endParaRPr>
+          </a:p>
+          <a:p>
+            <a:pPr marL="0" indent="0">
+              <a:buNone/>
+            </a:pPr>
+            <a:endParaRPr lang="en-US" sz="2400" dirty="0">
+              <a:latin typeface="Courier" pitchFamily="2" charset="0"/>
+            </a:endParaRPr>
+          </a:p>
+          <a:p>
+            <a:pPr marL="0" indent="0">
+              <a:buNone/>
+            </a:pPr>
+            <a:r>
+              <a:rPr lang="en-US" sz="2400" dirty="0">
+                <a:latin typeface="Courier" pitchFamily="2" charset="0"/>
+              </a:rPr>
+              <a:t>def </a:t>
+            </a:r>
+            <a:r>
+              <a:rPr lang="en-US" sz="2400" dirty="0" err="1">
+                <a:latin typeface="Courier" pitchFamily="2" charset="0"/>
+              </a:rPr>
+              <a:t>test_area</a:t>
+            </a:r>
+            <a:r>
+              <a:rPr lang="en-US" sz="2400" dirty="0">
+                <a:latin typeface="Courier" pitchFamily="2" charset="0"/>
+              </a:rPr>
+              <a:t>():</a:t>
+            </a:r>
+          </a:p>
+          <a:p>
+            <a:pPr marL="0" indent="0">
+              <a:buNone/>
+            </a:pPr>
+            <a:r>
+              <a:rPr lang="en-US" sz="2400" dirty="0">
+                <a:latin typeface="Courier" pitchFamily="2" charset="0"/>
+              </a:rPr>
+              <a:t>	assert </a:t>
+            </a:r>
+            <a:r>
+              <a:rPr lang="en-US" sz="2400" dirty="0" err="1">
+                <a:latin typeface="Courier" pitchFamily="2" charset="0"/>
+              </a:rPr>
+              <a:t>geometric_area.circle_area</a:t>
+            </a:r>
+            <a:r>
+              <a:rPr lang="en-US" sz="2400" dirty="0">
+                <a:latin typeface="Courier" pitchFamily="2" charset="0"/>
+              </a:rPr>
+              <a:t>(1) = </a:t>
+            </a:r>
+            <a:r>
+              <a:rPr lang="en-US" sz="2400" dirty="0" err="1">
+                <a:latin typeface="Courier" pitchFamily="2" charset="0"/>
+              </a:rPr>
+              <a:t>math.pi</a:t>
+            </a:r>
+            <a:endParaRPr lang="en-US" sz="2400" dirty="0">
+              <a:latin typeface="Courier" pitchFamily="2" charset="0"/>
+            </a:endParaRPr>
+          </a:p>
+          <a:p>
+            <a:r>
+              <a:rPr lang="en-US" sz="2400" dirty="0">
+                <a:latin typeface="Courier" pitchFamily="2" charset="0"/>
+              </a:rPr>
+              <a:t>	assert </a:t>
+            </a:r>
+            <a:r>
+              <a:rPr lang="en-US" sz="2400" dirty="0" err="1">
+                <a:latin typeface="Courier" pitchFamily="2" charset="0"/>
+              </a:rPr>
+              <a:t>geometric_area.circle_area</a:t>
+            </a:r>
+            <a:r>
+              <a:rPr lang="en-US" sz="2400" dirty="0">
+                <a:latin typeface="Courier" pitchFamily="2" charset="0"/>
+              </a:rPr>
+              <a:t>(0) = 0</a:t>
+            </a:r>
+            <a:br>
+              <a:rPr lang="en-US" sz="2400" dirty="0">
+                <a:latin typeface="Courier" pitchFamily="2" charset="0"/>
+              </a:rPr>
+            </a:br>
+            <a:endParaRPr lang="en-US" sz="2400" dirty="0">
+              <a:latin typeface="Courier" pitchFamily="2" charset="0"/>
+            </a:endParaRPr>
+          </a:p>
+        </p:txBody>
+      </p:sp>
+    </p:spTree>
+    <p:extLst>
+      <p:ext uri="{BB962C8B-B14F-4D97-AF65-F5344CB8AC3E}">
+        <p14:creationId xmlns:p14="http://schemas.microsoft.com/office/powerpoint/2010/main" val="376151755"/>
+      </p:ext>
+    </p:extLst>
+  </p:cSld>
+  <p:clrMapOvr>
+    <a:masterClrMapping/>
+  </p:clrMapOvr>
+  <p:timing>
+    <p:tnLst>
+      <p:par>
+        <p:cTn id="1" dur="indefinite" restart="never" nodeType="tmRoot">
+          <p:childTnLst>
+            <p:seq concurrent="1" nextAc="seek">
+              <p:cTn id="2" dur="indefinite" nodeType="mainSeq">
+                <p:childTnLst>
+                  <p:par>
+                    <p:cTn id="3" fill="hold">
+                      <p:stCondLst>
+                        <p:cond delay="indefinite"/>
+                        <p:cond evt="onBegin" delay="0">
+                          <p:tn val="2"/>
+                        </p:cond>
+                      </p:stCondLst>
+                      <p:childTnLst>
+                        <p:par>
+                          <p:cTn id="4" fill="hold">
+                            <p:stCondLst>
+                              <p:cond delay="0"/>
+                            </p:stCondLst>
+                            <p:childTnLst>
+                              <p:par>
+                                <p:cTn id="5" presetID="1" presetClass="entr" presetSubtype="0" fill="hold" nodeType="withEffect">
+                                  <p:stCondLst>
+                                    <p:cond delay="0"/>
+                                  </p:stCondLst>
+                                  <p:childTnLst>
+                                    <p:set>
+                                      <p:cBhvr>
+                                        <p:cTn id="6" dur="1" fill="hold">
+                                          <p:stCondLst>
+                                            <p:cond delay="0"/>
+                                          </p:stCondLst>
+                                        </p:cTn>
+                                        <p:tgtEl>
+                                          <p:spTgt spid="4">
+                                            <p:txEl>
+                                              <p:pRg st="1" end="1"/>
+                                            </p:txEl>
+                                          </p:spTgt>
+                                        </p:tgtEl>
+                                        <p:attrNameLst>
+                                          <p:attrName>style.visibility</p:attrName>
+                                        </p:attrNameLst>
+                                      </p:cBhvr>
+                                      <p:to>
+                                        <p:strVal val="visible"/>
+                                      </p:to>
+                                    </p:set>
+                                  </p:childTnLst>
+                                </p:cTn>
+                              </p:par>
+                              <p:par>
+                                <p:cTn id="7" presetID="1" presetClass="entr" presetSubtype="0" fill="hold" nodeType="withEffect">
+                                  <p:stCondLst>
+                                    <p:cond delay="0"/>
+                                  </p:stCondLst>
+                                  <p:childTnLst>
+                                    <p:set>
+                                      <p:cBhvr>
+                                        <p:cTn id="8" dur="1" fill="hold">
+                                          <p:stCondLst>
+                                            <p:cond delay="0"/>
+                                          </p:stCondLst>
+                                        </p:cTn>
+                                        <p:tgtEl>
+                                          <p:spTgt spid="4">
+                                            <p:txEl>
+                                              <p:pRg st="0" end="0"/>
+                                            </p:txEl>
+                                          </p:spTgt>
+                                        </p:tgtEl>
+                                        <p:attrNameLst>
+                                          <p:attrName>style.visibility</p:attrName>
+                                        </p:attrNameLst>
+                                      </p:cBhvr>
+                                      <p:to>
+                                        <p:strVal val="visible"/>
+                                      </p:to>
+                                    </p:set>
+                                  </p:childTnLst>
+                                </p:cTn>
+                              </p:par>
+                              <p:par>
+                                <p:cTn id="9" presetID="1" presetClass="entr" presetSubtype="0" fill="hold" nodeType="withEffect">
+                                  <p:stCondLst>
+                                    <p:cond delay="0"/>
+                                  </p:stCondLst>
+                                  <p:childTnLst>
+                                    <p:set>
+                                      <p:cBhvr>
+                                        <p:cTn id="10" dur="1" fill="hold">
+                                          <p:stCondLst>
+                                            <p:cond delay="0"/>
+                                          </p:stCondLst>
+                                        </p:cTn>
+                                        <p:tgtEl>
+                                          <p:spTgt spid="4">
+                                            <p:txEl>
+                                              <p:pRg st="3" end="3"/>
+                                            </p:txEl>
+                                          </p:spTgt>
+                                        </p:tgtEl>
+                                        <p:attrNameLst>
+                                          <p:attrName>style.visibility</p:attrName>
+                                        </p:attrNameLst>
+                                      </p:cBhvr>
+                                      <p:to>
+                                        <p:strVal val="visible"/>
+                                      </p:to>
+                                    </p:set>
+                                  </p:childTnLst>
+                                </p:cTn>
+                              </p:par>
+                              <p:par>
+                                <p:cTn id="11" presetID="1" presetClass="entr" presetSubtype="0" fill="hold" nodeType="withEffect">
+                                  <p:stCondLst>
+                                    <p:cond delay="0"/>
+                                  </p:stCondLst>
+                                  <p:childTnLst>
+                                    <p:set>
+                                      <p:cBhvr>
+                                        <p:cTn id="12" dur="1" fill="hold">
+                                          <p:stCondLst>
+                                            <p:cond delay="0"/>
+                                          </p:stCondLst>
+                                        </p:cTn>
+                                        <p:tgtEl>
+                                          <p:spTgt spid="4">
+                                            <p:txEl>
+                                              <p:pRg st="4" end="4"/>
+                                            </p:txEl>
+                                          </p:spTgt>
+                                        </p:tgtEl>
+                                        <p:attrNameLst>
+                                          <p:attrName>style.visibility</p:attrName>
+                                        </p:attrNameLst>
+                                      </p:cBhvr>
+                                      <p:to>
+                                        <p:strVal val="visible"/>
+                                      </p:to>
+                                    </p:set>
+                                  </p:childTnLst>
+                                </p:cTn>
+                              </p:par>
+                              <p:par>
+                                <p:cTn id="13" presetID="1" presetClass="entr" presetSubtype="0" fill="hold" nodeType="withEffect">
+                                  <p:stCondLst>
+                                    <p:cond delay="0"/>
+                                  </p:stCondLst>
+                                  <p:childTnLst>
+                                    <p:set>
+                                      <p:cBhvr>
+                                        <p:cTn id="14" dur="1" fill="hold">
+                                          <p:stCondLst>
+                                            <p:cond delay="0"/>
+                                          </p:stCondLst>
+                                        </p:cTn>
+                                        <p:tgtEl>
+                                          <p:spTgt spid="4">
+                                            <p:txEl>
+                                              <p:pRg st="5" end="5"/>
+                                            </p:txEl>
+                                          </p:spTgt>
+                                        </p:tgtEl>
+                                        <p:attrNameLst>
+                                          <p:attrName>style.visibility</p:attrName>
+                                        </p:attrNameLst>
+                                      </p:cBhvr>
+                                      <p:to>
+                                        <p:strVal val="visible"/>
+                                      </p:to>
+                                    </p:set>
+                                  </p:childTnLst>
+                                </p:cTn>
+                              </p:par>
+                            </p:childTnLst>
+                          </p:cTn>
+                        </p:par>
+                      </p:childTnLst>
+                    </p:cTn>
+                  </p:par>
+                </p:childTnLst>
+              </p:cTn>
+              <p:prevCondLst>
+                <p:cond evt="onPrev" delay="0">
+                  <p:tgtEl>
+                    <p:sldTgt/>
+                  </p:tgtEl>
+                </p:cond>
+              </p:prevCondLst>
+              <p:nextCondLst>
+                <p:cond evt="onNext" delay="0">
+                  <p:tgtEl>
+                    <p:sldTgt/>
+                  </p:tgtEl>
+                </p:cond>
+              </p:nextCondLst>
+            </p:seq>
+          </p:childTnLst>
+        </p:cTn>
+      </p:par>
+    </p:tnLst>
+  </p:timing>
+</p:sld>
+</file>
+
+<file path=ppt/slides/slide11.xml><?xml version="1.0" encoding="utf-8"?>
 <p:sld xmlns:a="http://schemas.openxmlformats.org/drawingml/2006/main" xmlns:r="http://schemas.openxmlformats.org/officeDocument/2006/relationships" xmlns:p="http://schemas.openxmlformats.org/presentationml/2006/main">
   <p:cSld>
     <p:spTree>
@@ -9491,221 +10046,6 @@
 </p:sld>
 </file>
 
-<file path=ppt/slides/slide11.xml><?xml version="1.0" encoding="utf-8"?>
-<p:sld xmlns:a="http://schemas.openxmlformats.org/drawingml/2006/main" xmlns:r="http://schemas.openxmlformats.org/officeDocument/2006/relationships" xmlns:p="http://schemas.openxmlformats.org/presentationml/2006/main">
-  <p:cSld>
-    <p:spTree>
-      <p:nvGrpSpPr>
-        <p:cNvPr id="1" name=""/>
-        <p:cNvGrpSpPr/>
-        <p:nvPr/>
-      </p:nvGrpSpPr>
-      <p:grpSpPr>
-        <a:xfrm>
-          <a:off x="0" y="0"/>
-          <a:ext cx="0" cy="0"/>
-          <a:chOff x="0" y="0"/>
-          <a:chExt cx="0" cy="0"/>
-        </a:xfrm>
-      </p:grpSpPr>
-      <p:sp>
-        <p:nvSpPr>
-          <p:cNvPr id="2" name="Title 1">
-            <a:extLst>
-              <a:ext uri="{FF2B5EF4-FFF2-40B4-BE49-F238E27FC236}">
-                <a16:creationId xmlns:a16="http://schemas.microsoft.com/office/drawing/2014/main" id="{2F1138F9-32CF-98D5-B3A0-D592C6510B80}"/>
-              </a:ext>
-            </a:extLst>
-          </p:cNvPr>
-          <p:cNvSpPr>
-            <a:spLocks noGrp="1"/>
-          </p:cNvSpPr>
-          <p:nvPr>
-            <p:ph type="title"/>
-          </p:nvPr>
-        </p:nvSpPr>
-        <p:spPr/>
-        <p:txBody>
-          <a:bodyPr/>
-          <a:lstStyle/>
-          <a:p>
-            <a:r>
-              <a:rPr lang="en-US" dirty="0" err="1"/>
-              <a:t>Jupyter</a:t>
-            </a:r>
-            <a:r>
-              <a:rPr lang="en-US" dirty="0"/>
-              <a:t> Notebooks</a:t>
-            </a:r>
-          </a:p>
-        </p:txBody>
-      </p:sp>
-      <p:sp>
-        <p:nvSpPr>
-          <p:cNvPr id="3" name="Content Placeholder 2">
-            <a:extLst>
-              <a:ext uri="{FF2B5EF4-FFF2-40B4-BE49-F238E27FC236}">
-                <a16:creationId xmlns:a16="http://schemas.microsoft.com/office/drawing/2014/main" id="{91D54C1D-6092-56DC-5F3C-1FC851E87E5E}"/>
-              </a:ext>
-            </a:extLst>
-          </p:cNvPr>
-          <p:cNvSpPr>
-            <a:spLocks noGrp="1"/>
-          </p:cNvSpPr>
-          <p:nvPr>
-            <p:ph idx="1"/>
-          </p:nvPr>
-        </p:nvSpPr>
-        <p:spPr>
-          <a:xfrm>
-            <a:off x="680321" y="2336873"/>
-            <a:ext cx="10419801" cy="4318570"/>
-          </a:xfrm>
-        </p:spPr>
-        <p:txBody>
-          <a:bodyPr>
-            <a:normAutofit lnSpcReduction="10000"/>
-          </a:bodyPr>
-          <a:lstStyle/>
-          <a:p>
-            <a:pPr marL="0" indent="0">
-              <a:buNone/>
-            </a:pPr>
-            <a:r>
-              <a:rPr lang="en-US" dirty="0"/>
-              <a:t>How can I apply unit testing with </a:t>
-            </a:r>
-            <a:r>
-              <a:rPr lang="en-US" dirty="0" err="1"/>
-              <a:t>Jupyter</a:t>
-            </a:r>
-            <a:r>
-              <a:rPr lang="en-US" dirty="0"/>
-              <a:t> notebooks?</a:t>
-            </a:r>
-          </a:p>
-          <a:p>
-            <a:pPr marL="0" indent="0">
-              <a:buNone/>
-            </a:pPr>
-            <a:r>
-              <a:rPr lang="en-US" dirty="0"/>
-              <a:t>(See example 02_pytest/examples/</a:t>
-            </a:r>
-            <a:r>
-              <a:rPr lang="en-US" dirty="0" err="1"/>
-              <a:t>notebook.ipynb</a:t>
-            </a:r>
-            <a:r>
-              <a:rPr lang="en-US" dirty="0"/>
-              <a:t>)</a:t>
-            </a:r>
-          </a:p>
-          <a:p>
-            <a:pPr marL="0" indent="0">
-              <a:buNone/>
-            </a:pPr>
-            <a:endParaRPr lang="en-US" dirty="0"/>
-          </a:p>
-          <a:p>
-            <a:pPr marL="0" indent="0">
-              <a:buNone/>
-            </a:pPr>
-            <a:r>
-              <a:rPr lang="en-US" dirty="0"/>
-              <a:t>My Recommendation:</a:t>
-            </a:r>
-          </a:p>
-          <a:p>
-            <a:pPr lvl="1"/>
-            <a:r>
-              <a:rPr lang="en-US" dirty="0"/>
-              <a:t>Create modules in the same directory as .</a:t>
-            </a:r>
-            <a:r>
-              <a:rPr lang="en-US" dirty="0" err="1"/>
-              <a:t>ipynb</a:t>
-            </a:r>
-            <a:r>
-              <a:rPr lang="en-US" dirty="0"/>
-              <a:t> with helpful functions.</a:t>
-            </a:r>
-          </a:p>
-          <a:p>
-            <a:pPr lvl="1"/>
-            <a:r>
-              <a:rPr lang="en-US" dirty="0"/>
-              <a:t>Write unit tests for the helpful functions</a:t>
-            </a:r>
-          </a:p>
-          <a:p>
-            <a:pPr lvl="1"/>
-            <a:r>
-              <a:rPr lang="en-US" dirty="0"/>
-              <a:t>Use the helpful function in your notebook to:</a:t>
-            </a:r>
-          </a:p>
-          <a:p>
-            <a:pPr lvl="2"/>
-            <a:r>
-              <a:rPr lang="en-US" dirty="0"/>
-              <a:t>Simplify your notebook code.</a:t>
-            </a:r>
-          </a:p>
-          <a:p>
-            <a:pPr lvl="2"/>
-            <a:r>
-              <a:rPr lang="en-US" dirty="0"/>
-              <a:t>Reduce debugging time by using tested shared functions.</a:t>
-            </a:r>
-          </a:p>
-          <a:p>
-            <a:pPr lvl="2"/>
-            <a:r>
-              <a:rPr lang="en-US" dirty="0"/>
-              <a:t>Applies principal of software module architecture</a:t>
-            </a:r>
-          </a:p>
-          <a:p>
-            <a:pPr marL="1371600" lvl="3" indent="0">
-              <a:buNone/>
-            </a:pPr>
-            <a:r>
-              <a:rPr lang="en-US" dirty="0">
-                <a:hlinkClick r:id="rId2"/>
-              </a:rPr>
-              <a:t>https://appmaster.io/blog/why-use-a-modular-architecture-in-software-design</a:t>
-            </a:r>
-            <a:endParaRPr lang="en-US" dirty="0"/>
-          </a:p>
-          <a:p>
-            <a:pPr lvl="1"/>
-            <a:r>
-              <a:rPr lang="en-US" dirty="0"/>
-              <a:t>Still retain advantages of fast prototyping and experimentation of Notebooks.</a:t>
-            </a:r>
-          </a:p>
-          <a:p>
-            <a:pPr marL="1371600" lvl="3" indent="0">
-              <a:buNone/>
-            </a:pPr>
-            <a:endParaRPr lang="en-US" dirty="0"/>
-          </a:p>
-        </p:txBody>
-      </p:sp>
-    </p:spTree>
-    <p:extLst>
-      <p:ext uri="{BB962C8B-B14F-4D97-AF65-F5344CB8AC3E}">
-        <p14:creationId xmlns:p14="http://schemas.microsoft.com/office/powerpoint/2010/main" val="819061628"/>
-      </p:ext>
-    </p:extLst>
-  </p:cSld>
-  <p:clrMapOvr>
-    <a:masterClrMapping/>
-  </p:clrMapOvr>
-</p:sld>
-</file>
-
 <file path=ppt/slides/slide12.xml><?xml version="1.0" encoding="utf-8"?>
 <p:sld xmlns:a="http://schemas.openxmlformats.org/drawingml/2006/main" xmlns:r="http://schemas.openxmlformats.org/officeDocument/2006/relationships" xmlns:p="http://schemas.openxmlformats.org/presentationml/2006/main">
   <p:cSld>
@@ -9728,6 +10068,221 @@
           <p:cNvPr id="2" name="Title 1">
             <a:extLst>
               <a:ext uri="{FF2B5EF4-FFF2-40B4-BE49-F238E27FC236}">
+                <a16:creationId xmlns:a16="http://schemas.microsoft.com/office/drawing/2014/main" id="{2F1138F9-32CF-98D5-B3A0-D592C6510B80}"/>
+              </a:ext>
+            </a:extLst>
+          </p:cNvPr>
+          <p:cNvSpPr>
+            <a:spLocks noGrp="1"/>
+          </p:cNvSpPr>
+          <p:nvPr>
+            <p:ph type="title"/>
+          </p:nvPr>
+        </p:nvSpPr>
+        <p:spPr/>
+        <p:txBody>
+          <a:bodyPr/>
+          <a:lstStyle/>
+          <a:p>
+            <a:r>
+              <a:rPr lang="en-US" dirty="0" err="1"/>
+              <a:t>Jupyter</a:t>
+            </a:r>
+            <a:r>
+              <a:rPr lang="en-US" dirty="0"/>
+              <a:t> Notebooks</a:t>
+            </a:r>
+          </a:p>
+        </p:txBody>
+      </p:sp>
+      <p:sp>
+        <p:nvSpPr>
+          <p:cNvPr id="3" name="Content Placeholder 2">
+            <a:extLst>
+              <a:ext uri="{FF2B5EF4-FFF2-40B4-BE49-F238E27FC236}">
+                <a16:creationId xmlns:a16="http://schemas.microsoft.com/office/drawing/2014/main" id="{91D54C1D-6092-56DC-5F3C-1FC851E87E5E}"/>
+              </a:ext>
+            </a:extLst>
+          </p:cNvPr>
+          <p:cNvSpPr>
+            <a:spLocks noGrp="1"/>
+          </p:cNvSpPr>
+          <p:nvPr>
+            <p:ph idx="1"/>
+          </p:nvPr>
+        </p:nvSpPr>
+        <p:spPr>
+          <a:xfrm>
+            <a:off x="680321" y="2336873"/>
+            <a:ext cx="10419801" cy="4318570"/>
+          </a:xfrm>
+        </p:spPr>
+        <p:txBody>
+          <a:bodyPr>
+            <a:normAutofit lnSpcReduction="10000"/>
+          </a:bodyPr>
+          <a:lstStyle/>
+          <a:p>
+            <a:pPr marL="0" indent="0">
+              <a:buNone/>
+            </a:pPr>
+            <a:r>
+              <a:rPr lang="en-US" dirty="0"/>
+              <a:t>How can I apply unit testing with </a:t>
+            </a:r>
+            <a:r>
+              <a:rPr lang="en-US" dirty="0" err="1"/>
+              <a:t>Jupyter</a:t>
+            </a:r>
+            <a:r>
+              <a:rPr lang="en-US" dirty="0"/>
+              <a:t> notebooks?</a:t>
+            </a:r>
+          </a:p>
+          <a:p>
+            <a:pPr marL="0" indent="0">
+              <a:buNone/>
+            </a:pPr>
+            <a:r>
+              <a:rPr lang="en-US" dirty="0"/>
+              <a:t>(See example 02_pytest/examples/</a:t>
+            </a:r>
+            <a:r>
+              <a:rPr lang="en-US" dirty="0" err="1"/>
+              <a:t>notebook.ipynb</a:t>
+            </a:r>
+            <a:r>
+              <a:rPr lang="en-US" dirty="0"/>
+              <a:t>)</a:t>
+            </a:r>
+          </a:p>
+          <a:p>
+            <a:pPr marL="0" indent="0">
+              <a:buNone/>
+            </a:pPr>
+            <a:endParaRPr lang="en-US" dirty="0"/>
+          </a:p>
+          <a:p>
+            <a:pPr marL="0" indent="0">
+              <a:buNone/>
+            </a:pPr>
+            <a:r>
+              <a:rPr lang="en-US" dirty="0"/>
+              <a:t>My Recommendation:</a:t>
+            </a:r>
+          </a:p>
+          <a:p>
+            <a:pPr lvl="1"/>
+            <a:r>
+              <a:rPr lang="en-US" dirty="0"/>
+              <a:t>Create modules in the same directory as .</a:t>
+            </a:r>
+            <a:r>
+              <a:rPr lang="en-US" dirty="0" err="1"/>
+              <a:t>ipynb</a:t>
+            </a:r>
+            <a:r>
+              <a:rPr lang="en-US" dirty="0"/>
+              <a:t> with helpful functions.</a:t>
+            </a:r>
+          </a:p>
+          <a:p>
+            <a:pPr lvl="1"/>
+            <a:r>
+              <a:rPr lang="en-US" dirty="0"/>
+              <a:t>Write unit tests for the helpful functions</a:t>
+            </a:r>
+          </a:p>
+          <a:p>
+            <a:pPr lvl="1"/>
+            <a:r>
+              <a:rPr lang="en-US" dirty="0"/>
+              <a:t>Use the helpful function in your notebook to:</a:t>
+            </a:r>
+          </a:p>
+          <a:p>
+            <a:pPr lvl="2"/>
+            <a:r>
+              <a:rPr lang="en-US" dirty="0"/>
+              <a:t>Simplify your notebook code.</a:t>
+            </a:r>
+          </a:p>
+          <a:p>
+            <a:pPr lvl="2"/>
+            <a:r>
+              <a:rPr lang="en-US" dirty="0"/>
+              <a:t>Reduce debugging time by using tested shared functions.</a:t>
+            </a:r>
+          </a:p>
+          <a:p>
+            <a:pPr lvl="2"/>
+            <a:r>
+              <a:rPr lang="en-US" dirty="0"/>
+              <a:t>Applies principal of software module architecture</a:t>
+            </a:r>
+          </a:p>
+          <a:p>
+            <a:pPr marL="1371600" lvl="3" indent="0">
+              <a:buNone/>
+            </a:pPr>
+            <a:r>
+              <a:rPr lang="en-US" dirty="0">
+                <a:hlinkClick r:id="rId2"/>
+              </a:rPr>
+              <a:t>https://appmaster.io/blog/why-use-a-modular-architecture-in-software-design</a:t>
+            </a:r>
+            <a:endParaRPr lang="en-US" dirty="0"/>
+          </a:p>
+          <a:p>
+            <a:pPr lvl="1"/>
+            <a:r>
+              <a:rPr lang="en-US" dirty="0"/>
+              <a:t>Still retain advantages of fast prototyping and experimentation of Notebooks.</a:t>
+            </a:r>
+          </a:p>
+          <a:p>
+            <a:pPr marL="1371600" lvl="3" indent="0">
+              <a:buNone/>
+            </a:pPr>
+            <a:endParaRPr lang="en-US" dirty="0"/>
+          </a:p>
+        </p:txBody>
+      </p:sp>
+    </p:spTree>
+    <p:extLst>
+      <p:ext uri="{BB962C8B-B14F-4D97-AF65-F5344CB8AC3E}">
+        <p14:creationId xmlns:p14="http://schemas.microsoft.com/office/powerpoint/2010/main" val="819061628"/>
+      </p:ext>
+    </p:extLst>
+  </p:cSld>
+  <p:clrMapOvr>
+    <a:masterClrMapping/>
+  </p:clrMapOvr>
+</p:sld>
+</file>
+
+<file path=ppt/slides/slide13.xml><?xml version="1.0" encoding="utf-8"?>
+<p:sld xmlns:a="http://schemas.openxmlformats.org/drawingml/2006/main" xmlns:r="http://schemas.openxmlformats.org/officeDocument/2006/relationships" xmlns:p="http://schemas.openxmlformats.org/presentationml/2006/main">
+  <p:cSld>
+    <p:spTree>
+      <p:nvGrpSpPr>
+        <p:cNvPr id="1" name=""/>
+        <p:cNvGrpSpPr/>
+        <p:nvPr/>
+      </p:nvGrpSpPr>
+      <p:grpSpPr>
+        <a:xfrm>
+          <a:off x="0" y="0"/>
+          <a:ext cx="0" cy="0"/>
+          <a:chOff x="0" y="0"/>
+          <a:chExt cx="0" cy="0"/>
+        </a:xfrm>
+      </p:grpSpPr>
+      <p:sp>
+        <p:nvSpPr>
+          <p:cNvPr id="2" name="Title 1">
+            <a:extLst>
+              <a:ext uri="{FF2B5EF4-FFF2-40B4-BE49-F238E27FC236}">
                 <a16:creationId xmlns:a16="http://schemas.microsoft.com/office/drawing/2014/main" id="{73616EDE-C681-FF0F-08B5-A0FCB45FC85D}"/>
               </a:ext>
             </a:extLst>
@@ -9932,7 +10487,7 @@
 </p:sld>
 </file>
 
-<file path=ppt/slides/slide13.xml><?xml version="1.0" encoding="utf-8"?>
+<file path=ppt/slides/slide14.xml><?xml version="1.0" encoding="utf-8"?>
 <p:sld xmlns:a="http://schemas.openxmlformats.org/drawingml/2006/main" xmlns:r="http://schemas.openxmlformats.org/officeDocument/2006/relationships" xmlns:p="http://schemas.openxmlformats.org/presentationml/2006/main">
   <p:cSld>
     <p:spTree>
@@ -10682,7 +11237,7 @@
 </p:sld>
 </file>
 
-<file path=ppt/slides/slide14.xml><?xml version="1.0" encoding="utf-8"?>
+<file path=ppt/slides/slide15.xml><?xml version="1.0" encoding="utf-8"?>
 <p:sld xmlns:a="http://schemas.openxmlformats.org/drawingml/2006/main" xmlns:r="http://schemas.openxmlformats.org/officeDocument/2006/relationships" xmlns:p="http://schemas.openxmlformats.org/presentationml/2006/main">
   <p:cSld>
     <p:spTree>
@@ -10912,7 +11467,7 @@
 </p:sld>
 </file>
 
-<file path=ppt/slides/slide15.xml><?xml version="1.0" encoding="utf-8"?>
+<file path=ppt/slides/slide16.xml><?xml version="1.0" encoding="utf-8"?>
 <p:sld xmlns:a="http://schemas.openxmlformats.org/drawingml/2006/main" xmlns:r="http://schemas.openxmlformats.org/officeDocument/2006/relationships" xmlns:p="http://schemas.openxmlformats.org/presentationml/2006/main">
   <p:cSld>
     <p:spTree>
@@ -11162,8 +11717,12 @@
               <a:buNone/>
             </a:pPr>
             <a:r>
-              <a:rPr lang="en-US" dirty="0"/>
-              <a:t>Mocking can intercept application code for unit testing purposes.</a:t>
+              <a:rPr lang="en-US" dirty="0" err="1"/>
+              <a:t>Pytest</a:t>
+            </a:r>
+            <a:r>
+              <a:rPr lang="en-US" dirty="0"/>
+              <a:t> Mocking can intercept application code for unit testing purposes.</a:t>
             </a:r>
           </a:p>
           <a:p>
@@ -11715,7 +12274,7 @@
 </p:sld>
 </file>
 
-<file path=ppt/slides/slide16.xml><?xml version="1.0" encoding="utf-8"?>
+<file path=ppt/slides/slide17.xml><?xml version="1.0" encoding="utf-8"?>
 <p:sld xmlns:a="http://schemas.openxmlformats.org/drawingml/2006/main" xmlns:r="http://schemas.openxmlformats.org/officeDocument/2006/relationships" xmlns:p="http://schemas.openxmlformats.org/presentationml/2006/main">
   <p:cSld>
     <p:spTree>
@@ -12150,7 +12709,7 @@
 </p:sld>
 </file>
 
-<file path=ppt/slides/slide17.xml><?xml version="1.0" encoding="utf-8"?>
+<file path=ppt/slides/slide18.xml><?xml version="1.0" encoding="utf-8"?>
 <p:sld xmlns:a="http://schemas.openxmlformats.org/drawingml/2006/main" xmlns:r="http://schemas.openxmlformats.org/officeDocument/2006/relationships" xmlns:p="http://schemas.openxmlformats.org/presentationml/2006/main">
   <p:cSld>
     <p:spTree>
@@ -12645,7 +13204,7 @@
 </p:sld>
 </file>
 
-<file path=ppt/slides/slide18.xml><?xml version="1.0" encoding="utf-8"?>
+<file path=ppt/slides/slide19.xml><?xml version="1.0" encoding="utf-8"?>
 <p:sld xmlns:a="http://schemas.openxmlformats.org/drawingml/2006/main" xmlns:r="http://schemas.openxmlformats.org/officeDocument/2006/relationships" xmlns:p="http://schemas.openxmlformats.org/presentationml/2006/main">
   <p:cSld>
     <p:spTree>
@@ -12939,7 +13498,253 @@
 </p:sld>
 </file>
 
-<file path=ppt/slides/slide19.xml><?xml version="1.0" encoding="utf-8"?>
+<file path=ppt/slides/slide2.xml><?xml version="1.0" encoding="utf-8"?>
+<p:sld xmlns:a="http://schemas.openxmlformats.org/drawingml/2006/main" xmlns:r="http://schemas.openxmlformats.org/officeDocument/2006/relationships" xmlns:p="http://schemas.openxmlformats.org/presentationml/2006/main">
+  <p:cSld>
+    <p:spTree>
+      <p:nvGrpSpPr>
+        <p:cNvPr id="1" name=""/>
+        <p:cNvGrpSpPr/>
+        <p:nvPr/>
+      </p:nvGrpSpPr>
+      <p:grpSpPr>
+        <a:xfrm>
+          <a:off x="0" y="0"/>
+          <a:ext cx="0" cy="0"/>
+          <a:chOff x="0" y="0"/>
+          <a:chExt cx="0" cy="0"/>
+        </a:xfrm>
+      </p:grpSpPr>
+      <p:sp>
+        <p:nvSpPr>
+          <p:cNvPr id="2" name="Title 1">
+            <a:extLst>
+              <a:ext uri="{FF2B5EF4-FFF2-40B4-BE49-F238E27FC236}">
+                <a16:creationId xmlns:a16="http://schemas.microsoft.com/office/drawing/2014/main" id="{4E02D287-EA3E-BB81-91C5-7A627B55F92D}"/>
+              </a:ext>
+            </a:extLst>
+          </p:cNvPr>
+          <p:cNvSpPr>
+            <a:spLocks noGrp="1"/>
+          </p:cNvSpPr>
+          <p:nvPr>
+            <p:ph type="title"/>
+          </p:nvPr>
+        </p:nvSpPr>
+        <p:spPr/>
+        <p:txBody>
+          <a:bodyPr/>
+          <a:lstStyle/>
+          <a:p>
+            <a:r>
+              <a:rPr lang="en-US" dirty="0"/>
+              <a:t>Clone GIT Repository For Slides and Examples</a:t>
+            </a:r>
+          </a:p>
+        </p:txBody>
+      </p:sp>
+      <p:sp>
+        <p:nvSpPr>
+          <p:cNvPr id="3" name="Content Placeholder 2">
+            <a:extLst>
+              <a:ext uri="{FF2B5EF4-FFF2-40B4-BE49-F238E27FC236}">
+                <a16:creationId xmlns:a16="http://schemas.microsoft.com/office/drawing/2014/main" id="{AC81859C-49C0-2DD5-94A0-05955D10B73C}"/>
+              </a:ext>
+            </a:extLst>
+          </p:cNvPr>
+          <p:cNvSpPr>
+            <a:spLocks noGrp="1"/>
+          </p:cNvSpPr>
+          <p:nvPr>
+            <p:ph idx="1"/>
+          </p:nvPr>
+        </p:nvSpPr>
+        <p:spPr>
+          <a:xfrm>
+            <a:off x="235527" y="2092036"/>
+            <a:ext cx="11734800" cy="4765963"/>
+          </a:xfrm>
+        </p:spPr>
+        <p:txBody>
+          <a:bodyPr>
+            <a:normAutofit/>
+          </a:bodyPr>
+          <a:lstStyle/>
+          <a:p>
+            <a:pPr marL="0" indent="0">
+              <a:buNone/>
+            </a:pPr>
+            <a:r>
+              <a:rPr lang="en-US" dirty="0"/>
+              <a:t>Clone Public Repo</a:t>
+            </a:r>
+          </a:p>
+          <a:p>
+            <a:pPr marL="0" indent="0">
+              <a:buNone/>
+            </a:pPr>
+            <a:r>
+              <a:rPr lang="en-US" dirty="0"/>
+              <a:t>  git clone </a:t>
+            </a:r>
+            <a:r>
+              <a:rPr lang="en-US" dirty="0">
+                <a:hlinkClick r:id="rId2">
+                  <a:extLst>
+                    <a:ext uri="{A12FA001-AC4F-418D-AE19-62706E023703}">
+                      <ahyp:hlinkClr xmlns:ahyp="http://schemas.microsoft.com/office/drawing/2018/hyperlinkcolor" val="tx"/>
+                    </a:ext>
+                  </a:extLst>
+                </a:hlinkClick>
+              </a:rPr>
+              <a:t>https://github.com/PrincetonUniversity/software_testing.git</a:t>
+            </a:r>
+            <a:endParaRPr lang="en-US" dirty="0"/>
+          </a:p>
+          <a:p>
+            <a:pPr marL="0" indent="0">
+              <a:buNone/>
+            </a:pPr>
+            <a:endParaRPr lang="en-US" dirty="0"/>
+          </a:p>
+          <a:p>
+            <a:pPr marL="0" indent="0">
+              <a:buNone/>
+            </a:pPr>
+            <a:r>
+              <a:rPr lang="en-US" sz="2800" dirty="0"/>
+              <a:t>Slides in Repo Root Folder:  </a:t>
+            </a:r>
+            <a:r>
+              <a:rPr lang="en-US" sz="2800" dirty="0" err="1"/>
+              <a:t>UnitTestingSlides.pptx</a:t>
+            </a:r>
+            <a:endParaRPr lang="en-US" sz="2800" dirty="0"/>
+          </a:p>
+          <a:p>
+            <a:pPr marL="0" indent="0">
+              <a:buNone/>
+            </a:pPr>
+            <a:br>
+              <a:rPr lang="en-US" dirty="0"/>
+            </a:br>
+            <a:r>
+              <a:rPr lang="en-US" dirty="0"/>
+              <a:t>On Adroit execute:</a:t>
+            </a:r>
+          </a:p>
+          <a:p>
+            <a:pPr marL="0" indent="0">
+              <a:buNone/>
+            </a:pPr>
+            <a:r>
+              <a:rPr lang="en-US" dirty="0"/>
+              <a:t>	</a:t>
+            </a:r>
+            <a:r>
+              <a:rPr lang="en-US" b="0" dirty="0">
+                <a:effectLst/>
+                <a:latin typeface="Menlo" panose="020B0609030804020204" pitchFamily="49" charset="0"/>
+              </a:rPr>
+              <a:t>source /scratch/network/wh3248/</a:t>
+            </a:r>
+            <a:r>
+              <a:rPr lang="en-US" b="0" dirty="0" err="1">
+                <a:effectLst/>
+                <a:latin typeface="Menlo" panose="020B0609030804020204" pitchFamily="49" charset="0"/>
+              </a:rPr>
+              <a:t>shared_venv</a:t>
+            </a:r>
+            <a:r>
+              <a:rPr lang="en-US" b="0" dirty="0">
+                <a:effectLst/>
+                <a:latin typeface="Menlo" panose="020B0609030804020204" pitchFamily="49" charset="0"/>
+              </a:rPr>
+              <a:t>/bin/activate</a:t>
+            </a:r>
+          </a:p>
+          <a:p>
+            <a:pPr marL="0" indent="0">
+              <a:buNone/>
+            </a:pPr>
+            <a:r>
+              <a:rPr lang="en-US" b="0" dirty="0">
+                <a:effectLst/>
+                <a:latin typeface="Menlo" panose="020B0609030804020204" pitchFamily="49" charset="0"/>
+              </a:rPr>
+              <a:t>On laptop:</a:t>
+            </a:r>
+          </a:p>
+          <a:p>
+            <a:pPr marL="0" indent="0">
+              <a:buNone/>
+            </a:pPr>
+            <a:r>
+              <a:rPr lang="en-US" dirty="0">
+                <a:latin typeface="Menlo" panose="020B0609030804020204" pitchFamily="49" charset="0"/>
+              </a:rPr>
+              <a:t>	pip install </a:t>
+            </a:r>
+            <a:r>
+              <a:rPr lang="en-US" dirty="0" err="1">
+                <a:latin typeface="Menlo" panose="020B0609030804020204" pitchFamily="49" charset="0"/>
+              </a:rPr>
+              <a:t>pytest</a:t>
+            </a:r>
+            <a:r>
+              <a:rPr lang="en-US" dirty="0">
+                <a:latin typeface="Menlo" panose="020B0609030804020204" pitchFamily="49" charset="0"/>
+              </a:rPr>
+              <a:t> </a:t>
+            </a:r>
+            <a:r>
+              <a:rPr lang="en-US" dirty="0" err="1">
+                <a:latin typeface="Menlo" panose="020B0609030804020204" pitchFamily="49" charset="0"/>
+              </a:rPr>
+              <a:t>pytest</a:t>
+            </a:r>
+            <a:r>
+              <a:rPr lang="en-US" dirty="0">
+                <a:latin typeface="Menlo" panose="020B0609030804020204" pitchFamily="49" charset="0"/>
+              </a:rPr>
+              <a:t>-mock flask requests</a:t>
+            </a:r>
+            <a:endParaRPr lang="en-US" b="0" dirty="0">
+              <a:effectLst/>
+              <a:latin typeface="Menlo" panose="020B0609030804020204" pitchFamily="49" charset="0"/>
+            </a:endParaRPr>
+          </a:p>
+          <a:p>
+            <a:pPr marL="0" indent="0">
+              <a:buNone/>
+            </a:pPr>
+            <a:endParaRPr lang="en-US" b="0" dirty="0">
+              <a:effectLst/>
+              <a:latin typeface="Menlo" panose="020B0609030804020204" pitchFamily="49" charset="0"/>
+            </a:endParaRPr>
+          </a:p>
+          <a:p>
+            <a:pPr marL="0" indent="0">
+              <a:buNone/>
+            </a:pPr>
+            <a:endParaRPr lang="en-US" dirty="0"/>
+          </a:p>
+        </p:txBody>
+      </p:sp>
+    </p:spTree>
+    <p:extLst>
+      <p:ext uri="{BB962C8B-B14F-4D97-AF65-F5344CB8AC3E}">
+        <p14:creationId xmlns:p14="http://schemas.microsoft.com/office/powerpoint/2010/main" val="2275561635"/>
+      </p:ext>
+    </p:extLst>
+  </p:cSld>
+  <p:clrMapOvr>
+    <a:masterClrMapping/>
+  </p:clrMapOvr>
+</p:sld>
+</file>
+
+<file path=ppt/slides/slide20.xml><?xml version="1.0" encoding="utf-8"?>
 <p:sld xmlns:a="http://schemas.openxmlformats.org/drawingml/2006/main" xmlns:r="http://schemas.openxmlformats.org/officeDocument/2006/relationships" xmlns:p="http://schemas.openxmlformats.org/presentationml/2006/main">
   <p:cSld>
     <p:spTree>
@@ -13509,457 +14314,6 @@
 </p:sld>
 </file>
 
-<file path=ppt/slides/slide2.xml><?xml version="1.0" encoding="utf-8"?>
-<p:sld xmlns:a="http://schemas.openxmlformats.org/drawingml/2006/main" xmlns:r="http://schemas.openxmlformats.org/officeDocument/2006/relationships" xmlns:p="http://schemas.openxmlformats.org/presentationml/2006/main">
-  <p:cSld>
-    <p:spTree>
-      <p:nvGrpSpPr>
-        <p:cNvPr id="1" name=""/>
-        <p:cNvGrpSpPr/>
-        <p:nvPr/>
-      </p:nvGrpSpPr>
-      <p:grpSpPr>
-        <a:xfrm>
-          <a:off x="0" y="0"/>
-          <a:ext cx="0" cy="0"/>
-          <a:chOff x="0" y="0"/>
-          <a:chExt cx="0" cy="0"/>
-        </a:xfrm>
-      </p:grpSpPr>
-      <p:sp>
-        <p:nvSpPr>
-          <p:cNvPr id="2" name="Title 1">
-            <a:extLst>
-              <a:ext uri="{FF2B5EF4-FFF2-40B4-BE49-F238E27FC236}">
-                <a16:creationId xmlns:a16="http://schemas.microsoft.com/office/drawing/2014/main" id="{4E02D287-EA3E-BB81-91C5-7A627B55F92D}"/>
-              </a:ext>
-            </a:extLst>
-          </p:cNvPr>
-          <p:cNvSpPr>
-            <a:spLocks noGrp="1"/>
-          </p:cNvSpPr>
-          <p:nvPr>
-            <p:ph type="title"/>
-          </p:nvPr>
-        </p:nvSpPr>
-        <p:spPr/>
-        <p:txBody>
-          <a:bodyPr/>
-          <a:lstStyle/>
-          <a:p>
-            <a:r>
-              <a:rPr lang="en-US" dirty="0"/>
-              <a:t>Clone GIT Repository For Slides and Examples</a:t>
-            </a:r>
-          </a:p>
-        </p:txBody>
-      </p:sp>
-      <p:sp>
-        <p:nvSpPr>
-          <p:cNvPr id="3" name="Content Placeholder 2">
-            <a:extLst>
-              <a:ext uri="{FF2B5EF4-FFF2-40B4-BE49-F238E27FC236}">
-                <a16:creationId xmlns:a16="http://schemas.microsoft.com/office/drawing/2014/main" id="{AC81859C-49C0-2DD5-94A0-05955D10B73C}"/>
-              </a:ext>
-            </a:extLst>
-          </p:cNvPr>
-          <p:cNvSpPr>
-            <a:spLocks noGrp="1"/>
-          </p:cNvSpPr>
-          <p:nvPr>
-            <p:ph idx="1"/>
-          </p:nvPr>
-        </p:nvSpPr>
-        <p:spPr>
-          <a:xfrm>
-            <a:off x="235527" y="2092036"/>
-            <a:ext cx="11734800" cy="4765963"/>
-          </a:xfrm>
-        </p:spPr>
-        <p:txBody>
-          <a:bodyPr>
-            <a:normAutofit/>
-          </a:bodyPr>
-          <a:lstStyle/>
-          <a:p>
-            <a:pPr marL="0" indent="0">
-              <a:buNone/>
-            </a:pPr>
-            <a:r>
-              <a:rPr lang="en-US" dirty="0"/>
-              <a:t>Clone Public Repo</a:t>
-            </a:r>
-          </a:p>
-          <a:p>
-            <a:pPr marL="0" indent="0">
-              <a:buNone/>
-            </a:pPr>
-            <a:r>
-              <a:rPr lang="en-US" dirty="0"/>
-              <a:t>  git clone </a:t>
-            </a:r>
-            <a:r>
-              <a:rPr lang="en-US" dirty="0">
-                <a:hlinkClick r:id="rId2">
-                  <a:extLst>
-                    <a:ext uri="{A12FA001-AC4F-418D-AE19-62706E023703}">
-                      <ahyp:hlinkClr xmlns:ahyp="http://schemas.microsoft.com/office/drawing/2018/hyperlinkcolor" val="tx"/>
-                    </a:ext>
-                  </a:extLst>
-                </a:hlinkClick>
-              </a:rPr>
-              <a:t>https://github.com/PrincetonUniversity/software_testing.git</a:t>
-            </a:r>
-            <a:endParaRPr lang="en-US" dirty="0"/>
-          </a:p>
-          <a:p>
-            <a:pPr marL="0" indent="0">
-              <a:buNone/>
-            </a:pPr>
-            <a:endParaRPr lang="en-US" dirty="0"/>
-          </a:p>
-          <a:p>
-            <a:pPr marL="0" indent="0">
-              <a:buNone/>
-            </a:pPr>
-            <a:r>
-              <a:rPr lang="en-US" sz="2800" dirty="0"/>
-              <a:t>Slides in Repo Root Folder:  </a:t>
-            </a:r>
-            <a:r>
-              <a:rPr lang="en-US" sz="2800" dirty="0" err="1"/>
-              <a:t>UnitTestingSlides.pptx</a:t>
-            </a:r>
-            <a:endParaRPr lang="en-US" sz="2800" dirty="0"/>
-          </a:p>
-          <a:p>
-            <a:pPr marL="0" indent="0">
-              <a:buNone/>
-            </a:pPr>
-            <a:br>
-              <a:rPr lang="en-US" dirty="0"/>
-            </a:br>
-            <a:r>
-              <a:rPr lang="en-US" dirty="0"/>
-              <a:t>On Adroit execute:</a:t>
-            </a:r>
-          </a:p>
-          <a:p>
-            <a:pPr marL="0" indent="0">
-              <a:buNone/>
-            </a:pPr>
-            <a:r>
-              <a:rPr lang="en-US" dirty="0"/>
-              <a:t>	</a:t>
-            </a:r>
-            <a:r>
-              <a:rPr lang="en-US" b="0" dirty="0">
-                <a:effectLst/>
-                <a:latin typeface="Menlo" panose="020B0609030804020204" pitchFamily="49" charset="0"/>
-              </a:rPr>
-              <a:t>source /scratch/environments/</a:t>
-            </a:r>
-            <a:r>
-              <a:rPr lang="en-US" b="0" dirty="0" err="1">
-                <a:effectLst/>
-                <a:latin typeface="Menlo" panose="020B0609030804020204" pitchFamily="49" charset="0"/>
-              </a:rPr>
-              <a:t>shared_venv</a:t>
-            </a:r>
-            <a:r>
-              <a:rPr lang="en-US" b="0" dirty="0">
-                <a:effectLst/>
-                <a:latin typeface="Menlo" panose="020B0609030804020204" pitchFamily="49" charset="0"/>
-              </a:rPr>
-              <a:t>/bin/activate</a:t>
-            </a:r>
-          </a:p>
-          <a:p>
-            <a:pPr marL="0" indent="0">
-              <a:buNone/>
-            </a:pPr>
-            <a:r>
-              <a:rPr lang="en-US" b="0" dirty="0">
-                <a:effectLst/>
-                <a:latin typeface="Menlo" panose="020B0609030804020204" pitchFamily="49" charset="0"/>
-              </a:rPr>
-              <a:t>On laptop:</a:t>
-            </a:r>
-          </a:p>
-          <a:p>
-            <a:pPr marL="0" indent="0">
-              <a:buNone/>
-            </a:pPr>
-            <a:r>
-              <a:rPr lang="en-US" dirty="0">
-                <a:latin typeface="Menlo" panose="020B0609030804020204" pitchFamily="49" charset="0"/>
-              </a:rPr>
-              <a:t>	pip install </a:t>
-            </a:r>
-            <a:r>
-              <a:rPr lang="en-US" dirty="0" err="1">
-                <a:latin typeface="Menlo" panose="020B0609030804020204" pitchFamily="49" charset="0"/>
-              </a:rPr>
-              <a:t>pytest</a:t>
-            </a:r>
-            <a:r>
-              <a:rPr lang="en-US" dirty="0">
-                <a:latin typeface="Menlo" panose="020B0609030804020204" pitchFamily="49" charset="0"/>
-              </a:rPr>
-              <a:t> </a:t>
-            </a:r>
-            <a:r>
-              <a:rPr lang="en-US" dirty="0" err="1">
-                <a:latin typeface="Menlo" panose="020B0609030804020204" pitchFamily="49" charset="0"/>
-              </a:rPr>
-              <a:t>pytest</a:t>
-            </a:r>
-            <a:r>
-              <a:rPr lang="en-US" dirty="0">
-                <a:latin typeface="Menlo" panose="020B0609030804020204" pitchFamily="49" charset="0"/>
-              </a:rPr>
-              <a:t>-mock flask requests</a:t>
-            </a:r>
-            <a:endParaRPr lang="en-US" b="0" dirty="0">
-              <a:effectLst/>
-              <a:latin typeface="Menlo" panose="020B0609030804020204" pitchFamily="49" charset="0"/>
-            </a:endParaRPr>
-          </a:p>
-          <a:p>
-            <a:pPr marL="0" indent="0">
-              <a:buNone/>
-            </a:pPr>
-            <a:endParaRPr lang="en-US" b="0" dirty="0">
-              <a:effectLst/>
-              <a:latin typeface="Menlo" panose="020B0609030804020204" pitchFamily="49" charset="0"/>
-            </a:endParaRPr>
-          </a:p>
-          <a:p>
-            <a:pPr marL="0" indent="0">
-              <a:buNone/>
-            </a:pPr>
-            <a:endParaRPr lang="en-US" dirty="0"/>
-          </a:p>
-        </p:txBody>
-      </p:sp>
-    </p:spTree>
-    <p:extLst>
-      <p:ext uri="{BB962C8B-B14F-4D97-AF65-F5344CB8AC3E}">
-        <p14:creationId xmlns:p14="http://schemas.microsoft.com/office/powerpoint/2010/main" val="2275561635"/>
-      </p:ext>
-    </p:extLst>
-  </p:cSld>
-  <p:clrMapOvr>
-    <a:masterClrMapping/>
-  </p:clrMapOvr>
-</p:sld>
-</file>
-
-<file path=ppt/slides/slide20.xml><?xml version="1.0" encoding="utf-8"?>
-<p:sld xmlns:a="http://schemas.openxmlformats.org/drawingml/2006/main" xmlns:r="http://schemas.openxmlformats.org/officeDocument/2006/relationships" xmlns:p="http://schemas.openxmlformats.org/presentationml/2006/main">
-  <p:cSld>
-    <p:spTree>
-      <p:nvGrpSpPr>
-        <p:cNvPr id="1" name=""/>
-        <p:cNvGrpSpPr/>
-        <p:nvPr/>
-      </p:nvGrpSpPr>
-      <p:grpSpPr>
-        <a:xfrm>
-          <a:off x="0" y="0"/>
-          <a:ext cx="0" cy="0"/>
-          <a:chOff x="0" y="0"/>
-          <a:chExt cx="0" cy="0"/>
-        </a:xfrm>
-      </p:grpSpPr>
-      <p:sp>
-        <p:nvSpPr>
-          <p:cNvPr id="2" name="Title 1">
-            <a:extLst>
-              <a:ext uri="{FF2B5EF4-FFF2-40B4-BE49-F238E27FC236}">
-                <a16:creationId xmlns:a16="http://schemas.microsoft.com/office/drawing/2014/main" id="{BC9FF478-6F99-D45F-AB47-B407C21C95E4}"/>
-              </a:ext>
-            </a:extLst>
-          </p:cNvPr>
-          <p:cNvSpPr>
-            <a:spLocks noGrp="1"/>
-          </p:cNvSpPr>
-          <p:nvPr>
-            <p:ph type="title"/>
-          </p:nvPr>
-        </p:nvSpPr>
-        <p:spPr/>
-        <p:txBody>
-          <a:bodyPr/>
-          <a:lstStyle/>
-          <a:p>
-            <a:r>
-              <a:rPr lang="en-US" dirty="0"/>
-              <a:t>03 Executing Unit tests</a:t>
-            </a:r>
-          </a:p>
-        </p:txBody>
-      </p:sp>
-      <p:sp>
-        <p:nvSpPr>
-          <p:cNvPr id="3" name="Content Placeholder 2">
-            <a:extLst>
-              <a:ext uri="{FF2B5EF4-FFF2-40B4-BE49-F238E27FC236}">
-                <a16:creationId xmlns:a16="http://schemas.microsoft.com/office/drawing/2014/main" id="{ACA4E9D1-F822-1238-D8B5-01D1A36167DF}"/>
-              </a:ext>
-            </a:extLst>
-          </p:cNvPr>
-          <p:cNvSpPr>
-            <a:spLocks noGrp="1"/>
-          </p:cNvSpPr>
-          <p:nvPr>
-            <p:ph idx="1"/>
-          </p:nvPr>
-        </p:nvSpPr>
-        <p:spPr>
-          <a:xfrm>
-            <a:off x="680321" y="2050472"/>
-            <a:ext cx="9613861" cy="4655127"/>
-          </a:xfrm>
-        </p:spPr>
-        <p:txBody>
-          <a:bodyPr>
-            <a:normAutofit/>
-          </a:bodyPr>
-          <a:lstStyle/>
-          <a:p>
-            <a:pPr marL="0" indent="0">
-              <a:buNone/>
-            </a:pPr>
-            <a:r>
-              <a:rPr lang="en-US" dirty="0"/>
-              <a:t>There are several ways to execute a unit test:</a:t>
-            </a:r>
-          </a:p>
-          <a:p>
-            <a:pPr marL="0" indent="0">
-              <a:buNone/>
-            </a:pPr>
-            <a:r>
-              <a:rPr lang="en-US" dirty="0"/>
-              <a:t>	$ python –m </a:t>
-            </a:r>
-            <a:r>
-              <a:rPr lang="en-US" dirty="0" err="1"/>
-              <a:t>unittest</a:t>
-            </a:r>
-            <a:r>
-              <a:rPr lang="en-US" dirty="0"/>
-              <a:t> </a:t>
-            </a:r>
-            <a:r>
-              <a:rPr lang="en-US" dirty="0" err="1"/>
-              <a:t>test_circle_area.py</a:t>
-            </a:r>
-            <a:endParaRPr lang="en-US" dirty="0"/>
-          </a:p>
-          <a:p>
-            <a:pPr marL="0" indent="0">
-              <a:buNone/>
-            </a:pPr>
-            <a:r>
-              <a:rPr lang="en-US" dirty="0"/>
-              <a:t>	$ python </a:t>
-            </a:r>
-            <a:r>
-              <a:rPr lang="en-US" dirty="0" err="1"/>
-              <a:t>test_circle_area.py</a:t>
-            </a:r>
-            <a:endParaRPr lang="en-US" dirty="0"/>
-          </a:p>
-          <a:p>
-            <a:pPr marL="0" indent="0">
-              <a:buNone/>
-            </a:pPr>
-            <a:r>
-              <a:rPr lang="en-US" dirty="0"/>
-              <a:t>	$ </a:t>
-            </a:r>
-            <a:r>
-              <a:rPr lang="en-US" dirty="0" err="1"/>
-              <a:t>pytest</a:t>
-            </a:r>
-            <a:r>
-              <a:rPr lang="en-US" dirty="0"/>
-              <a:t> </a:t>
-            </a:r>
-            <a:r>
-              <a:rPr lang="en-US" dirty="0" err="1"/>
-              <a:t>test_circle_area.py</a:t>
-            </a:r>
-            <a:endParaRPr lang="en-US" dirty="0"/>
-          </a:p>
-          <a:p>
-            <a:pPr marL="0" indent="0">
-              <a:buNone/>
-            </a:pPr>
-            <a:endParaRPr lang="en-US" dirty="0"/>
-          </a:p>
-          <a:p>
-            <a:pPr marL="0" indent="0">
-              <a:buNone/>
-            </a:pPr>
-            <a:r>
-              <a:rPr lang="en-US" dirty="0"/>
-              <a:t>You can run a test suite with either with –m or with </a:t>
-            </a:r>
-            <a:r>
-              <a:rPr lang="en-US" dirty="0" err="1"/>
-              <a:t>pytest</a:t>
-            </a:r>
-            <a:r>
-              <a:rPr lang="en-US" dirty="0"/>
-              <a:t>:</a:t>
-            </a:r>
-          </a:p>
-          <a:p>
-            <a:pPr marL="0" indent="0">
-              <a:buNone/>
-            </a:pPr>
-            <a:r>
-              <a:rPr lang="en-US" dirty="0"/>
-              <a:t>	$ python –m </a:t>
-            </a:r>
-            <a:r>
-              <a:rPr lang="en-US" dirty="0" err="1"/>
-              <a:t>unittest</a:t>
-            </a:r>
-            <a:endParaRPr lang="en-US" dirty="0"/>
-          </a:p>
-          <a:p>
-            <a:pPr marL="0" indent="0">
-              <a:buNone/>
-            </a:pPr>
-            <a:r>
-              <a:rPr lang="en-US" dirty="0"/>
-              <a:t>	$ </a:t>
-            </a:r>
-            <a:r>
-              <a:rPr lang="en-US" dirty="0" err="1"/>
-              <a:t>pytest</a:t>
-            </a:r>
-            <a:endParaRPr lang="en-US" dirty="0"/>
-          </a:p>
-        </p:txBody>
-      </p:sp>
-    </p:spTree>
-    <p:extLst>
-      <p:ext uri="{BB962C8B-B14F-4D97-AF65-F5344CB8AC3E}">
-        <p14:creationId xmlns:p14="http://schemas.microsoft.com/office/powerpoint/2010/main" val="3229755496"/>
-      </p:ext>
-    </p:extLst>
-  </p:cSld>
-  <p:clrMapOvr>
-    <a:masterClrMapping/>
-  </p:clrMapOvr>
-</p:sld>
-</file>
-
 <file path=ppt/slides/slide21.xml><?xml version="1.0" encoding="utf-8"?>
 <p:sld xmlns:a="http://schemas.openxmlformats.org/drawingml/2006/main" xmlns:r="http://schemas.openxmlformats.org/officeDocument/2006/relationships" xmlns:p="http://schemas.openxmlformats.org/presentationml/2006/main">
   <p:cSld>
@@ -13982,6 +14336,211 @@
           <p:cNvPr id="2" name="Title 1">
             <a:extLst>
               <a:ext uri="{FF2B5EF4-FFF2-40B4-BE49-F238E27FC236}">
+                <a16:creationId xmlns:a16="http://schemas.microsoft.com/office/drawing/2014/main" id="{BC9FF478-6F99-D45F-AB47-B407C21C95E4}"/>
+              </a:ext>
+            </a:extLst>
+          </p:cNvPr>
+          <p:cNvSpPr>
+            <a:spLocks noGrp="1"/>
+          </p:cNvSpPr>
+          <p:nvPr>
+            <p:ph type="title"/>
+          </p:nvPr>
+        </p:nvSpPr>
+        <p:spPr/>
+        <p:txBody>
+          <a:bodyPr/>
+          <a:lstStyle/>
+          <a:p>
+            <a:r>
+              <a:rPr lang="en-US" dirty="0"/>
+              <a:t>03 Executing Unit tests</a:t>
+            </a:r>
+          </a:p>
+        </p:txBody>
+      </p:sp>
+      <p:sp>
+        <p:nvSpPr>
+          <p:cNvPr id="3" name="Content Placeholder 2">
+            <a:extLst>
+              <a:ext uri="{FF2B5EF4-FFF2-40B4-BE49-F238E27FC236}">
+                <a16:creationId xmlns:a16="http://schemas.microsoft.com/office/drawing/2014/main" id="{ACA4E9D1-F822-1238-D8B5-01D1A36167DF}"/>
+              </a:ext>
+            </a:extLst>
+          </p:cNvPr>
+          <p:cNvSpPr>
+            <a:spLocks noGrp="1"/>
+          </p:cNvSpPr>
+          <p:nvPr>
+            <p:ph idx="1"/>
+          </p:nvPr>
+        </p:nvSpPr>
+        <p:spPr>
+          <a:xfrm>
+            <a:off x="680321" y="2050472"/>
+            <a:ext cx="9613861" cy="4655127"/>
+          </a:xfrm>
+        </p:spPr>
+        <p:txBody>
+          <a:bodyPr>
+            <a:normAutofit/>
+          </a:bodyPr>
+          <a:lstStyle/>
+          <a:p>
+            <a:pPr marL="0" indent="0">
+              <a:buNone/>
+            </a:pPr>
+            <a:r>
+              <a:rPr lang="en-US" dirty="0"/>
+              <a:t>There are several ways to execute a unit test:</a:t>
+            </a:r>
+          </a:p>
+          <a:p>
+            <a:pPr marL="0" indent="0">
+              <a:buNone/>
+            </a:pPr>
+            <a:r>
+              <a:rPr lang="en-US" dirty="0"/>
+              <a:t>	$ python –m </a:t>
+            </a:r>
+            <a:r>
+              <a:rPr lang="en-US" dirty="0" err="1"/>
+              <a:t>unittest</a:t>
+            </a:r>
+            <a:r>
+              <a:rPr lang="en-US" dirty="0"/>
+              <a:t> </a:t>
+            </a:r>
+            <a:r>
+              <a:rPr lang="en-US" dirty="0" err="1"/>
+              <a:t>test_circle_area.py</a:t>
+            </a:r>
+            <a:endParaRPr lang="en-US" dirty="0"/>
+          </a:p>
+          <a:p>
+            <a:pPr marL="0" indent="0">
+              <a:buNone/>
+            </a:pPr>
+            <a:r>
+              <a:rPr lang="en-US" dirty="0"/>
+              <a:t>	$ python </a:t>
+            </a:r>
+            <a:r>
+              <a:rPr lang="en-US" dirty="0" err="1"/>
+              <a:t>test_circle_area.py</a:t>
+            </a:r>
+            <a:endParaRPr lang="en-US" dirty="0"/>
+          </a:p>
+          <a:p>
+            <a:pPr marL="0" indent="0">
+              <a:buNone/>
+            </a:pPr>
+            <a:r>
+              <a:rPr lang="en-US" dirty="0"/>
+              <a:t>	$ </a:t>
+            </a:r>
+            <a:r>
+              <a:rPr lang="en-US" dirty="0" err="1"/>
+              <a:t>pytest</a:t>
+            </a:r>
+            <a:r>
+              <a:rPr lang="en-US" dirty="0"/>
+              <a:t> </a:t>
+            </a:r>
+            <a:r>
+              <a:rPr lang="en-US" dirty="0" err="1"/>
+              <a:t>test_circle_area.py</a:t>
+            </a:r>
+            <a:endParaRPr lang="en-US" dirty="0"/>
+          </a:p>
+          <a:p>
+            <a:pPr marL="0" indent="0">
+              <a:buNone/>
+            </a:pPr>
+            <a:endParaRPr lang="en-US" dirty="0"/>
+          </a:p>
+          <a:p>
+            <a:pPr marL="0" indent="0">
+              <a:buNone/>
+            </a:pPr>
+            <a:r>
+              <a:rPr lang="en-US" dirty="0"/>
+              <a:t>You can run a test suite with either with –m or with </a:t>
+            </a:r>
+            <a:r>
+              <a:rPr lang="en-US" dirty="0" err="1"/>
+              <a:t>pytest</a:t>
+            </a:r>
+            <a:r>
+              <a:rPr lang="en-US" dirty="0"/>
+              <a:t>:</a:t>
+            </a:r>
+          </a:p>
+          <a:p>
+            <a:pPr marL="0" indent="0">
+              <a:buNone/>
+            </a:pPr>
+            <a:r>
+              <a:rPr lang="en-US" dirty="0"/>
+              <a:t>	$ python –m </a:t>
+            </a:r>
+            <a:r>
+              <a:rPr lang="en-US" dirty="0" err="1"/>
+              <a:t>unittest</a:t>
+            </a:r>
+            <a:endParaRPr lang="en-US" dirty="0"/>
+          </a:p>
+          <a:p>
+            <a:pPr marL="0" indent="0">
+              <a:buNone/>
+            </a:pPr>
+            <a:r>
+              <a:rPr lang="en-US" dirty="0"/>
+              <a:t>	$ </a:t>
+            </a:r>
+            <a:r>
+              <a:rPr lang="en-US" dirty="0" err="1"/>
+              <a:t>pytest</a:t>
+            </a:r>
+            <a:endParaRPr lang="en-US" dirty="0"/>
+          </a:p>
+        </p:txBody>
+      </p:sp>
+    </p:spTree>
+    <p:extLst>
+      <p:ext uri="{BB962C8B-B14F-4D97-AF65-F5344CB8AC3E}">
+        <p14:creationId xmlns:p14="http://schemas.microsoft.com/office/powerpoint/2010/main" val="3229755496"/>
+      </p:ext>
+    </p:extLst>
+  </p:cSld>
+  <p:clrMapOvr>
+    <a:masterClrMapping/>
+  </p:clrMapOvr>
+</p:sld>
+</file>
+
+<file path=ppt/slides/slide22.xml><?xml version="1.0" encoding="utf-8"?>
+<p:sld xmlns:a="http://schemas.openxmlformats.org/drawingml/2006/main" xmlns:r="http://schemas.openxmlformats.org/officeDocument/2006/relationships" xmlns:p="http://schemas.openxmlformats.org/presentationml/2006/main">
+  <p:cSld>
+    <p:spTree>
+      <p:nvGrpSpPr>
+        <p:cNvPr id="1" name=""/>
+        <p:cNvGrpSpPr/>
+        <p:nvPr/>
+      </p:nvGrpSpPr>
+      <p:grpSpPr>
+        <a:xfrm>
+          <a:off x="0" y="0"/>
+          <a:ext cx="0" cy="0"/>
+          <a:chOff x="0" y="0"/>
+          <a:chExt cx="0" cy="0"/>
+        </a:xfrm>
+      </p:grpSpPr>
+      <p:sp>
+        <p:nvSpPr>
+          <p:cNvPr id="2" name="Title 1">
+            <a:extLst>
+              <a:ext uri="{FF2B5EF4-FFF2-40B4-BE49-F238E27FC236}">
                 <a16:creationId xmlns:a16="http://schemas.microsoft.com/office/drawing/2014/main" id="{1ACE1201-6411-2BA2-AB2D-E793E1C25471}"/>
               </a:ext>
             </a:extLst>
@@ -14056,11 +14615,11 @@
             </a:r>
             <a:r>
               <a:rPr lang="en-US" dirty="0" err="1"/>
-              <a:t>TestCase</a:t>
-            </a:r>
-            <a:r>
-              <a:rPr lang="en-US" dirty="0"/>
-              <a:t> parent class.</a:t>
+              <a:t>unitest</a:t>
+            </a:r>
+            <a:r>
+              <a:rPr lang="en-US" dirty="0"/>
+              <a:t> library parent class.</a:t>
             </a:r>
           </a:p>
           <a:p>
@@ -14523,7 +15082,7 @@
 </p:sld>
 </file>
 
-<file path=ppt/slides/slide22.xml><?xml version="1.0" encoding="utf-8"?>
+<file path=ppt/slides/slide23.xml><?xml version="1.0" encoding="utf-8"?>
 <p:sld xmlns:a="http://schemas.openxmlformats.org/drawingml/2006/main" xmlns:r="http://schemas.openxmlformats.org/officeDocument/2006/relationships" xmlns:p="http://schemas.openxmlformats.org/presentationml/2006/main">
   <p:cSld>
     <p:spTree>
@@ -14767,7 +15326,7 @@
 </p:sld>
 </file>
 
-<file path=ppt/slides/slide23.xml><?xml version="1.0" encoding="utf-8"?>
+<file path=ppt/slides/slide24.xml><?xml version="1.0" encoding="utf-8"?>
 <p:sld xmlns:a="http://schemas.openxmlformats.org/drawingml/2006/main" xmlns:r="http://schemas.openxmlformats.org/officeDocument/2006/relationships" xmlns:p="http://schemas.openxmlformats.org/presentationml/2006/main">
   <p:cSld>
     <p:spTree>
@@ -15393,691 +15952,6 @@
 </p:sld>
 </file>
 
-<file path=ppt/slides/slide24.xml><?xml version="1.0" encoding="utf-8"?>
-<p:sld xmlns:a="http://schemas.openxmlformats.org/drawingml/2006/main" xmlns:r="http://schemas.openxmlformats.org/officeDocument/2006/relationships" xmlns:p="http://schemas.openxmlformats.org/presentationml/2006/main">
-  <p:cSld>
-    <p:spTree>
-      <p:nvGrpSpPr>
-        <p:cNvPr id="1" name=""/>
-        <p:cNvGrpSpPr/>
-        <p:nvPr/>
-      </p:nvGrpSpPr>
-      <p:grpSpPr>
-        <a:xfrm>
-          <a:off x="0" y="0"/>
-          <a:ext cx="0" cy="0"/>
-          <a:chOff x="0" y="0"/>
-          <a:chExt cx="0" cy="0"/>
-        </a:xfrm>
-      </p:grpSpPr>
-      <p:sp>
-        <p:nvSpPr>
-          <p:cNvPr id="2" name="Title 1">
-            <a:extLst>
-              <a:ext uri="{FF2B5EF4-FFF2-40B4-BE49-F238E27FC236}">
-                <a16:creationId xmlns:a16="http://schemas.microsoft.com/office/drawing/2014/main" id="{13126664-8BE4-65A1-D9DD-B7A77299AC05}"/>
-              </a:ext>
-            </a:extLst>
-          </p:cNvPr>
-          <p:cNvSpPr>
-            <a:spLocks noGrp="1"/>
-          </p:cNvSpPr>
-          <p:nvPr>
-            <p:ph type="title"/>
-          </p:nvPr>
-        </p:nvSpPr>
-        <p:spPr/>
-        <p:txBody>
-          <a:bodyPr/>
-          <a:lstStyle/>
-          <a:p>
-            <a:r>
-              <a:rPr lang="en-US" dirty="0"/>
-              <a:t>05 C++ Testing</a:t>
-            </a:r>
-          </a:p>
-        </p:txBody>
-      </p:sp>
-      <p:sp>
-        <p:nvSpPr>
-          <p:cNvPr id="3" name="Content Placeholder 2">
-            <a:extLst>
-              <a:ext uri="{FF2B5EF4-FFF2-40B4-BE49-F238E27FC236}">
-                <a16:creationId xmlns:a16="http://schemas.microsoft.com/office/drawing/2014/main" id="{8E996BD5-C477-7FE7-4BEA-9FCB725D42EF}"/>
-              </a:ext>
-            </a:extLst>
-          </p:cNvPr>
-          <p:cNvSpPr>
-            <a:spLocks noGrp="1"/>
-          </p:cNvSpPr>
-          <p:nvPr>
-            <p:ph idx="1"/>
-          </p:nvPr>
-        </p:nvSpPr>
-        <p:spPr>
-          <a:xfrm>
-            <a:off x="658434" y="2092372"/>
-            <a:ext cx="9613861" cy="697272"/>
-          </a:xfrm>
-        </p:spPr>
-        <p:txBody>
-          <a:bodyPr/>
-          <a:lstStyle/>
-          <a:p>
-            <a:pPr marL="0" indent="0">
-              <a:buNone/>
-            </a:pPr>
-            <a:r>
-              <a:rPr lang="en-US" dirty="0"/>
-              <a:t>Boost Test is a Popular Testing Framework for C++</a:t>
-            </a:r>
-          </a:p>
-          <a:p>
-            <a:pPr marL="0" indent="0">
-              <a:buNone/>
-            </a:pPr>
-            <a:endParaRPr lang="en-US" dirty="0"/>
-          </a:p>
-          <a:p>
-            <a:pPr marL="0" indent="0">
-              <a:buNone/>
-            </a:pPr>
-            <a:endParaRPr lang="en-US" dirty="0"/>
-          </a:p>
-        </p:txBody>
-      </p:sp>
-      <p:sp>
-        <p:nvSpPr>
-          <p:cNvPr id="4" name="TextBox 3">
-            <a:extLst>
-              <a:ext uri="{FF2B5EF4-FFF2-40B4-BE49-F238E27FC236}">
-                <a16:creationId xmlns:a16="http://schemas.microsoft.com/office/drawing/2014/main" id="{C93011BF-2B2E-1AE5-C772-7470F25E00E1}"/>
-              </a:ext>
-            </a:extLst>
-          </p:cNvPr>
-          <p:cNvSpPr txBox="1"/>
-          <p:nvPr/>
-        </p:nvSpPr>
-        <p:spPr>
-          <a:xfrm>
-            <a:off x="1919705" y="2531194"/>
-            <a:ext cx="7135091" cy="2585323"/>
-          </a:xfrm>
-          <a:prstGeom prst="rect">
-            <a:avLst/>
-          </a:prstGeom>
-          <a:noFill/>
-        </p:spPr>
-        <p:txBody>
-          <a:bodyPr wrap="square" rtlCol="0">
-            <a:spAutoFit/>
-          </a:bodyPr>
-          <a:lstStyle/>
-          <a:p>
-            <a:r>
-              <a:rPr lang="en-US" b="0" dirty="0">
-                <a:solidFill>
-                  <a:srgbClr val="0000FF"/>
-                </a:solidFill>
-                <a:effectLst/>
-                <a:latin typeface="Menlo" panose="020B0609030804020204" pitchFamily="49" charset="0"/>
-              </a:rPr>
-              <a:t>#define BOOST_TEST_MODULE My Test</a:t>
-            </a:r>
-            <a:endParaRPr lang="en-US" b="0" dirty="0">
-              <a:solidFill>
-                <a:srgbClr val="000000"/>
-              </a:solidFill>
-              <a:effectLst/>
-              <a:latin typeface="Menlo" panose="020B0609030804020204" pitchFamily="49" charset="0"/>
-            </a:endParaRPr>
-          </a:p>
-          <a:p>
-            <a:r>
-              <a:rPr lang="en-US" b="0" dirty="0">
-                <a:solidFill>
-                  <a:srgbClr val="0000FF"/>
-                </a:solidFill>
-                <a:effectLst/>
-                <a:latin typeface="Menlo" panose="020B0609030804020204" pitchFamily="49" charset="0"/>
-              </a:rPr>
-              <a:t>#include </a:t>
-            </a:r>
-            <a:r>
-              <a:rPr lang="en-US" b="0" dirty="0">
-                <a:solidFill>
-                  <a:srgbClr val="A31515"/>
-                </a:solidFill>
-                <a:effectLst/>
-                <a:latin typeface="Menlo" panose="020B0609030804020204" pitchFamily="49" charset="0"/>
-              </a:rPr>
-              <a:t>&lt;boost/test/included/</a:t>
-            </a:r>
-            <a:r>
-              <a:rPr lang="en-US" b="0" dirty="0" err="1">
-                <a:solidFill>
-                  <a:srgbClr val="A31515"/>
-                </a:solidFill>
-                <a:effectLst/>
-                <a:latin typeface="Menlo" panose="020B0609030804020204" pitchFamily="49" charset="0"/>
-              </a:rPr>
-              <a:t>unit_test.hpp</a:t>
-            </a:r>
-            <a:r>
-              <a:rPr lang="en-US" b="0" dirty="0">
-                <a:solidFill>
-                  <a:srgbClr val="A31515"/>
-                </a:solidFill>
-                <a:effectLst/>
-                <a:latin typeface="Menlo" panose="020B0609030804020204" pitchFamily="49" charset="0"/>
-              </a:rPr>
-              <a:t>&gt;</a:t>
-            </a:r>
-            <a:endParaRPr lang="en-US" b="0" dirty="0">
-              <a:solidFill>
-                <a:srgbClr val="000000"/>
-              </a:solidFill>
-              <a:effectLst/>
-              <a:latin typeface="Menlo" panose="020B0609030804020204" pitchFamily="49" charset="0"/>
-            </a:endParaRPr>
-          </a:p>
-          <a:p>
-            <a:br>
-              <a:rPr lang="en-US" b="0" dirty="0">
-                <a:solidFill>
-                  <a:srgbClr val="000000"/>
-                </a:solidFill>
-                <a:effectLst/>
-                <a:latin typeface="Menlo" panose="020B0609030804020204" pitchFamily="49" charset="0"/>
-              </a:rPr>
-            </a:br>
-            <a:r>
-              <a:rPr lang="en-US" b="0" dirty="0">
-                <a:solidFill>
-                  <a:srgbClr val="000000"/>
-                </a:solidFill>
-                <a:effectLst/>
-                <a:latin typeface="Menlo" panose="020B0609030804020204" pitchFamily="49" charset="0"/>
-              </a:rPr>
-              <a:t>BOOST_AUTO_TEST_CASE(</a:t>
-            </a:r>
-            <a:r>
-              <a:rPr lang="en-US" b="0" dirty="0" err="1">
-                <a:solidFill>
-                  <a:srgbClr val="000000"/>
-                </a:solidFill>
-                <a:effectLst/>
-                <a:latin typeface="Menlo" panose="020B0609030804020204" pitchFamily="49" charset="0"/>
-              </a:rPr>
-              <a:t>first_test</a:t>
-            </a:r>
-            <a:r>
-              <a:rPr lang="en-US" b="0" dirty="0">
-                <a:solidFill>
-                  <a:srgbClr val="000000"/>
-                </a:solidFill>
-                <a:effectLst/>
-                <a:latin typeface="Menlo" panose="020B0609030804020204" pitchFamily="49" charset="0"/>
-              </a:rPr>
-              <a:t>)</a:t>
-            </a:r>
-          </a:p>
-          <a:p>
-            <a:r>
-              <a:rPr lang="en-US" b="0" dirty="0">
-                <a:solidFill>
-                  <a:srgbClr val="000000"/>
-                </a:solidFill>
-                <a:effectLst/>
-                <a:latin typeface="Menlo" panose="020B0609030804020204" pitchFamily="49" charset="0"/>
-              </a:rPr>
-              <a:t>{</a:t>
-            </a:r>
-          </a:p>
-          <a:p>
-            <a:r>
-              <a:rPr lang="en-US" b="0" dirty="0">
-                <a:solidFill>
-                  <a:srgbClr val="0000FF"/>
-                </a:solidFill>
-                <a:effectLst/>
-                <a:latin typeface="Menlo" panose="020B0609030804020204" pitchFamily="49" charset="0"/>
-              </a:rPr>
-              <a:t>    int</a:t>
-            </a:r>
-            <a:r>
-              <a:rPr lang="en-US" b="0" dirty="0">
-                <a:solidFill>
-                  <a:srgbClr val="000000"/>
-                </a:solidFill>
-                <a:effectLst/>
-                <a:latin typeface="Menlo" panose="020B0609030804020204" pitchFamily="49" charset="0"/>
-              </a:rPr>
-              <a:t> </a:t>
-            </a:r>
-            <a:r>
-              <a:rPr lang="en-US" b="0" dirty="0" err="1">
-                <a:solidFill>
-                  <a:srgbClr val="000000"/>
-                </a:solidFill>
-                <a:effectLst/>
-                <a:latin typeface="Menlo" panose="020B0609030804020204" pitchFamily="49" charset="0"/>
-              </a:rPr>
-              <a:t>i</a:t>
-            </a:r>
-            <a:r>
-              <a:rPr lang="en-US" b="0" dirty="0">
-                <a:solidFill>
-                  <a:srgbClr val="000000"/>
-                </a:solidFill>
-                <a:effectLst/>
-                <a:latin typeface="Menlo" panose="020B0609030804020204" pitchFamily="49" charset="0"/>
-              </a:rPr>
-              <a:t> = </a:t>
-            </a:r>
-            <a:r>
-              <a:rPr lang="en-US" b="0" dirty="0">
-                <a:solidFill>
-                  <a:srgbClr val="098658"/>
-                </a:solidFill>
-                <a:effectLst/>
-                <a:latin typeface="Menlo" panose="020B0609030804020204" pitchFamily="49" charset="0"/>
-              </a:rPr>
-              <a:t>1</a:t>
-            </a:r>
-            <a:r>
-              <a:rPr lang="en-US" b="0" dirty="0">
-                <a:solidFill>
-                  <a:srgbClr val="000000"/>
-                </a:solidFill>
-                <a:effectLst/>
-                <a:latin typeface="Menlo" panose="020B0609030804020204" pitchFamily="49" charset="0"/>
-              </a:rPr>
-              <a:t>;</a:t>
-            </a:r>
-          </a:p>
-          <a:p>
-            <a:r>
-              <a:rPr lang="en-US" b="0" dirty="0">
-                <a:solidFill>
-                  <a:srgbClr val="000000"/>
-                </a:solidFill>
-                <a:effectLst/>
-                <a:latin typeface="Menlo" panose="020B0609030804020204" pitchFamily="49" charset="0"/>
-              </a:rPr>
-              <a:t>    BOOST_TEST(</a:t>
-            </a:r>
-            <a:r>
-              <a:rPr lang="en-US" b="0" dirty="0" err="1">
-                <a:solidFill>
-                  <a:srgbClr val="000000"/>
-                </a:solidFill>
-                <a:effectLst/>
-                <a:latin typeface="Menlo" panose="020B0609030804020204" pitchFamily="49" charset="0"/>
-              </a:rPr>
-              <a:t>i</a:t>
-            </a:r>
-            <a:r>
-              <a:rPr lang="en-US" b="0" dirty="0">
-                <a:solidFill>
-                  <a:srgbClr val="000000"/>
-                </a:solidFill>
-                <a:effectLst/>
-                <a:latin typeface="Menlo" panose="020B0609030804020204" pitchFamily="49" charset="0"/>
-              </a:rPr>
-              <a:t>);</a:t>
-            </a:r>
-          </a:p>
-          <a:p>
-            <a:r>
-              <a:rPr lang="en-US" b="0" dirty="0">
-                <a:solidFill>
-                  <a:srgbClr val="000000"/>
-                </a:solidFill>
-                <a:effectLst/>
-                <a:latin typeface="Menlo" panose="020B0609030804020204" pitchFamily="49" charset="0"/>
-              </a:rPr>
-              <a:t>    BOOST_TEST(</a:t>
-            </a:r>
-            <a:r>
-              <a:rPr lang="en-US" b="0" dirty="0" err="1">
-                <a:solidFill>
-                  <a:srgbClr val="000000"/>
-                </a:solidFill>
-                <a:effectLst/>
-                <a:latin typeface="Menlo" panose="020B0609030804020204" pitchFamily="49" charset="0"/>
-              </a:rPr>
-              <a:t>i</a:t>
-            </a:r>
-            <a:r>
-              <a:rPr lang="en-US" b="0" dirty="0">
-                <a:solidFill>
-                  <a:srgbClr val="000000"/>
-                </a:solidFill>
-                <a:effectLst/>
-                <a:latin typeface="Menlo" panose="020B0609030804020204" pitchFamily="49" charset="0"/>
-              </a:rPr>
-              <a:t> == </a:t>
-            </a:r>
-            <a:r>
-              <a:rPr lang="en-US" b="0" dirty="0">
-                <a:solidFill>
-                  <a:srgbClr val="098658"/>
-                </a:solidFill>
-                <a:effectLst/>
-                <a:latin typeface="Menlo" panose="020B0609030804020204" pitchFamily="49" charset="0"/>
-              </a:rPr>
-              <a:t>2</a:t>
-            </a:r>
-            <a:r>
-              <a:rPr lang="en-US" b="0" dirty="0">
-                <a:solidFill>
-                  <a:srgbClr val="000000"/>
-                </a:solidFill>
-                <a:effectLst/>
-                <a:latin typeface="Menlo" panose="020B0609030804020204" pitchFamily="49" charset="0"/>
-              </a:rPr>
-              <a:t>);</a:t>
-            </a:r>
-          </a:p>
-          <a:p>
-            <a:r>
-              <a:rPr lang="en-US" b="0" dirty="0">
-                <a:solidFill>
-                  <a:srgbClr val="000000"/>
-                </a:solidFill>
-                <a:effectLst/>
-                <a:latin typeface="Menlo" panose="020B0609030804020204" pitchFamily="49" charset="0"/>
-              </a:rPr>
-              <a:t>}</a:t>
-            </a:r>
-          </a:p>
-        </p:txBody>
-      </p:sp>
-      <p:sp>
-        <p:nvSpPr>
-          <p:cNvPr id="5" name="TextBox 4">
-            <a:extLst>
-              <a:ext uri="{FF2B5EF4-FFF2-40B4-BE49-F238E27FC236}">
-                <a16:creationId xmlns:a16="http://schemas.microsoft.com/office/drawing/2014/main" id="{75A8009C-2A09-68C6-F2C7-4DD46FDB2A1A}"/>
-              </a:ext>
-            </a:extLst>
-          </p:cNvPr>
-          <p:cNvSpPr txBox="1"/>
-          <p:nvPr/>
-        </p:nvSpPr>
-        <p:spPr>
-          <a:xfrm>
-            <a:off x="472503" y="5023835"/>
-            <a:ext cx="10504799" cy="2031325"/>
-          </a:xfrm>
-          <a:prstGeom prst="rect">
-            <a:avLst/>
-          </a:prstGeom>
-          <a:noFill/>
-        </p:spPr>
-        <p:txBody>
-          <a:bodyPr wrap="none" rtlCol="0">
-            <a:spAutoFit/>
-          </a:bodyPr>
-          <a:lstStyle/>
-          <a:p>
-            <a:r>
-              <a:rPr lang="en-US" b="0" dirty="0">
-                <a:solidFill>
-                  <a:srgbClr val="000000"/>
-                </a:solidFill>
-                <a:effectLst/>
-                <a:latin typeface="Menlo" panose="020B0609030804020204" pitchFamily="49" charset="0"/>
-              </a:rPr>
-              <a:t>$ g++ </a:t>
-            </a:r>
-            <a:r>
-              <a:rPr lang="en-US" b="0" dirty="0" err="1">
-                <a:solidFill>
-                  <a:srgbClr val="000000"/>
-                </a:solidFill>
-                <a:effectLst/>
-                <a:latin typeface="Menlo" panose="020B0609030804020204" pitchFamily="49" charset="0"/>
-              </a:rPr>
-              <a:t>test_file.cpp</a:t>
-            </a:r>
-            <a:r>
-              <a:rPr lang="en-US" b="0" dirty="0">
-                <a:solidFill>
-                  <a:srgbClr val="000000"/>
-                </a:solidFill>
-                <a:effectLst/>
-                <a:latin typeface="Menlo" panose="020B0609030804020204" pitchFamily="49" charset="0"/>
-              </a:rPr>
-              <a:t> </a:t>
-            </a:r>
-          </a:p>
-          <a:p>
-            <a:r>
-              <a:rPr lang="en-US" b="0" dirty="0">
-                <a:solidFill>
-                  <a:srgbClr val="000000"/>
-                </a:solidFill>
-                <a:effectLst/>
-                <a:latin typeface="Menlo" panose="020B0609030804020204" pitchFamily="49" charset="0"/>
-              </a:rPr>
-              <a:t>$ ./</a:t>
-            </a:r>
-            <a:r>
-              <a:rPr lang="en-US" b="0" dirty="0" err="1">
-                <a:solidFill>
-                  <a:srgbClr val="000000"/>
-                </a:solidFill>
-                <a:effectLst/>
-                <a:latin typeface="Menlo" panose="020B0609030804020204" pitchFamily="49" charset="0"/>
-              </a:rPr>
-              <a:t>a.out</a:t>
-            </a:r>
-            <a:r>
-              <a:rPr lang="en-US" b="0" dirty="0">
-                <a:solidFill>
-                  <a:srgbClr val="000000"/>
-                </a:solidFill>
-                <a:effectLst/>
-                <a:latin typeface="Menlo" panose="020B0609030804020204" pitchFamily="49" charset="0"/>
-              </a:rPr>
-              <a:t> </a:t>
-            </a:r>
-          </a:p>
-          <a:p>
-            <a:r>
-              <a:rPr lang="en-US" b="0" dirty="0">
-                <a:solidFill>
-                  <a:srgbClr val="000000"/>
-                </a:solidFill>
-                <a:effectLst/>
-                <a:latin typeface="Menlo" panose="020B0609030804020204" pitchFamily="49" charset="0"/>
-              </a:rPr>
-              <a:t>Running 1 test case...</a:t>
-            </a:r>
-          </a:p>
-          <a:p>
-            <a:r>
-              <a:rPr lang="en-US" b="0" dirty="0" err="1">
-                <a:solidFill>
-                  <a:srgbClr val="000000"/>
-                </a:solidFill>
-                <a:effectLst/>
-                <a:latin typeface="Menlo" panose="020B0609030804020204" pitchFamily="49" charset="0"/>
-              </a:rPr>
-              <a:t>test_file.cpp</a:t>
-            </a:r>
-            <a:r>
-              <a:rPr lang="en-US" b="0" dirty="0">
-                <a:solidFill>
-                  <a:srgbClr val="000000"/>
-                </a:solidFill>
-                <a:effectLst/>
-                <a:latin typeface="Menlo" panose="020B0609030804020204" pitchFamily="49" charset="0"/>
-              </a:rPr>
-              <a:t>(8): error: </a:t>
-            </a:r>
-            <a:r>
-              <a:rPr lang="en-US" b="0" dirty="0">
-                <a:solidFill>
-                  <a:srgbClr val="0000FF"/>
-                </a:solidFill>
-                <a:effectLst/>
-                <a:latin typeface="Menlo" panose="020B0609030804020204" pitchFamily="49" charset="0"/>
-              </a:rPr>
-              <a:t>in</a:t>
-            </a:r>
-            <a:r>
-              <a:rPr lang="en-US" b="0" dirty="0">
-                <a:solidFill>
-                  <a:srgbClr val="000000"/>
-                </a:solidFill>
-                <a:effectLst/>
-                <a:latin typeface="Menlo" panose="020B0609030804020204" pitchFamily="49" charset="0"/>
-              </a:rPr>
-              <a:t> </a:t>
-            </a:r>
-            <a:r>
-              <a:rPr lang="en-US" b="0" dirty="0">
-                <a:solidFill>
-                  <a:srgbClr val="A31515"/>
-                </a:solidFill>
-                <a:effectLst/>
-                <a:latin typeface="Menlo" panose="020B0609030804020204" pitchFamily="49" charset="0"/>
-              </a:rPr>
-              <a:t>"</a:t>
-            </a:r>
-            <a:r>
-              <a:rPr lang="en-US" b="0" dirty="0" err="1">
-                <a:solidFill>
-                  <a:srgbClr val="A31515"/>
-                </a:solidFill>
-                <a:effectLst/>
-                <a:latin typeface="Menlo" panose="020B0609030804020204" pitchFamily="49" charset="0"/>
-              </a:rPr>
-              <a:t>first_test</a:t>
-            </a:r>
-            <a:r>
-              <a:rPr lang="en-US" b="0" dirty="0">
-                <a:solidFill>
-                  <a:srgbClr val="A31515"/>
-                </a:solidFill>
-                <a:effectLst/>
-                <a:latin typeface="Menlo" panose="020B0609030804020204" pitchFamily="49" charset="0"/>
-              </a:rPr>
-              <a:t>"</a:t>
-            </a:r>
-            <a:r>
-              <a:rPr lang="en-US" b="0" dirty="0">
-                <a:solidFill>
-                  <a:srgbClr val="000000"/>
-                </a:solidFill>
-                <a:effectLst/>
-                <a:latin typeface="Menlo" panose="020B0609030804020204" pitchFamily="49" charset="0"/>
-              </a:rPr>
-              <a:t>: check </a:t>
-            </a:r>
-            <a:r>
-              <a:rPr lang="en-US" b="0" dirty="0" err="1">
-                <a:solidFill>
-                  <a:srgbClr val="000000"/>
-                </a:solidFill>
-                <a:effectLst/>
-                <a:latin typeface="Menlo" panose="020B0609030804020204" pitchFamily="49" charset="0"/>
-              </a:rPr>
-              <a:t>i</a:t>
-            </a:r>
-            <a:r>
-              <a:rPr lang="en-US" b="0" dirty="0">
-                <a:solidFill>
-                  <a:srgbClr val="000000"/>
-                </a:solidFill>
-                <a:effectLst/>
-                <a:latin typeface="Menlo" panose="020B0609030804020204" pitchFamily="49" charset="0"/>
-              </a:rPr>
-              <a:t> == 2 has failed [1 != 2]</a:t>
-            </a:r>
-          </a:p>
-          <a:p>
-            <a:br>
-              <a:rPr lang="en-US" b="0" dirty="0">
-                <a:solidFill>
-                  <a:srgbClr val="000000"/>
-                </a:solidFill>
-                <a:effectLst/>
-                <a:latin typeface="Menlo" panose="020B0609030804020204" pitchFamily="49" charset="0"/>
-              </a:rPr>
-            </a:br>
-            <a:r>
-              <a:rPr lang="en-US" b="0" dirty="0">
-                <a:solidFill>
-                  <a:srgbClr val="000000"/>
-                </a:solidFill>
-                <a:effectLst/>
-                <a:latin typeface="Menlo" panose="020B0609030804020204" pitchFamily="49" charset="0"/>
-              </a:rPr>
-              <a:t>*** 1 failure is detected </a:t>
-            </a:r>
-            <a:r>
-              <a:rPr lang="en-US" b="0" dirty="0">
-                <a:solidFill>
-                  <a:srgbClr val="0000FF"/>
-                </a:solidFill>
-                <a:effectLst/>
-                <a:latin typeface="Menlo" panose="020B0609030804020204" pitchFamily="49" charset="0"/>
-              </a:rPr>
-              <a:t>in</a:t>
-            </a:r>
-            <a:r>
-              <a:rPr lang="en-US" b="0" dirty="0">
-                <a:solidFill>
-                  <a:srgbClr val="000000"/>
-                </a:solidFill>
-                <a:effectLst/>
-                <a:latin typeface="Menlo" panose="020B0609030804020204" pitchFamily="49" charset="0"/>
-              </a:rPr>
-              <a:t> the test module </a:t>
-            </a:r>
-            <a:r>
-              <a:rPr lang="en-US" b="0" dirty="0">
-                <a:solidFill>
-                  <a:srgbClr val="A31515"/>
-                </a:solidFill>
-                <a:effectLst/>
-                <a:latin typeface="Menlo" panose="020B0609030804020204" pitchFamily="49" charset="0"/>
-              </a:rPr>
-              <a:t>"My Test"</a:t>
-            </a:r>
-            <a:r>
-              <a:rPr lang="en-US" b="0" dirty="0">
-                <a:solidFill>
-                  <a:srgbClr val="000000"/>
-                </a:solidFill>
-                <a:effectLst/>
-                <a:latin typeface="Menlo" panose="020B0609030804020204" pitchFamily="49" charset="0"/>
-              </a:rPr>
-              <a:t> </a:t>
-            </a:r>
-          </a:p>
-          <a:p>
-            <a:endParaRPr lang="en-US" dirty="0"/>
-          </a:p>
-        </p:txBody>
-      </p:sp>
-    </p:spTree>
-    <p:extLst>
-      <p:ext uri="{BB962C8B-B14F-4D97-AF65-F5344CB8AC3E}">
-        <p14:creationId xmlns:p14="http://schemas.microsoft.com/office/powerpoint/2010/main" val="404222977"/>
-      </p:ext>
-    </p:extLst>
-  </p:cSld>
-  <p:clrMapOvr>
-    <a:masterClrMapping/>
-  </p:clrMapOvr>
-</p:sld>
-</file>
-
 <file path=ppt/slides/slide25.xml><?xml version="1.0" encoding="utf-8"?>
 <p:sld xmlns:a="http://schemas.openxmlformats.org/drawingml/2006/main" xmlns:r="http://schemas.openxmlformats.org/officeDocument/2006/relationships" xmlns:p="http://schemas.openxmlformats.org/presentationml/2006/main">
   <p:cSld>
@@ -16100,7 +15974,7 @@
           <p:cNvPr id="2" name="Title 1">
             <a:extLst>
               <a:ext uri="{FF2B5EF4-FFF2-40B4-BE49-F238E27FC236}">
-                <a16:creationId xmlns:a16="http://schemas.microsoft.com/office/drawing/2014/main" id="{F0323625-6E9D-8BD6-EF2A-3D3A89B4035B}"/>
+                <a16:creationId xmlns:a16="http://schemas.microsoft.com/office/drawing/2014/main" id="{13126664-8BE4-65A1-D9DD-B7A77299AC05}"/>
               </a:ext>
             </a:extLst>
           </p:cNvPr>
@@ -16118,7 +15992,7 @@
           <a:p>
             <a:r>
               <a:rPr lang="en-US" dirty="0"/>
-              <a:t>TDD – Test Driven Design</a:t>
+              <a:t>05 C++ Testing</a:t>
             </a:r>
           </a:p>
         </p:txBody>
@@ -16128,7 +16002,7 @@
           <p:cNvPr id="3" name="Content Placeholder 2">
             <a:extLst>
               <a:ext uri="{FF2B5EF4-FFF2-40B4-BE49-F238E27FC236}">
-                <a16:creationId xmlns:a16="http://schemas.microsoft.com/office/drawing/2014/main" id="{2DD885AA-8633-4B1D-638C-C27E92A8A907}"/>
+                <a16:creationId xmlns:a16="http://schemas.microsoft.com/office/drawing/2014/main" id="{8E996BD5-C477-7FE7-4BEA-9FCB725D42EF}"/>
               </a:ext>
             </a:extLst>
           </p:cNvPr>
@@ -16139,7 +16013,12 @@
             <p:ph idx="1"/>
           </p:nvPr>
         </p:nvSpPr>
-        <p:spPr/>
+        <p:spPr>
+          <a:xfrm>
+            <a:off x="658434" y="2092372"/>
+            <a:ext cx="9613861" cy="697272"/>
+          </a:xfrm>
+        </p:spPr>
         <p:txBody>
           <a:bodyPr/>
           <a:lstStyle/>
@@ -16149,7 +16028,7 @@
             </a:pPr>
             <a:r>
               <a:rPr lang="en-US" dirty="0"/>
-              <a:t>Refers to the practice of writing test BEFORE you write code.</a:t>
+              <a:t>Boost Test is a Popular Testing Framework for C++</a:t>
             </a:r>
           </a:p>
           <a:p>
@@ -16162,35 +16041,593 @@
             <a:pPr marL="0" indent="0">
               <a:buNone/>
             </a:pPr>
-            <a:r>
-              <a:rPr lang="en-US" dirty="0"/>
-              <a:t>Benefits:</a:t>
-            </a:r>
-          </a:p>
-          <a:p>
-            <a:r>
-              <a:rPr lang="en-US" dirty="0"/>
-              <a:t>Writing tests first helps you understand the specification.</a:t>
-            </a:r>
-          </a:p>
-          <a:p>
-            <a:r>
-              <a:rPr lang="en-US" dirty="0"/>
-              <a:t>Writing test to reproduce a bug proves it is fixed by the change.</a:t>
-            </a:r>
-          </a:p>
-          <a:p>
-            <a:r>
-              <a:rPr lang="en-US" dirty="0"/>
-              <a:t>Running tests as you develop lets you fix bugs early (is faster).</a:t>
-            </a:r>
+            <a:endParaRPr lang="en-US" dirty="0"/>
+          </a:p>
+        </p:txBody>
+      </p:sp>
+      <p:sp>
+        <p:nvSpPr>
+          <p:cNvPr id="4" name="TextBox 3">
+            <a:extLst>
+              <a:ext uri="{FF2B5EF4-FFF2-40B4-BE49-F238E27FC236}">
+                <a16:creationId xmlns:a16="http://schemas.microsoft.com/office/drawing/2014/main" id="{C93011BF-2B2E-1AE5-C772-7470F25E00E1}"/>
+              </a:ext>
+            </a:extLst>
+          </p:cNvPr>
+          <p:cNvSpPr txBox="1"/>
+          <p:nvPr/>
+        </p:nvSpPr>
+        <p:spPr>
+          <a:xfrm>
+            <a:off x="1919705" y="2531194"/>
+            <a:ext cx="7135091" cy="2585323"/>
+          </a:xfrm>
+          <a:prstGeom prst="rect">
+            <a:avLst/>
+          </a:prstGeom>
+          <a:noFill/>
+        </p:spPr>
+        <p:txBody>
+          <a:bodyPr wrap="square" rtlCol="0">
+            <a:spAutoFit/>
+          </a:bodyPr>
+          <a:lstStyle/>
+          <a:p>
+            <a:r>
+              <a:rPr lang="en-US" b="0" dirty="0">
+                <a:solidFill>
+                  <a:srgbClr val="0000FF"/>
+                </a:solidFill>
+                <a:effectLst/>
+                <a:latin typeface="Menlo" panose="020B0609030804020204" pitchFamily="49" charset="0"/>
+              </a:rPr>
+              <a:t>#define BOOST_TEST_MODULE My Test</a:t>
+            </a:r>
+            <a:endParaRPr lang="en-US" b="0" dirty="0">
+              <a:solidFill>
+                <a:srgbClr val="000000"/>
+              </a:solidFill>
+              <a:effectLst/>
+              <a:latin typeface="Menlo" panose="020B0609030804020204" pitchFamily="49" charset="0"/>
+            </a:endParaRPr>
+          </a:p>
+          <a:p>
+            <a:r>
+              <a:rPr lang="en-US" b="0" dirty="0">
+                <a:solidFill>
+                  <a:srgbClr val="0000FF"/>
+                </a:solidFill>
+                <a:effectLst/>
+                <a:latin typeface="Menlo" panose="020B0609030804020204" pitchFamily="49" charset="0"/>
+              </a:rPr>
+              <a:t>#include </a:t>
+            </a:r>
+            <a:r>
+              <a:rPr lang="en-US" b="0" dirty="0">
+                <a:solidFill>
+                  <a:srgbClr val="A31515"/>
+                </a:solidFill>
+                <a:effectLst/>
+                <a:latin typeface="Menlo" panose="020B0609030804020204" pitchFamily="49" charset="0"/>
+              </a:rPr>
+              <a:t>&lt;boost/test/included/</a:t>
+            </a:r>
+            <a:r>
+              <a:rPr lang="en-US" b="0" dirty="0" err="1">
+                <a:solidFill>
+                  <a:srgbClr val="A31515"/>
+                </a:solidFill>
+                <a:effectLst/>
+                <a:latin typeface="Menlo" panose="020B0609030804020204" pitchFamily="49" charset="0"/>
+              </a:rPr>
+              <a:t>unit_test.hpp</a:t>
+            </a:r>
+            <a:r>
+              <a:rPr lang="en-US" b="0" dirty="0">
+                <a:solidFill>
+                  <a:srgbClr val="A31515"/>
+                </a:solidFill>
+                <a:effectLst/>
+                <a:latin typeface="Menlo" panose="020B0609030804020204" pitchFamily="49" charset="0"/>
+              </a:rPr>
+              <a:t>&gt;</a:t>
+            </a:r>
+            <a:endParaRPr lang="en-US" b="0" dirty="0">
+              <a:solidFill>
+                <a:srgbClr val="000000"/>
+              </a:solidFill>
+              <a:effectLst/>
+              <a:latin typeface="Menlo" panose="020B0609030804020204" pitchFamily="49" charset="0"/>
+            </a:endParaRPr>
+          </a:p>
+          <a:p>
+            <a:br>
+              <a:rPr lang="en-US" b="0" dirty="0">
+                <a:solidFill>
+                  <a:srgbClr val="000000"/>
+                </a:solidFill>
+                <a:effectLst/>
+                <a:latin typeface="Menlo" panose="020B0609030804020204" pitchFamily="49" charset="0"/>
+              </a:rPr>
+            </a:br>
+            <a:r>
+              <a:rPr lang="en-US" b="0" dirty="0">
+                <a:solidFill>
+                  <a:srgbClr val="000000"/>
+                </a:solidFill>
+                <a:effectLst/>
+                <a:latin typeface="Menlo" panose="020B0609030804020204" pitchFamily="49" charset="0"/>
+              </a:rPr>
+              <a:t>BOOST_AUTO_TEST_CASE(</a:t>
+            </a:r>
+            <a:r>
+              <a:rPr lang="en-US" b="0" dirty="0" err="1">
+                <a:solidFill>
+                  <a:srgbClr val="000000"/>
+                </a:solidFill>
+                <a:effectLst/>
+                <a:latin typeface="Menlo" panose="020B0609030804020204" pitchFamily="49" charset="0"/>
+              </a:rPr>
+              <a:t>first_test</a:t>
+            </a:r>
+            <a:r>
+              <a:rPr lang="en-US" b="0" dirty="0">
+                <a:solidFill>
+                  <a:srgbClr val="000000"/>
+                </a:solidFill>
+                <a:effectLst/>
+                <a:latin typeface="Menlo" panose="020B0609030804020204" pitchFamily="49" charset="0"/>
+              </a:rPr>
+              <a:t>)</a:t>
+            </a:r>
+          </a:p>
+          <a:p>
+            <a:r>
+              <a:rPr lang="en-US" b="0" dirty="0">
+                <a:solidFill>
+                  <a:srgbClr val="000000"/>
+                </a:solidFill>
+                <a:effectLst/>
+                <a:latin typeface="Menlo" panose="020B0609030804020204" pitchFamily="49" charset="0"/>
+              </a:rPr>
+              <a:t>{</a:t>
+            </a:r>
+          </a:p>
+          <a:p>
+            <a:r>
+              <a:rPr lang="en-US" b="0" dirty="0">
+                <a:solidFill>
+                  <a:srgbClr val="0000FF"/>
+                </a:solidFill>
+                <a:effectLst/>
+                <a:latin typeface="Menlo" panose="020B0609030804020204" pitchFamily="49" charset="0"/>
+              </a:rPr>
+              <a:t>    int</a:t>
+            </a:r>
+            <a:r>
+              <a:rPr lang="en-US" b="0" dirty="0">
+                <a:solidFill>
+                  <a:srgbClr val="000000"/>
+                </a:solidFill>
+                <a:effectLst/>
+                <a:latin typeface="Menlo" panose="020B0609030804020204" pitchFamily="49" charset="0"/>
+              </a:rPr>
+              <a:t> </a:t>
+            </a:r>
+            <a:r>
+              <a:rPr lang="en-US" b="0" dirty="0" err="1">
+                <a:solidFill>
+                  <a:srgbClr val="000000"/>
+                </a:solidFill>
+                <a:effectLst/>
+                <a:latin typeface="Menlo" panose="020B0609030804020204" pitchFamily="49" charset="0"/>
+              </a:rPr>
+              <a:t>i</a:t>
+            </a:r>
+            <a:r>
+              <a:rPr lang="en-US" b="0" dirty="0">
+                <a:solidFill>
+                  <a:srgbClr val="000000"/>
+                </a:solidFill>
+                <a:effectLst/>
+                <a:latin typeface="Menlo" panose="020B0609030804020204" pitchFamily="49" charset="0"/>
+              </a:rPr>
+              <a:t> = </a:t>
+            </a:r>
+            <a:r>
+              <a:rPr lang="en-US" b="0" dirty="0">
+                <a:solidFill>
+                  <a:srgbClr val="098658"/>
+                </a:solidFill>
+                <a:effectLst/>
+                <a:latin typeface="Menlo" panose="020B0609030804020204" pitchFamily="49" charset="0"/>
+              </a:rPr>
+              <a:t>1</a:t>
+            </a:r>
+            <a:r>
+              <a:rPr lang="en-US" b="0" dirty="0">
+                <a:solidFill>
+                  <a:srgbClr val="000000"/>
+                </a:solidFill>
+                <a:effectLst/>
+                <a:latin typeface="Menlo" panose="020B0609030804020204" pitchFamily="49" charset="0"/>
+              </a:rPr>
+              <a:t>;</a:t>
+            </a:r>
+          </a:p>
+          <a:p>
+            <a:r>
+              <a:rPr lang="en-US" b="0" dirty="0">
+                <a:solidFill>
+                  <a:srgbClr val="000000"/>
+                </a:solidFill>
+                <a:effectLst/>
+                <a:latin typeface="Menlo" panose="020B0609030804020204" pitchFamily="49" charset="0"/>
+              </a:rPr>
+              <a:t>    BOOST_TEST(</a:t>
+            </a:r>
+            <a:r>
+              <a:rPr lang="en-US" b="0" dirty="0" err="1">
+                <a:solidFill>
+                  <a:srgbClr val="000000"/>
+                </a:solidFill>
+                <a:effectLst/>
+                <a:latin typeface="Menlo" panose="020B0609030804020204" pitchFamily="49" charset="0"/>
+              </a:rPr>
+              <a:t>i</a:t>
+            </a:r>
+            <a:r>
+              <a:rPr lang="en-US" b="0" dirty="0">
+                <a:solidFill>
+                  <a:srgbClr val="000000"/>
+                </a:solidFill>
+                <a:effectLst/>
+                <a:latin typeface="Menlo" panose="020B0609030804020204" pitchFamily="49" charset="0"/>
+              </a:rPr>
+              <a:t>);</a:t>
+            </a:r>
+          </a:p>
+          <a:p>
+            <a:r>
+              <a:rPr lang="en-US" b="0" dirty="0">
+                <a:solidFill>
+                  <a:srgbClr val="000000"/>
+                </a:solidFill>
+                <a:effectLst/>
+                <a:latin typeface="Menlo" panose="020B0609030804020204" pitchFamily="49" charset="0"/>
+              </a:rPr>
+              <a:t>    BOOST_TEST(</a:t>
+            </a:r>
+            <a:r>
+              <a:rPr lang="en-US" b="0" dirty="0" err="1">
+                <a:solidFill>
+                  <a:srgbClr val="000000"/>
+                </a:solidFill>
+                <a:effectLst/>
+                <a:latin typeface="Menlo" panose="020B0609030804020204" pitchFamily="49" charset="0"/>
+              </a:rPr>
+              <a:t>i</a:t>
+            </a:r>
+            <a:r>
+              <a:rPr lang="en-US" b="0" dirty="0">
+                <a:solidFill>
+                  <a:srgbClr val="000000"/>
+                </a:solidFill>
+                <a:effectLst/>
+                <a:latin typeface="Menlo" panose="020B0609030804020204" pitchFamily="49" charset="0"/>
+              </a:rPr>
+              <a:t> == </a:t>
+            </a:r>
+            <a:r>
+              <a:rPr lang="en-US" b="0" dirty="0">
+                <a:solidFill>
+                  <a:srgbClr val="098658"/>
+                </a:solidFill>
+                <a:effectLst/>
+                <a:latin typeface="Menlo" panose="020B0609030804020204" pitchFamily="49" charset="0"/>
+              </a:rPr>
+              <a:t>2</a:t>
+            </a:r>
+            <a:r>
+              <a:rPr lang="en-US" b="0" dirty="0">
+                <a:solidFill>
+                  <a:srgbClr val="000000"/>
+                </a:solidFill>
+                <a:effectLst/>
+                <a:latin typeface="Menlo" panose="020B0609030804020204" pitchFamily="49" charset="0"/>
+              </a:rPr>
+              <a:t>);</a:t>
+            </a:r>
+          </a:p>
+          <a:p>
+            <a:r>
+              <a:rPr lang="en-US" b="0" dirty="0">
+                <a:solidFill>
+                  <a:srgbClr val="000000"/>
+                </a:solidFill>
+                <a:effectLst/>
+                <a:latin typeface="Menlo" panose="020B0609030804020204" pitchFamily="49" charset="0"/>
+              </a:rPr>
+              <a:t>}</a:t>
+            </a:r>
+          </a:p>
+        </p:txBody>
+      </p:sp>
+      <p:sp>
+        <p:nvSpPr>
+          <p:cNvPr id="5" name="TextBox 4">
+            <a:extLst>
+              <a:ext uri="{FF2B5EF4-FFF2-40B4-BE49-F238E27FC236}">
+                <a16:creationId xmlns:a16="http://schemas.microsoft.com/office/drawing/2014/main" id="{75A8009C-2A09-68C6-F2C7-4DD46FDB2A1A}"/>
+              </a:ext>
+            </a:extLst>
+          </p:cNvPr>
+          <p:cNvSpPr txBox="1"/>
+          <p:nvPr/>
+        </p:nvSpPr>
+        <p:spPr>
+          <a:xfrm>
+            <a:off x="472503" y="5023835"/>
+            <a:ext cx="10504799" cy="2031325"/>
+          </a:xfrm>
+          <a:prstGeom prst="rect">
+            <a:avLst/>
+          </a:prstGeom>
+          <a:noFill/>
+        </p:spPr>
+        <p:txBody>
+          <a:bodyPr wrap="none" rtlCol="0">
+            <a:spAutoFit/>
+          </a:bodyPr>
+          <a:lstStyle/>
+          <a:p>
+            <a:r>
+              <a:rPr lang="en-US" b="0" dirty="0">
+                <a:solidFill>
+                  <a:srgbClr val="000000"/>
+                </a:solidFill>
+                <a:effectLst/>
+                <a:latin typeface="Menlo" panose="020B0609030804020204" pitchFamily="49" charset="0"/>
+              </a:rPr>
+              <a:t>$ g++ </a:t>
+            </a:r>
+            <a:r>
+              <a:rPr lang="en-US" b="0" dirty="0" err="1">
+                <a:solidFill>
+                  <a:srgbClr val="000000"/>
+                </a:solidFill>
+                <a:effectLst/>
+                <a:latin typeface="Menlo" panose="020B0609030804020204" pitchFamily="49" charset="0"/>
+              </a:rPr>
+              <a:t>test_file.cpp</a:t>
+            </a:r>
+            <a:r>
+              <a:rPr lang="en-US" b="0" dirty="0">
+                <a:solidFill>
+                  <a:srgbClr val="000000"/>
+                </a:solidFill>
+                <a:effectLst/>
+                <a:latin typeface="Menlo" panose="020B0609030804020204" pitchFamily="49" charset="0"/>
+              </a:rPr>
+              <a:t> </a:t>
+            </a:r>
+          </a:p>
+          <a:p>
+            <a:r>
+              <a:rPr lang="en-US" b="0" dirty="0">
+                <a:solidFill>
+                  <a:srgbClr val="000000"/>
+                </a:solidFill>
+                <a:effectLst/>
+                <a:latin typeface="Menlo" panose="020B0609030804020204" pitchFamily="49" charset="0"/>
+              </a:rPr>
+              <a:t>$ ./</a:t>
+            </a:r>
+            <a:r>
+              <a:rPr lang="en-US" b="0" dirty="0" err="1">
+                <a:solidFill>
+                  <a:srgbClr val="000000"/>
+                </a:solidFill>
+                <a:effectLst/>
+                <a:latin typeface="Menlo" panose="020B0609030804020204" pitchFamily="49" charset="0"/>
+              </a:rPr>
+              <a:t>a.out</a:t>
+            </a:r>
+            <a:r>
+              <a:rPr lang="en-US" b="0" dirty="0">
+                <a:solidFill>
+                  <a:srgbClr val="000000"/>
+                </a:solidFill>
+                <a:effectLst/>
+                <a:latin typeface="Menlo" panose="020B0609030804020204" pitchFamily="49" charset="0"/>
+              </a:rPr>
+              <a:t> </a:t>
+            </a:r>
+          </a:p>
+          <a:p>
+            <a:r>
+              <a:rPr lang="en-US" b="0" dirty="0">
+                <a:solidFill>
+                  <a:srgbClr val="000000"/>
+                </a:solidFill>
+                <a:effectLst/>
+                <a:latin typeface="Menlo" panose="020B0609030804020204" pitchFamily="49" charset="0"/>
+              </a:rPr>
+              <a:t>Running 1 test case...</a:t>
+            </a:r>
+          </a:p>
+          <a:p>
+            <a:r>
+              <a:rPr lang="en-US" b="0" dirty="0" err="1">
+                <a:solidFill>
+                  <a:srgbClr val="000000"/>
+                </a:solidFill>
+                <a:effectLst/>
+                <a:latin typeface="Menlo" panose="020B0609030804020204" pitchFamily="49" charset="0"/>
+              </a:rPr>
+              <a:t>test_file.cpp</a:t>
+            </a:r>
+            <a:r>
+              <a:rPr lang="en-US" b="0" dirty="0">
+                <a:solidFill>
+                  <a:srgbClr val="000000"/>
+                </a:solidFill>
+                <a:effectLst/>
+                <a:latin typeface="Menlo" panose="020B0609030804020204" pitchFamily="49" charset="0"/>
+              </a:rPr>
+              <a:t>(8): error: </a:t>
+            </a:r>
+            <a:r>
+              <a:rPr lang="en-US" b="0" dirty="0">
+                <a:solidFill>
+                  <a:srgbClr val="0000FF"/>
+                </a:solidFill>
+                <a:effectLst/>
+                <a:latin typeface="Menlo" panose="020B0609030804020204" pitchFamily="49" charset="0"/>
+              </a:rPr>
+              <a:t>in</a:t>
+            </a:r>
+            <a:r>
+              <a:rPr lang="en-US" b="0" dirty="0">
+                <a:solidFill>
+                  <a:srgbClr val="000000"/>
+                </a:solidFill>
+                <a:effectLst/>
+                <a:latin typeface="Menlo" panose="020B0609030804020204" pitchFamily="49" charset="0"/>
+              </a:rPr>
+              <a:t> </a:t>
+            </a:r>
+            <a:r>
+              <a:rPr lang="en-US" b="0" dirty="0">
+                <a:solidFill>
+                  <a:srgbClr val="A31515"/>
+                </a:solidFill>
+                <a:effectLst/>
+                <a:latin typeface="Menlo" panose="020B0609030804020204" pitchFamily="49" charset="0"/>
+              </a:rPr>
+              <a:t>"</a:t>
+            </a:r>
+            <a:r>
+              <a:rPr lang="en-US" b="0" dirty="0" err="1">
+                <a:solidFill>
+                  <a:srgbClr val="A31515"/>
+                </a:solidFill>
+                <a:effectLst/>
+                <a:latin typeface="Menlo" panose="020B0609030804020204" pitchFamily="49" charset="0"/>
+              </a:rPr>
+              <a:t>first_test</a:t>
+            </a:r>
+            <a:r>
+              <a:rPr lang="en-US" b="0" dirty="0">
+                <a:solidFill>
+                  <a:srgbClr val="A31515"/>
+                </a:solidFill>
+                <a:effectLst/>
+                <a:latin typeface="Menlo" panose="020B0609030804020204" pitchFamily="49" charset="0"/>
+              </a:rPr>
+              <a:t>"</a:t>
+            </a:r>
+            <a:r>
+              <a:rPr lang="en-US" b="0" dirty="0">
+                <a:solidFill>
+                  <a:srgbClr val="000000"/>
+                </a:solidFill>
+                <a:effectLst/>
+                <a:latin typeface="Menlo" panose="020B0609030804020204" pitchFamily="49" charset="0"/>
+              </a:rPr>
+              <a:t>: check </a:t>
+            </a:r>
+            <a:r>
+              <a:rPr lang="en-US" b="0" dirty="0" err="1">
+                <a:solidFill>
+                  <a:srgbClr val="000000"/>
+                </a:solidFill>
+                <a:effectLst/>
+                <a:latin typeface="Menlo" panose="020B0609030804020204" pitchFamily="49" charset="0"/>
+              </a:rPr>
+              <a:t>i</a:t>
+            </a:r>
+            <a:r>
+              <a:rPr lang="en-US" b="0" dirty="0">
+                <a:solidFill>
+                  <a:srgbClr val="000000"/>
+                </a:solidFill>
+                <a:effectLst/>
+                <a:latin typeface="Menlo" panose="020B0609030804020204" pitchFamily="49" charset="0"/>
+              </a:rPr>
+              <a:t> == 2 has failed [1 != 2]</a:t>
+            </a:r>
+          </a:p>
+          <a:p>
+            <a:br>
+              <a:rPr lang="en-US" b="0" dirty="0">
+                <a:solidFill>
+                  <a:srgbClr val="000000"/>
+                </a:solidFill>
+                <a:effectLst/>
+                <a:latin typeface="Menlo" panose="020B0609030804020204" pitchFamily="49" charset="0"/>
+              </a:rPr>
+            </a:br>
+            <a:r>
+              <a:rPr lang="en-US" b="0" dirty="0">
+                <a:solidFill>
+                  <a:srgbClr val="000000"/>
+                </a:solidFill>
+                <a:effectLst/>
+                <a:latin typeface="Menlo" panose="020B0609030804020204" pitchFamily="49" charset="0"/>
+              </a:rPr>
+              <a:t>*** 1 failure is detected </a:t>
+            </a:r>
+            <a:r>
+              <a:rPr lang="en-US" b="0" dirty="0">
+                <a:solidFill>
+                  <a:srgbClr val="0000FF"/>
+                </a:solidFill>
+                <a:effectLst/>
+                <a:latin typeface="Menlo" panose="020B0609030804020204" pitchFamily="49" charset="0"/>
+              </a:rPr>
+              <a:t>in</a:t>
+            </a:r>
+            <a:r>
+              <a:rPr lang="en-US" b="0" dirty="0">
+                <a:solidFill>
+                  <a:srgbClr val="000000"/>
+                </a:solidFill>
+                <a:effectLst/>
+                <a:latin typeface="Menlo" panose="020B0609030804020204" pitchFamily="49" charset="0"/>
+              </a:rPr>
+              <a:t> the test module </a:t>
+            </a:r>
+            <a:r>
+              <a:rPr lang="en-US" b="0" dirty="0">
+                <a:solidFill>
+                  <a:srgbClr val="A31515"/>
+                </a:solidFill>
+                <a:effectLst/>
+                <a:latin typeface="Menlo" panose="020B0609030804020204" pitchFamily="49" charset="0"/>
+              </a:rPr>
+              <a:t>"My Test"</a:t>
+            </a:r>
+            <a:r>
+              <a:rPr lang="en-US" b="0" dirty="0">
+                <a:solidFill>
+                  <a:srgbClr val="000000"/>
+                </a:solidFill>
+                <a:effectLst/>
+                <a:latin typeface="Menlo" panose="020B0609030804020204" pitchFamily="49" charset="0"/>
+              </a:rPr>
+              <a:t> </a:t>
+            </a:r>
+          </a:p>
+          <a:p>
+            <a:endParaRPr lang="en-US" dirty="0"/>
           </a:p>
         </p:txBody>
       </p:sp>
     </p:spTree>
     <p:extLst>
       <p:ext uri="{BB962C8B-B14F-4D97-AF65-F5344CB8AC3E}">
-        <p14:creationId xmlns:p14="http://schemas.microsoft.com/office/powerpoint/2010/main" val="3767648746"/>
+        <p14:creationId xmlns:p14="http://schemas.microsoft.com/office/powerpoint/2010/main" val="404222977"/>
       </p:ext>
     </p:extLst>
   </p:cSld>
@@ -16222,6 +16659,128 @@
           <p:cNvPr id="2" name="Title 1">
             <a:extLst>
               <a:ext uri="{FF2B5EF4-FFF2-40B4-BE49-F238E27FC236}">
+                <a16:creationId xmlns:a16="http://schemas.microsoft.com/office/drawing/2014/main" id="{F0323625-6E9D-8BD6-EF2A-3D3A89B4035B}"/>
+              </a:ext>
+            </a:extLst>
+          </p:cNvPr>
+          <p:cNvSpPr>
+            <a:spLocks noGrp="1"/>
+          </p:cNvSpPr>
+          <p:nvPr>
+            <p:ph type="title"/>
+          </p:nvPr>
+        </p:nvSpPr>
+        <p:spPr/>
+        <p:txBody>
+          <a:bodyPr/>
+          <a:lstStyle/>
+          <a:p>
+            <a:r>
+              <a:rPr lang="en-US" dirty="0"/>
+              <a:t>TDD – Test Driven Design</a:t>
+            </a:r>
+          </a:p>
+        </p:txBody>
+      </p:sp>
+      <p:sp>
+        <p:nvSpPr>
+          <p:cNvPr id="3" name="Content Placeholder 2">
+            <a:extLst>
+              <a:ext uri="{FF2B5EF4-FFF2-40B4-BE49-F238E27FC236}">
+                <a16:creationId xmlns:a16="http://schemas.microsoft.com/office/drawing/2014/main" id="{2DD885AA-8633-4B1D-638C-C27E92A8A907}"/>
+              </a:ext>
+            </a:extLst>
+          </p:cNvPr>
+          <p:cNvSpPr>
+            <a:spLocks noGrp="1"/>
+          </p:cNvSpPr>
+          <p:nvPr>
+            <p:ph idx="1"/>
+          </p:nvPr>
+        </p:nvSpPr>
+        <p:spPr/>
+        <p:txBody>
+          <a:bodyPr/>
+          <a:lstStyle/>
+          <a:p>
+            <a:pPr marL="0" indent="0">
+              <a:buNone/>
+            </a:pPr>
+            <a:r>
+              <a:rPr lang="en-US" dirty="0"/>
+              <a:t>Refers to the practice of writing test BEFORE you write code.</a:t>
+            </a:r>
+          </a:p>
+          <a:p>
+            <a:pPr marL="0" indent="0">
+              <a:buNone/>
+            </a:pPr>
+            <a:endParaRPr lang="en-US" dirty="0"/>
+          </a:p>
+          <a:p>
+            <a:pPr marL="0" indent="0">
+              <a:buNone/>
+            </a:pPr>
+            <a:r>
+              <a:rPr lang="en-US" dirty="0"/>
+              <a:t>Benefits:</a:t>
+            </a:r>
+          </a:p>
+          <a:p>
+            <a:r>
+              <a:rPr lang="en-US" dirty="0"/>
+              <a:t>Writing tests first helps you understand the specification.</a:t>
+            </a:r>
+          </a:p>
+          <a:p>
+            <a:r>
+              <a:rPr lang="en-US" dirty="0"/>
+              <a:t>Writing test to reproduce a bug proves it is fixed by the change.</a:t>
+            </a:r>
+          </a:p>
+          <a:p>
+            <a:r>
+              <a:rPr lang="en-US" dirty="0"/>
+              <a:t>Running tests as you develop lets you fix bugs early (is faster).</a:t>
+            </a:r>
+          </a:p>
+        </p:txBody>
+      </p:sp>
+    </p:spTree>
+    <p:extLst>
+      <p:ext uri="{BB962C8B-B14F-4D97-AF65-F5344CB8AC3E}">
+        <p14:creationId xmlns:p14="http://schemas.microsoft.com/office/powerpoint/2010/main" val="3767648746"/>
+      </p:ext>
+    </p:extLst>
+  </p:cSld>
+  <p:clrMapOvr>
+    <a:masterClrMapping/>
+  </p:clrMapOvr>
+</p:sld>
+</file>
+
+<file path=ppt/slides/slide27.xml><?xml version="1.0" encoding="utf-8"?>
+<p:sld xmlns:a="http://schemas.openxmlformats.org/drawingml/2006/main" xmlns:r="http://schemas.openxmlformats.org/officeDocument/2006/relationships" xmlns:p="http://schemas.openxmlformats.org/presentationml/2006/main">
+  <p:cSld>
+    <p:spTree>
+      <p:nvGrpSpPr>
+        <p:cNvPr id="1" name=""/>
+        <p:cNvGrpSpPr/>
+        <p:nvPr/>
+      </p:nvGrpSpPr>
+      <p:grpSpPr>
+        <a:xfrm>
+          <a:off x="0" y="0"/>
+          <a:ext cx="0" cy="0"/>
+          <a:chOff x="0" y="0"/>
+          <a:chExt cx="0" cy="0"/>
+        </a:xfrm>
+      </p:grpSpPr>
+      <p:sp>
+        <p:nvSpPr>
+          <p:cNvPr id="2" name="Title 1">
+            <a:extLst>
+              <a:ext uri="{FF2B5EF4-FFF2-40B4-BE49-F238E27FC236}">
                 <a16:creationId xmlns:a16="http://schemas.microsoft.com/office/drawing/2014/main" id="{0584A545-6FA8-C91A-FCC4-AAB0B775D43F}"/>
               </a:ext>
             </a:extLst>
@@ -16357,7 +16916,7 @@
 </p:sld>
 </file>
 
-<file path=ppt/slides/slide27.xml><?xml version="1.0" encoding="utf-8"?>
+<file path=ppt/slides/slide28.xml><?xml version="1.0" encoding="utf-8"?>
 <p:sld xmlns:a="http://schemas.openxmlformats.org/drawingml/2006/main" xmlns:r="http://schemas.openxmlformats.org/officeDocument/2006/relationships" xmlns:p="http://schemas.openxmlformats.org/presentationml/2006/main">
   <p:cSld>
     <p:spTree>
@@ -16671,6 +17230,161 @@
 </file>
 
 <file path=ppt/slides/slide4.xml><?xml version="1.0" encoding="utf-8"?>
+<p:sld xmlns:a="http://schemas.openxmlformats.org/drawingml/2006/main" xmlns:r="http://schemas.openxmlformats.org/officeDocument/2006/relationships" xmlns:p="http://schemas.openxmlformats.org/presentationml/2006/main">
+  <p:cSld>
+    <p:spTree>
+      <p:nvGrpSpPr>
+        <p:cNvPr id="1" name=""/>
+        <p:cNvGrpSpPr/>
+        <p:nvPr/>
+      </p:nvGrpSpPr>
+      <p:grpSpPr>
+        <a:xfrm>
+          <a:off x="0" y="0"/>
+          <a:ext cx="0" cy="0"/>
+          <a:chOff x="0" y="0"/>
+          <a:chExt cx="0" cy="0"/>
+        </a:xfrm>
+      </p:grpSpPr>
+      <p:sp>
+        <p:nvSpPr>
+          <p:cNvPr id="2" name="Title 1">
+            <a:extLst>
+              <a:ext uri="{FF2B5EF4-FFF2-40B4-BE49-F238E27FC236}">
+                <a16:creationId xmlns:a16="http://schemas.microsoft.com/office/drawing/2014/main" id="{3B063437-88CB-AD02-6894-6F2F93DD6249}"/>
+              </a:ext>
+            </a:extLst>
+          </p:cNvPr>
+          <p:cNvSpPr>
+            <a:spLocks noGrp="1"/>
+          </p:cNvSpPr>
+          <p:nvPr>
+            <p:ph type="title"/>
+          </p:nvPr>
+        </p:nvSpPr>
+        <p:spPr/>
+        <p:txBody>
+          <a:bodyPr/>
+          <a:lstStyle/>
+          <a:p>
+            <a:r>
+              <a:rPr lang="en-US" dirty="0"/>
+              <a:t>Software Engineering</a:t>
+            </a:r>
+          </a:p>
+        </p:txBody>
+      </p:sp>
+      <p:sp>
+        <p:nvSpPr>
+          <p:cNvPr id="3" name="Content Placeholder 2">
+            <a:extLst>
+              <a:ext uri="{FF2B5EF4-FFF2-40B4-BE49-F238E27FC236}">
+                <a16:creationId xmlns:a16="http://schemas.microsoft.com/office/drawing/2014/main" id="{1BD13937-0BEA-91AF-4D54-AD048D3F2AE3}"/>
+              </a:ext>
+            </a:extLst>
+          </p:cNvPr>
+          <p:cNvSpPr>
+            <a:spLocks noGrp="1"/>
+          </p:cNvSpPr>
+          <p:nvPr>
+            <p:ph idx="1"/>
+          </p:nvPr>
+        </p:nvSpPr>
+        <p:spPr/>
+        <p:txBody>
+          <a:bodyPr>
+            <a:normAutofit lnSpcReduction="10000"/>
+          </a:bodyPr>
+          <a:lstStyle/>
+          <a:p>
+            <a:pPr marL="0" indent="0">
+              <a:buNone/>
+            </a:pPr>
+            <a:r>
+              <a:rPr lang="en-US" dirty="0"/>
+              <a:t>Difference between Software Engineering and Plain Development</a:t>
+            </a:r>
+          </a:p>
+          <a:p>
+            <a:pPr marL="0" indent="0">
+              <a:buNone/>
+            </a:pPr>
+            <a:endParaRPr lang="en-US" dirty="0"/>
+          </a:p>
+          <a:p>
+            <a:pPr marL="0" indent="0">
+              <a:buNone/>
+            </a:pPr>
+            <a:r>
+              <a:rPr lang="en-US" dirty="0"/>
+              <a:t>Process:</a:t>
+            </a:r>
+          </a:p>
+          <a:p>
+            <a:pPr lvl="1"/>
+            <a:r>
+              <a:rPr lang="en-US" dirty="0"/>
+              <a:t>Version Control (e.g. GIT)</a:t>
+            </a:r>
+          </a:p>
+          <a:p>
+            <a:pPr lvl="1"/>
+            <a:r>
+              <a:rPr lang="en-US" dirty="0"/>
+              <a:t>Software Design (modularity, repeatability, non-functional properties)</a:t>
+            </a:r>
+          </a:p>
+          <a:p>
+            <a:pPr lvl="1"/>
+            <a:r>
+              <a:rPr lang="en-US" dirty="0"/>
+              <a:t>Specifications and Requirements</a:t>
+            </a:r>
+          </a:p>
+          <a:p>
+            <a:pPr lvl="1"/>
+            <a:r>
+              <a:rPr lang="en-US" dirty="0"/>
+              <a:t>Naming and Coding Conventions (static analysis)</a:t>
+            </a:r>
+          </a:p>
+          <a:p>
+            <a:pPr lvl="1"/>
+            <a:r>
+              <a:rPr lang="en-US" dirty="0"/>
+              <a:t>Task and Defect Tracking</a:t>
+            </a:r>
+          </a:p>
+          <a:p>
+            <a:pPr lvl="1"/>
+            <a:r>
+              <a:rPr lang="en-US" dirty="0"/>
+              <a:t>Automation (e.g. continuous integration)</a:t>
+            </a:r>
+          </a:p>
+          <a:p>
+            <a:pPr lvl="1"/>
+            <a:r>
+              <a:rPr lang="en-US" dirty="0"/>
+              <a:t>Testing (especially unit testing)</a:t>
+            </a:r>
+          </a:p>
+        </p:txBody>
+      </p:sp>
+    </p:spTree>
+    <p:extLst>
+      <p:ext uri="{BB962C8B-B14F-4D97-AF65-F5344CB8AC3E}">
+        <p14:creationId xmlns:p14="http://schemas.microsoft.com/office/powerpoint/2010/main" val="2310388860"/>
+      </p:ext>
+    </p:extLst>
+  </p:cSld>
+  <p:clrMapOvr>
+    <a:masterClrMapping/>
+  </p:clrMapOvr>
+</p:sld>
+</file>
+
+<file path=ppt/slides/slide5.xml><?xml version="1.0" encoding="utf-8"?>
 <p:sld xmlns:a="http://schemas.openxmlformats.org/drawingml/2006/main" xmlns:r="http://schemas.openxmlformats.org/officeDocument/2006/relationships" xmlns:p="http://schemas.openxmlformats.org/presentationml/2006/main">
   <p:cSld>
     <p:spTree>
@@ -17226,7 +17940,7 @@
 </p:sld>
 </file>
 
-<file path=ppt/slides/slide5.xml><?xml version="1.0" encoding="utf-8"?>
+<file path=ppt/slides/slide6.xml><?xml version="1.0" encoding="utf-8"?>
 <p:sld xmlns:a="http://schemas.openxmlformats.org/drawingml/2006/main" xmlns:r="http://schemas.openxmlformats.org/officeDocument/2006/relationships" xmlns:p="http://schemas.openxmlformats.org/presentationml/2006/main">
   <p:cSld>
     <p:spTree>
@@ -17315,7 +18029,7 @@
             <a:pPr lvl="1"/>
             <a:r>
               <a:rPr lang="en-US" sz="2900" dirty="0"/>
-              <a:t>The Sceptic</a:t>
+              <a:t>The Skeptic</a:t>
             </a:r>
             <a:br>
               <a:rPr lang="en-US" sz="2900" dirty="0"/>
@@ -17389,7 +18103,7 @@
 </p:sld>
 </file>
 
-<file path=ppt/slides/slide6.xml><?xml version="1.0" encoding="utf-8"?>
+<file path=ppt/slides/slide7.xml><?xml version="1.0" encoding="utf-8"?>
 <p:sld xmlns:a="http://schemas.openxmlformats.org/drawingml/2006/main" xmlns:r="http://schemas.openxmlformats.org/officeDocument/2006/relationships" xmlns:p="http://schemas.openxmlformats.org/presentationml/2006/main">
   <p:cSld>
     <p:spTree>
@@ -17898,7 +18612,7 @@
 </p:sld>
 </file>
 
-<file path=ppt/slides/slide7.xml><?xml version="1.0" encoding="utf-8"?>
+<file path=ppt/slides/slide8.xml><?xml version="1.0" encoding="utf-8"?>
 <p:sld xmlns:a="http://schemas.openxmlformats.org/drawingml/2006/main" xmlns:r="http://schemas.openxmlformats.org/officeDocument/2006/relationships" xmlns:p="http://schemas.openxmlformats.org/presentationml/2006/main">
   <p:cSld>
     <p:spTree>
@@ -18028,7 +18742,7 @@
 </p:sld>
 </file>
 
-<file path=ppt/slides/slide8.xml><?xml version="1.0" encoding="utf-8"?>
+<file path=ppt/slides/slide9.xml><?xml version="1.0" encoding="utf-8"?>
 <p:sld xmlns:a="http://schemas.openxmlformats.org/drawingml/2006/main" xmlns:r="http://schemas.openxmlformats.org/officeDocument/2006/relationships" xmlns:p="http://schemas.openxmlformats.org/presentationml/2006/main">
   <p:cSld>
     <p:spTree>
@@ -18363,546 +19077,6 @@
                                           <p:spTgt spid="3">
                                             <p:txEl>
                                               <p:pRg st="6" end="6"/>
-                                            </p:txEl>
-                                          </p:spTgt>
-                                        </p:tgtEl>
-                                        <p:attrNameLst>
-                                          <p:attrName>style.visibility</p:attrName>
-                                        </p:attrNameLst>
-                                      </p:cBhvr>
-                                      <p:to>
-                                        <p:strVal val="visible"/>
-                                      </p:to>
-                                    </p:set>
-                                  </p:childTnLst>
-                                </p:cTn>
-                              </p:par>
-                            </p:childTnLst>
-                          </p:cTn>
-                        </p:par>
-                      </p:childTnLst>
-                    </p:cTn>
-                  </p:par>
-                </p:childTnLst>
-              </p:cTn>
-              <p:prevCondLst>
-                <p:cond evt="onPrev" delay="0">
-                  <p:tgtEl>
-                    <p:sldTgt/>
-                  </p:tgtEl>
-                </p:cond>
-              </p:prevCondLst>
-              <p:nextCondLst>
-                <p:cond evt="onNext" delay="0">
-                  <p:tgtEl>
-                    <p:sldTgt/>
-                  </p:tgtEl>
-                </p:cond>
-              </p:nextCondLst>
-            </p:seq>
-          </p:childTnLst>
-        </p:cTn>
-      </p:par>
-    </p:tnLst>
-  </p:timing>
-</p:sld>
-</file>
-
-<file path=ppt/slides/slide9.xml><?xml version="1.0" encoding="utf-8"?>
-<p:sld xmlns:a="http://schemas.openxmlformats.org/drawingml/2006/main" xmlns:r="http://schemas.openxmlformats.org/officeDocument/2006/relationships" xmlns:p="http://schemas.openxmlformats.org/presentationml/2006/main">
-  <p:cSld>
-    <p:spTree>
-      <p:nvGrpSpPr>
-        <p:cNvPr id="1" name=""/>
-        <p:cNvGrpSpPr/>
-        <p:nvPr/>
-      </p:nvGrpSpPr>
-      <p:grpSpPr>
-        <a:xfrm>
-          <a:off x="0" y="0"/>
-          <a:ext cx="0" cy="0"/>
-          <a:chOff x="0" y="0"/>
-          <a:chExt cx="0" cy="0"/>
-        </a:xfrm>
-      </p:grpSpPr>
-      <p:sp>
-        <p:nvSpPr>
-          <p:cNvPr id="2" name="Title 1">
-            <a:extLst>
-              <a:ext uri="{FF2B5EF4-FFF2-40B4-BE49-F238E27FC236}">
-                <a16:creationId xmlns:a16="http://schemas.microsoft.com/office/drawing/2014/main" id="{7B1BC8CA-23DC-00F6-9485-97991DED6A35}"/>
-              </a:ext>
-            </a:extLst>
-          </p:cNvPr>
-          <p:cNvSpPr>
-            <a:spLocks noGrp="1"/>
-          </p:cNvSpPr>
-          <p:nvPr>
-            <p:ph type="title"/>
-          </p:nvPr>
-        </p:nvSpPr>
-        <p:spPr/>
-        <p:txBody>
-          <a:bodyPr/>
-          <a:lstStyle/>
-          <a:p>
-            <a:r>
-              <a:rPr lang="en-US" dirty="0"/>
-              <a:t>02 </a:t>
-            </a:r>
-            <a:r>
-              <a:rPr lang="en-US" dirty="0" err="1"/>
-              <a:t>PyTest</a:t>
-            </a:r>
-            <a:endParaRPr lang="en-US" dirty="0"/>
-          </a:p>
-        </p:txBody>
-      </p:sp>
-      <p:sp>
-        <p:nvSpPr>
-          <p:cNvPr id="3" name="Content Placeholder 2">
-            <a:extLst>
-              <a:ext uri="{FF2B5EF4-FFF2-40B4-BE49-F238E27FC236}">
-                <a16:creationId xmlns:a16="http://schemas.microsoft.com/office/drawing/2014/main" id="{D133F77E-93E8-297B-19D0-2CEFDBCB06FD}"/>
-              </a:ext>
-            </a:extLst>
-          </p:cNvPr>
-          <p:cNvSpPr>
-            <a:spLocks noGrp="1"/>
-          </p:cNvSpPr>
-          <p:nvPr>
-            <p:ph idx="1"/>
-          </p:nvPr>
-        </p:nvSpPr>
-        <p:spPr>
-          <a:xfrm>
-            <a:off x="680321" y="2184472"/>
-            <a:ext cx="10402718" cy="4673528"/>
-          </a:xfrm>
-        </p:spPr>
-        <p:txBody>
-          <a:bodyPr>
-            <a:normAutofit/>
-          </a:bodyPr>
-          <a:lstStyle/>
-          <a:p>
-            <a:pPr marL="0" indent="0">
-              <a:buNone/>
-            </a:pPr>
-            <a:r>
-              <a:rPr lang="en-US" dirty="0"/>
-              <a:t>Requires “pip install </a:t>
-            </a:r>
-            <a:r>
-              <a:rPr lang="en-US" dirty="0" err="1"/>
-              <a:t>pytest</a:t>
-            </a:r>
-            <a:r>
-              <a:rPr lang="en-US" dirty="0"/>
-              <a:t>”</a:t>
-            </a:r>
-          </a:p>
-          <a:p>
-            <a:pPr marL="0" indent="0">
-              <a:buNone/>
-            </a:pPr>
-            <a:r>
-              <a:rPr lang="en-US" dirty="0"/>
-              <a:t>(See example 02_pytest/examples/</a:t>
-            </a:r>
-            <a:r>
-              <a:rPr lang="en-US" dirty="0" err="1"/>
-              <a:t>test_geometric_area.py</a:t>
-            </a:r>
-            <a:r>
-              <a:rPr lang="en-US" dirty="0"/>
-              <a:t>)</a:t>
-            </a:r>
-          </a:p>
-          <a:p>
-            <a:pPr marL="0" indent="0">
-              <a:buNone/>
-            </a:pPr>
-            <a:br>
-              <a:rPr lang="en-US" dirty="0"/>
-            </a:br>
-            <a:endParaRPr lang="en-US" dirty="0"/>
-          </a:p>
-          <a:p>
-            <a:endParaRPr lang="en-US" dirty="0"/>
-          </a:p>
-          <a:p>
-            <a:endParaRPr lang="en-US" dirty="0"/>
-          </a:p>
-          <a:p>
-            <a:endParaRPr lang="en-US" dirty="0"/>
-          </a:p>
-          <a:p>
-            <a:endParaRPr lang="en-US" dirty="0"/>
-          </a:p>
-          <a:p>
-            <a:r>
-              <a:rPr lang="en-US" dirty="0"/>
-              <a:t>Execute with </a:t>
-            </a:r>
-            <a:r>
-              <a:rPr lang="en-US" dirty="0" err="1"/>
-              <a:t>pytest</a:t>
-            </a:r>
-            <a:r>
-              <a:rPr lang="en-US" dirty="0"/>
-              <a:t> command (in directory 02_pytest/examples):</a:t>
-            </a:r>
-          </a:p>
-          <a:p>
-            <a:pPr marL="457200" lvl="1" indent="0">
-              <a:buNone/>
-            </a:pPr>
-            <a:r>
-              <a:rPr lang="en-US" dirty="0"/>
-              <a:t>  </a:t>
-            </a:r>
-            <a:r>
-              <a:rPr lang="en-US" sz="2400" dirty="0" err="1"/>
-              <a:t>pytest</a:t>
-            </a:r>
-            <a:r>
-              <a:rPr lang="en-US" sz="2400" dirty="0"/>
-              <a:t> </a:t>
-            </a:r>
-            <a:r>
-              <a:rPr lang="en-US" sz="2400" dirty="0" err="1"/>
-              <a:t>test_geometric_area.py</a:t>
-            </a:r>
-            <a:endParaRPr lang="en-US" sz="2400" dirty="0"/>
-          </a:p>
-        </p:txBody>
-      </p:sp>
-      <p:sp>
-        <p:nvSpPr>
-          <p:cNvPr id="4" name="TextBox 3">
-            <a:extLst>
-              <a:ext uri="{FF2B5EF4-FFF2-40B4-BE49-F238E27FC236}">
-                <a16:creationId xmlns:a16="http://schemas.microsoft.com/office/drawing/2014/main" id="{E07ED173-C2F9-18B9-8090-CCB1DFE7FA10}"/>
-              </a:ext>
-            </a:extLst>
-          </p:cNvPr>
-          <p:cNvSpPr txBox="1"/>
-          <p:nvPr/>
-        </p:nvSpPr>
-        <p:spPr>
-          <a:xfrm>
-            <a:off x="1469178" y="3323915"/>
-            <a:ext cx="9613861" cy="2677656"/>
-          </a:xfrm>
-          <a:prstGeom prst="rect">
-            <a:avLst/>
-          </a:prstGeom>
-          <a:noFill/>
-        </p:spPr>
-        <p:txBody>
-          <a:bodyPr wrap="square" rtlCol="0">
-            <a:spAutoFit/>
-          </a:bodyPr>
-          <a:lstStyle/>
-          <a:p>
-            <a:pPr marL="0" indent="0">
-              <a:buNone/>
-            </a:pPr>
-            <a:r>
-              <a:rPr lang="en-US" sz="2400" dirty="0">
-                <a:latin typeface="Courier" pitchFamily="2" charset="0"/>
-              </a:rPr>
-              <a:t>import math</a:t>
-            </a:r>
-          </a:p>
-          <a:p>
-            <a:pPr marL="0" indent="0">
-              <a:buNone/>
-            </a:pPr>
-            <a:r>
-              <a:rPr lang="en-US" sz="2400" dirty="0">
-                <a:latin typeface="Courier" pitchFamily="2" charset="0"/>
-              </a:rPr>
-              <a:t>import </a:t>
-            </a:r>
-            <a:r>
-              <a:rPr lang="en-US" sz="2400" dirty="0" err="1">
-                <a:latin typeface="Courier" pitchFamily="2" charset="0"/>
-              </a:rPr>
-              <a:t>geometric_area</a:t>
-            </a:r>
-            <a:endParaRPr lang="en-US" sz="2400" dirty="0">
-              <a:latin typeface="Courier" pitchFamily="2" charset="0"/>
-            </a:endParaRPr>
-          </a:p>
-          <a:p>
-            <a:pPr marL="0" indent="0">
-              <a:buNone/>
-            </a:pPr>
-            <a:endParaRPr lang="en-US" sz="2400" dirty="0">
-              <a:latin typeface="Courier" pitchFamily="2" charset="0"/>
-            </a:endParaRPr>
-          </a:p>
-          <a:p>
-            <a:pPr marL="0" indent="0">
-              <a:buNone/>
-            </a:pPr>
-            <a:r>
-              <a:rPr lang="en-US" sz="2400" dirty="0">
-                <a:latin typeface="Courier" pitchFamily="2" charset="0"/>
-              </a:rPr>
-              <a:t>def </a:t>
-            </a:r>
-            <a:r>
-              <a:rPr lang="en-US" sz="2400" dirty="0" err="1">
-                <a:latin typeface="Courier" pitchFamily="2" charset="0"/>
-              </a:rPr>
-              <a:t>test_area</a:t>
-            </a:r>
-            <a:r>
-              <a:rPr lang="en-US" sz="2400" dirty="0">
-                <a:latin typeface="Courier" pitchFamily="2" charset="0"/>
-              </a:rPr>
-              <a:t>():</a:t>
-            </a:r>
-          </a:p>
-          <a:p>
-            <a:pPr marL="0" indent="0">
-              <a:buNone/>
-            </a:pPr>
-            <a:r>
-              <a:rPr lang="en-US" sz="2400" dirty="0">
-                <a:latin typeface="Courier" pitchFamily="2" charset="0"/>
-              </a:rPr>
-              <a:t>	assert </a:t>
-            </a:r>
-            <a:r>
-              <a:rPr lang="en-US" sz="2400" dirty="0" err="1">
-                <a:latin typeface="Courier" pitchFamily="2" charset="0"/>
-              </a:rPr>
-              <a:t>geometric_area.circle_area</a:t>
-            </a:r>
-            <a:r>
-              <a:rPr lang="en-US" sz="2400" dirty="0">
-                <a:latin typeface="Courier" pitchFamily="2" charset="0"/>
-              </a:rPr>
-              <a:t>(1) = </a:t>
-            </a:r>
-            <a:r>
-              <a:rPr lang="en-US" sz="2400" dirty="0" err="1">
-                <a:latin typeface="Courier" pitchFamily="2" charset="0"/>
-              </a:rPr>
-              <a:t>math.pi</a:t>
-            </a:r>
-            <a:endParaRPr lang="en-US" sz="2400" dirty="0">
-              <a:latin typeface="Courier" pitchFamily="2" charset="0"/>
-            </a:endParaRPr>
-          </a:p>
-          <a:p>
-            <a:r>
-              <a:rPr lang="en-US" sz="2400" dirty="0">
-                <a:latin typeface="Courier" pitchFamily="2" charset="0"/>
-              </a:rPr>
-              <a:t>	assert </a:t>
-            </a:r>
-            <a:r>
-              <a:rPr lang="en-US" sz="2400" dirty="0" err="1">
-                <a:latin typeface="Courier" pitchFamily="2" charset="0"/>
-              </a:rPr>
-              <a:t>geometric_area.circle_area</a:t>
-            </a:r>
-            <a:r>
-              <a:rPr lang="en-US" sz="2400" dirty="0">
-                <a:latin typeface="Courier" pitchFamily="2" charset="0"/>
-              </a:rPr>
-              <a:t>(0) = 0</a:t>
-            </a:r>
-            <a:br>
-              <a:rPr lang="en-US" sz="2400" dirty="0">
-                <a:latin typeface="Courier" pitchFamily="2" charset="0"/>
-              </a:rPr>
-            </a:br>
-            <a:endParaRPr lang="en-US" sz="2400" dirty="0">
-              <a:latin typeface="Courier" pitchFamily="2" charset="0"/>
-            </a:endParaRPr>
-          </a:p>
-        </p:txBody>
-      </p:sp>
-    </p:spTree>
-    <p:extLst>
-      <p:ext uri="{BB962C8B-B14F-4D97-AF65-F5344CB8AC3E}">
-        <p14:creationId xmlns:p14="http://schemas.microsoft.com/office/powerpoint/2010/main" val="376151755"/>
-      </p:ext>
-    </p:extLst>
-  </p:cSld>
-  <p:clrMapOvr>
-    <a:masterClrMapping/>
-  </p:clrMapOvr>
-  <p:timing>
-    <p:tnLst>
-      <p:par>
-        <p:cTn id="1" dur="indefinite" restart="never" nodeType="tmRoot">
-          <p:childTnLst>
-            <p:seq concurrent="1" nextAc="seek">
-              <p:cTn id="2" dur="indefinite" nodeType="mainSeq">
-                <p:childTnLst>
-                  <p:par>
-                    <p:cTn id="3" fill="hold">
-                      <p:stCondLst>
-                        <p:cond delay="indefinite"/>
-                        <p:cond evt="onBegin" delay="0">
-                          <p:tn val="2"/>
-                        </p:cond>
-                      </p:stCondLst>
-                      <p:childTnLst>
-                        <p:par>
-                          <p:cTn id="4" fill="hold">
-                            <p:stCondLst>
-                              <p:cond delay="0"/>
-                            </p:stCondLst>
-                            <p:childTnLst>
-                              <p:par>
-                                <p:cTn id="5" presetID="1" presetClass="entr" presetSubtype="0" fill="hold" nodeType="withEffect">
-                                  <p:stCondLst>
-                                    <p:cond delay="0"/>
-                                  </p:stCondLst>
-                                  <p:childTnLst>
-                                    <p:set>
-                                      <p:cBhvr>
-                                        <p:cTn id="6" dur="1" fill="hold">
-                                          <p:stCondLst>
-                                            <p:cond delay="0"/>
-                                          </p:stCondLst>
-                                        </p:cTn>
-                                        <p:tgtEl>
-                                          <p:spTgt spid="4">
-                                            <p:txEl>
-                                              <p:pRg st="1" end="1"/>
-                                            </p:txEl>
-                                          </p:spTgt>
-                                        </p:tgtEl>
-                                        <p:attrNameLst>
-                                          <p:attrName>style.visibility</p:attrName>
-                                        </p:attrNameLst>
-                                      </p:cBhvr>
-                                      <p:to>
-                                        <p:strVal val="visible"/>
-                                      </p:to>
-                                    </p:set>
-                                  </p:childTnLst>
-                                </p:cTn>
-                              </p:par>
-                              <p:par>
-                                <p:cTn id="7" presetID="1" presetClass="entr" presetSubtype="0" fill="hold" nodeType="withEffect">
-                                  <p:stCondLst>
-                                    <p:cond delay="0"/>
-                                  </p:stCondLst>
-                                  <p:childTnLst>
-                                    <p:set>
-                                      <p:cBhvr>
-                                        <p:cTn id="8" dur="1" fill="hold">
-                                          <p:stCondLst>
-                                            <p:cond delay="0"/>
-                                          </p:stCondLst>
-                                        </p:cTn>
-                                        <p:tgtEl>
-                                          <p:spTgt spid="4">
-                                            <p:txEl>
-                                              <p:pRg st="0" end="0"/>
-                                            </p:txEl>
-                                          </p:spTgt>
-                                        </p:tgtEl>
-                                        <p:attrNameLst>
-                                          <p:attrName>style.visibility</p:attrName>
-                                        </p:attrNameLst>
-                                      </p:cBhvr>
-                                      <p:to>
-                                        <p:strVal val="visible"/>
-                                      </p:to>
-                                    </p:set>
-                                  </p:childTnLst>
-                                </p:cTn>
-                              </p:par>
-                              <p:par>
-                                <p:cTn id="9" presetID="1" presetClass="entr" presetSubtype="0" fill="hold" nodeType="withEffect">
-                                  <p:stCondLst>
-                                    <p:cond delay="0"/>
-                                  </p:stCondLst>
-                                  <p:childTnLst>
-                                    <p:set>
-                                      <p:cBhvr>
-                                        <p:cTn id="10" dur="1" fill="hold">
-                                          <p:stCondLst>
-                                            <p:cond delay="0"/>
-                                          </p:stCondLst>
-                                        </p:cTn>
-                                        <p:tgtEl>
-                                          <p:spTgt spid="4">
-                                            <p:txEl>
-                                              <p:pRg st="3" end="3"/>
-                                            </p:txEl>
-                                          </p:spTgt>
-                                        </p:tgtEl>
-                                        <p:attrNameLst>
-                                          <p:attrName>style.visibility</p:attrName>
-                                        </p:attrNameLst>
-                                      </p:cBhvr>
-                                      <p:to>
-                                        <p:strVal val="visible"/>
-                                      </p:to>
-                                    </p:set>
-                                  </p:childTnLst>
-                                </p:cTn>
-                              </p:par>
-                              <p:par>
-                                <p:cTn id="11" presetID="1" presetClass="entr" presetSubtype="0" fill="hold" nodeType="withEffect">
-                                  <p:stCondLst>
-                                    <p:cond delay="0"/>
-                                  </p:stCondLst>
-                                  <p:childTnLst>
-                                    <p:set>
-                                      <p:cBhvr>
-                                        <p:cTn id="12" dur="1" fill="hold">
-                                          <p:stCondLst>
-                                            <p:cond delay="0"/>
-                                          </p:stCondLst>
-                                        </p:cTn>
-                                        <p:tgtEl>
-                                          <p:spTgt spid="4">
-                                            <p:txEl>
-                                              <p:pRg st="4" end="4"/>
-                                            </p:txEl>
-                                          </p:spTgt>
-                                        </p:tgtEl>
-                                        <p:attrNameLst>
-                                          <p:attrName>style.visibility</p:attrName>
-                                        </p:attrNameLst>
-                                      </p:cBhvr>
-                                      <p:to>
-                                        <p:strVal val="visible"/>
-                                      </p:to>
-                                    </p:set>
-                                  </p:childTnLst>
-                                </p:cTn>
-                              </p:par>
-                              <p:par>
-                                <p:cTn id="13" presetID="1" presetClass="entr" presetSubtype="0" fill="hold" nodeType="withEffect">
-                                  <p:stCondLst>
-                                    <p:cond delay="0"/>
-                                  </p:stCondLst>
-                                  <p:childTnLst>
-                                    <p:set>
-                                      <p:cBhvr>
-                                        <p:cTn id="14" dur="1" fill="hold">
-                                          <p:stCondLst>
-                                            <p:cond delay="0"/>
-                                          </p:stCondLst>
-                                        </p:cTn>
-                                        <p:tgtEl>
-                                          <p:spTgt spid="4">
-                                            <p:txEl>
-                                              <p:pRg st="5" end="5"/>
                                             </p:txEl>
                                           </p:spTgt>
                                         </p:tgtEl>

</xml_diff>

<commit_message>
animation for SE slide
</commit_message>
<xml_diff>
--- a/UnitTestingSlides.pptx
+++ b/UnitTestingSlides.pptx
@@ -224,7 +224,7 @@
           <a:p>
             <a:fld id="{EF6A6A60-C693-BC49-85A7-98B318EF45A1}" type="datetimeFigureOut">
               <a:rPr lang="en-US" smtClean="0"/>
-              <a:t>1/10/26</a:t>
+              <a:t>1/14/26</a:t>
             </a:fld>
             <a:endParaRPr lang="en-US"/>
           </a:p>
@@ -1451,7 +1451,7 @@
           <a:p>
             <a:fld id="{78ABE3C1-DBE1-495D-B57B-2849774B866A}" type="datetimeFigureOut">
               <a:rPr lang="en-US" dirty="0"/>
-              <a:t>1/10/26</a:t>
+              <a:t>1/14/26</a:t>
             </a:fld>
             <a:endParaRPr lang="en-US" dirty="0"/>
           </a:p>
@@ -1860,7 +1860,7 @@
           <a:p>
             <a:fld id="{446C117F-5CCF-4837-BE5F-2B92066CAFAF}" type="datetimeFigureOut">
               <a:rPr lang="en-US" dirty="0"/>
-              <a:t>1/10/26</a:t>
+              <a:t>1/14/26</a:t>
             </a:fld>
             <a:endParaRPr lang="en-US" dirty="0"/>
           </a:p>
@@ -2191,7 +2191,7 @@
           <a:p>
             <a:fld id="{84EB90BD-B6CE-46B7-997F-7313B992CCDC}" type="datetimeFigureOut">
               <a:rPr lang="en-US" dirty="0"/>
-              <a:t>1/10/26</a:t>
+              <a:t>1/14/26</a:t>
             </a:fld>
             <a:endParaRPr lang="en-US" dirty="0"/>
           </a:p>
@@ -2591,7 +2591,7 @@
           <a:p>
             <a:fld id="{CDB9D11F-B188-461D-B23F-39381795C052}" type="datetimeFigureOut">
               <a:rPr lang="en-US" dirty="0"/>
-              <a:t>1/10/26</a:t>
+              <a:t>1/14/26</a:t>
             </a:fld>
             <a:endParaRPr lang="en-US" dirty="0"/>
           </a:p>
@@ -3154,7 +3154,7 @@
           <a:p>
             <a:fld id="{52E6D8D9-55A2-4063-B0F3-121F44549695}" type="datetimeFigureOut">
               <a:rPr lang="en-US" dirty="0"/>
-              <a:t>1/10/26</a:t>
+              <a:t>1/14/26</a:t>
             </a:fld>
             <a:endParaRPr lang="en-US" dirty="0"/>
           </a:p>
@@ -3830,7 +3830,7 @@
           <a:p>
             <a:fld id="{D4B24536-994D-4021-A283-9F449C0DB509}" type="datetimeFigureOut">
               <a:rPr lang="en-US" dirty="0"/>
-              <a:t>1/10/26</a:t>
+              <a:t>1/14/26</a:t>
             </a:fld>
             <a:endParaRPr lang="en-US" dirty="0"/>
           </a:p>
@@ -4738,7 +4738,7 @@
           <a:p>
             <a:fld id="{3CBBBB78-C96F-47B7-AB17-D852CA960AC9}" type="datetimeFigureOut">
               <a:rPr lang="en-US" dirty="0"/>
-              <a:t>1/10/26</a:t>
+              <a:t>1/14/26</a:t>
             </a:fld>
             <a:endParaRPr lang="en-US" dirty="0"/>
           </a:p>
@@ -5046,7 +5046,7 @@
           <a:p>
             <a:fld id="{1FA3F48C-C7C6-4055-9F49-3777875E72AE}" type="datetimeFigureOut">
               <a:rPr lang="en-US" dirty="0"/>
-              <a:t>1/10/26</a:t>
+              <a:t>1/14/26</a:t>
             </a:fld>
             <a:endParaRPr lang="en-US" dirty="0"/>
           </a:p>
@@ -5305,7 +5305,7 @@
           <a:p>
             <a:fld id="{6178E61D-D431-422C-9764-11DAFE33AB63}" type="datetimeFigureOut">
               <a:rPr lang="en-US" dirty="0"/>
-              <a:t>1/10/26</a:t>
+              <a:t>1/14/26</a:t>
             </a:fld>
             <a:endParaRPr lang="en-US" dirty="0"/>
           </a:p>
@@ -5624,7 +5624,7 @@
           <a:p>
             <a:fld id="{12DE42F4-6EEF-4EF7-8ED4-2208F0F89A08}" type="datetimeFigureOut">
               <a:rPr lang="en-US" dirty="0"/>
-              <a:t>1/10/26</a:t>
+              <a:t>1/14/26</a:t>
             </a:fld>
             <a:endParaRPr lang="en-US" dirty="0"/>
           </a:p>
@@ -6008,7 +6008,7 @@
           <a:p>
             <a:fld id="{30578ACC-22D6-47C1-A373-4FD133E34F3C}" type="datetimeFigureOut">
               <a:rPr lang="en-US" dirty="0"/>
-              <a:t>1/10/26</a:t>
+              <a:t>1/14/26</a:t>
             </a:fld>
             <a:endParaRPr lang="en-US" dirty="0"/>
           </a:p>
@@ -6379,7 +6379,7 @@
           <a:p>
             <a:fld id="{4E5A6C69-6797-4E8A-BF37-F2C3751466E9}" type="datetimeFigureOut">
               <a:rPr lang="en-US" dirty="0"/>
-              <a:t>1/10/26</a:t>
+              <a:t>1/14/26</a:t>
             </a:fld>
             <a:endParaRPr lang="en-US" dirty="0"/>
           </a:p>
@@ -6880,7 +6880,7 @@
           <a:p>
             <a:fld id="{D82014A1-A632-4878-A0D3-F52BA7563730}" type="datetimeFigureOut">
               <a:rPr lang="en-US" dirty="0"/>
-              <a:t>1/10/26</a:t>
+              <a:t>1/14/26</a:t>
             </a:fld>
             <a:endParaRPr lang="en-US" dirty="0"/>
           </a:p>
@@ -7132,7 +7132,7 @@
           <a:p>
             <a:fld id="{CE99F462-093F-4566-844B-4C71F2739DA5}" type="datetimeFigureOut">
               <a:rPr lang="en-US" dirty="0"/>
-              <a:t>1/10/26</a:t>
+              <a:t>1/14/26</a:t>
             </a:fld>
             <a:endParaRPr lang="en-US" dirty="0"/>
           </a:p>
@@ -7290,7 +7290,7 @@
           <a:p>
             <a:fld id="{3D24A7AC-904D-4781-85BA-7D10C17ED021}" type="datetimeFigureOut">
               <a:rPr lang="en-US" dirty="0"/>
-              <a:t>1/10/26</a:t>
+              <a:t>1/14/26</a:t>
             </a:fld>
             <a:endParaRPr lang="en-US" dirty="0"/>
           </a:p>
@@ -7675,7 +7675,7 @@
           <a:p>
             <a:fld id="{E331444B-B92B-4E27-8C94-BB93EAF5CB18}" type="datetimeFigureOut">
               <a:rPr lang="en-US" dirty="0"/>
-              <a:t>1/10/26</a:t>
+              <a:t>1/14/26</a:t>
             </a:fld>
             <a:endParaRPr lang="en-US" dirty="0"/>
           </a:p>
@@ -8079,7 +8079,7 @@
           <a:p>
             <a:fld id="{363EFA5E-FA76-400D-B3DC-F0BA90E6D107}" type="datetimeFigureOut">
               <a:rPr lang="en-US" dirty="0"/>
-              <a:t>1/10/26</a:t>
+              <a:t>1/14/26</a:t>
             </a:fld>
             <a:endParaRPr lang="en-US" dirty="0"/>
           </a:p>
@@ -8318,7 +8318,7 @@
           <a:p>
             <a:fld id="{9D6E9DEC-419B-4CC5-A080-3B06BD5A8291}" type="datetimeFigureOut">
               <a:rPr lang="en-US" dirty="0"/>
-              <a:t>1/10/26</a:t>
+              <a:t>1/14/26</a:t>
             </a:fld>
             <a:endParaRPr lang="en-US" dirty="0"/>
           </a:p>
@@ -17331,35 +17331,35 @@
             <a:pPr lvl="1"/>
             <a:r>
               <a:rPr lang="en-US" dirty="0"/>
+              <a:t>Naming and Coding Conventions (static analysis)</a:t>
+            </a:r>
+          </a:p>
+          <a:p>
+            <a:pPr lvl="1"/>
+            <a:r>
+              <a:rPr lang="en-US" dirty="0"/>
+              <a:t>Task and Defect Tracking</a:t>
+            </a:r>
+          </a:p>
+          <a:p>
+            <a:pPr lvl="1"/>
+            <a:r>
+              <a:rPr lang="en-US" dirty="0"/>
+              <a:t>Automation (e.g. continuous integration)</a:t>
+            </a:r>
+          </a:p>
+          <a:p>
+            <a:pPr lvl="1"/>
+            <a:r>
+              <a:rPr lang="en-US" dirty="0"/>
+              <a:t>Specifications and Requirements</a:t>
+            </a:r>
+          </a:p>
+          <a:p>
+            <a:pPr lvl="1"/>
+            <a:r>
+              <a:rPr lang="en-US" dirty="0"/>
               <a:t>Software Design (modularity, repeatability, non-functional properties)</a:t>
-            </a:r>
-          </a:p>
-          <a:p>
-            <a:pPr lvl="1"/>
-            <a:r>
-              <a:rPr lang="en-US" dirty="0"/>
-              <a:t>Specifications and Requirements</a:t>
-            </a:r>
-          </a:p>
-          <a:p>
-            <a:pPr lvl="1"/>
-            <a:r>
-              <a:rPr lang="en-US" dirty="0"/>
-              <a:t>Naming and Coding Conventions (static analysis)</a:t>
-            </a:r>
-          </a:p>
-          <a:p>
-            <a:pPr lvl="1"/>
-            <a:r>
-              <a:rPr lang="en-US" dirty="0"/>
-              <a:t>Task and Defect Tracking</a:t>
-            </a:r>
-          </a:p>
-          <a:p>
-            <a:pPr lvl="1"/>
-            <a:r>
-              <a:rPr lang="en-US" dirty="0"/>
-              <a:t>Automation (e.g. continuous integration)</a:t>
             </a:r>
           </a:p>
           <a:p>
@@ -17381,6 +17381,752 @@
   <p:clrMapOvr>
     <a:masterClrMapping/>
   </p:clrMapOvr>
+  <p:timing>
+    <p:tnLst>
+      <p:par>
+        <p:cTn id="1" dur="indefinite" restart="never" nodeType="tmRoot">
+          <p:childTnLst>
+            <p:seq concurrent="1" nextAc="seek">
+              <p:cTn id="2" dur="indefinite" nodeType="mainSeq">
+                <p:childTnLst>
+                  <p:par>
+                    <p:cTn id="3" fill="hold">
+                      <p:stCondLst>
+                        <p:cond delay="indefinite"/>
+                      </p:stCondLst>
+                      <p:childTnLst>
+                        <p:par>
+                          <p:cTn id="4" fill="hold">
+                            <p:stCondLst>
+                              <p:cond delay="0"/>
+                            </p:stCondLst>
+                            <p:childTnLst>
+                              <p:par>
+                                <p:cTn id="5" presetID="2" presetClass="entr" presetSubtype="4" fill="hold" nodeType="clickEffect">
+                                  <p:stCondLst>
+                                    <p:cond delay="0"/>
+                                  </p:stCondLst>
+                                  <p:childTnLst>
+                                    <p:set>
+                                      <p:cBhvr>
+                                        <p:cTn id="6" dur="1" fill="hold">
+                                          <p:stCondLst>
+                                            <p:cond delay="0"/>
+                                          </p:stCondLst>
+                                        </p:cTn>
+                                        <p:tgtEl>
+                                          <p:spTgt spid="3">
+                                            <p:txEl>
+                                              <p:pRg st="2" end="2"/>
+                                            </p:txEl>
+                                          </p:spTgt>
+                                        </p:tgtEl>
+                                        <p:attrNameLst>
+                                          <p:attrName>style.visibility</p:attrName>
+                                        </p:attrNameLst>
+                                      </p:cBhvr>
+                                      <p:to>
+                                        <p:strVal val="visible"/>
+                                      </p:to>
+                                    </p:set>
+                                    <p:anim calcmode="lin" valueType="num">
+                                      <p:cBhvr additive="base">
+                                        <p:cTn id="7" dur="500" fill="hold"/>
+                                        <p:tgtEl>
+                                          <p:spTgt spid="3">
+                                            <p:txEl>
+                                              <p:pRg st="2" end="2"/>
+                                            </p:txEl>
+                                          </p:spTgt>
+                                        </p:tgtEl>
+                                        <p:attrNameLst>
+                                          <p:attrName>ppt_x</p:attrName>
+                                        </p:attrNameLst>
+                                      </p:cBhvr>
+                                      <p:tavLst>
+                                        <p:tav tm="0">
+                                          <p:val>
+                                            <p:strVal val="#ppt_x"/>
+                                          </p:val>
+                                        </p:tav>
+                                        <p:tav tm="100000">
+                                          <p:val>
+                                            <p:strVal val="#ppt_x"/>
+                                          </p:val>
+                                        </p:tav>
+                                      </p:tavLst>
+                                    </p:anim>
+                                    <p:anim calcmode="lin" valueType="num">
+                                      <p:cBhvr additive="base">
+                                        <p:cTn id="8" dur="500" fill="hold"/>
+                                        <p:tgtEl>
+                                          <p:spTgt spid="3">
+                                            <p:txEl>
+                                              <p:pRg st="2" end="2"/>
+                                            </p:txEl>
+                                          </p:spTgt>
+                                        </p:tgtEl>
+                                        <p:attrNameLst>
+                                          <p:attrName>ppt_y</p:attrName>
+                                        </p:attrNameLst>
+                                      </p:cBhvr>
+                                      <p:tavLst>
+                                        <p:tav tm="0">
+                                          <p:val>
+                                            <p:strVal val="1+#ppt_h/2"/>
+                                          </p:val>
+                                        </p:tav>
+                                        <p:tav tm="100000">
+                                          <p:val>
+                                            <p:strVal val="#ppt_y"/>
+                                          </p:val>
+                                        </p:tav>
+                                      </p:tavLst>
+                                    </p:anim>
+                                  </p:childTnLst>
+                                </p:cTn>
+                              </p:par>
+                            </p:childTnLst>
+                          </p:cTn>
+                        </p:par>
+                      </p:childTnLst>
+                    </p:cTn>
+                  </p:par>
+                  <p:par>
+                    <p:cTn id="9" fill="hold">
+                      <p:stCondLst>
+                        <p:cond delay="indefinite"/>
+                      </p:stCondLst>
+                      <p:childTnLst>
+                        <p:par>
+                          <p:cTn id="10" fill="hold">
+                            <p:stCondLst>
+                              <p:cond delay="0"/>
+                            </p:stCondLst>
+                            <p:childTnLst>
+                              <p:par>
+                                <p:cTn id="11" presetID="2" presetClass="entr" presetSubtype="4" fill="hold" nodeType="clickEffect">
+                                  <p:stCondLst>
+                                    <p:cond delay="0"/>
+                                  </p:stCondLst>
+                                  <p:childTnLst>
+                                    <p:set>
+                                      <p:cBhvr>
+                                        <p:cTn id="12" dur="1" fill="hold">
+                                          <p:stCondLst>
+                                            <p:cond delay="0"/>
+                                          </p:stCondLst>
+                                        </p:cTn>
+                                        <p:tgtEl>
+                                          <p:spTgt spid="3">
+                                            <p:txEl>
+                                              <p:pRg st="3" end="3"/>
+                                            </p:txEl>
+                                          </p:spTgt>
+                                        </p:tgtEl>
+                                        <p:attrNameLst>
+                                          <p:attrName>style.visibility</p:attrName>
+                                        </p:attrNameLst>
+                                      </p:cBhvr>
+                                      <p:to>
+                                        <p:strVal val="visible"/>
+                                      </p:to>
+                                    </p:set>
+                                    <p:anim calcmode="lin" valueType="num">
+                                      <p:cBhvr additive="base">
+                                        <p:cTn id="13" dur="500" fill="hold"/>
+                                        <p:tgtEl>
+                                          <p:spTgt spid="3">
+                                            <p:txEl>
+                                              <p:pRg st="3" end="3"/>
+                                            </p:txEl>
+                                          </p:spTgt>
+                                        </p:tgtEl>
+                                        <p:attrNameLst>
+                                          <p:attrName>ppt_x</p:attrName>
+                                        </p:attrNameLst>
+                                      </p:cBhvr>
+                                      <p:tavLst>
+                                        <p:tav tm="0">
+                                          <p:val>
+                                            <p:strVal val="#ppt_x"/>
+                                          </p:val>
+                                        </p:tav>
+                                        <p:tav tm="100000">
+                                          <p:val>
+                                            <p:strVal val="#ppt_x"/>
+                                          </p:val>
+                                        </p:tav>
+                                      </p:tavLst>
+                                    </p:anim>
+                                    <p:anim calcmode="lin" valueType="num">
+                                      <p:cBhvr additive="base">
+                                        <p:cTn id="14" dur="500" fill="hold"/>
+                                        <p:tgtEl>
+                                          <p:spTgt spid="3">
+                                            <p:txEl>
+                                              <p:pRg st="3" end="3"/>
+                                            </p:txEl>
+                                          </p:spTgt>
+                                        </p:tgtEl>
+                                        <p:attrNameLst>
+                                          <p:attrName>ppt_y</p:attrName>
+                                        </p:attrNameLst>
+                                      </p:cBhvr>
+                                      <p:tavLst>
+                                        <p:tav tm="0">
+                                          <p:val>
+                                            <p:strVal val="1+#ppt_h/2"/>
+                                          </p:val>
+                                        </p:tav>
+                                        <p:tav tm="100000">
+                                          <p:val>
+                                            <p:strVal val="#ppt_y"/>
+                                          </p:val>
+                                        </p:tav>
+                                      </p:tavLst>
+                                    </p:anim>
+                                  </p:childTnLst>
+                                </p:cTn>
+                              </p:par>
+                              <p:par>
+                                <p:cTn id="15" presetID="2" presetClass="entr" presetSubtype="4" fill="hold" nodeType="withEffect">
+                                  <p:stCondLst>
+                                    <p:cond delay="0"/>
+                                  </p:stCondLst>
+                                  <p:childTnLst>
+                                    <p:set>
+                                      <p:cBhvr>
+                                        <p:cTn id="16" dur="1" fill="hold">
+                                          <p:stCondLst>
+                                            <p:cond delay="0"/>
+                                          </p:stCondLst>
+                                        </p:cTn>
+                                        <p:tgtEl>
+                                          <p:spTgt spid="3">
+                                            <p:txEl>
+                                              <p:pRg st="4" end="4"/>
+                                            </p:txEl>
+                                          </p:spTgt>
+                                        </p:tgtEl>
+                                        <p:attrNameLst>
+                                          <p:attrName>style.visibility</p:attrName>
+                                        </p:attrNameLst>
+                                      </p:cBhvr>
+                                      <p:to>
+                                        <p:strVal val="visible"/>
+                                      </p:to>
+                                    </p:set>
+                                    <p:anim calcmode="lin" valueType="num">
+                                      <p:cBhvr additive="base">
+                                        <p:cTn id="17" dur="500" fill="hold"/>
+                                        <p:tgtEl>
+                                          <p:spTgt spid="3">
+                                            <p:txEl>
+                                              <p:pRg st="4" end="4"/>
+                                            </p:txEl>
+                                          </p:spTgt>
+                                        </p:tgtEl>
+                                        <p:attrNameLst>
+                                          <p:attrName>ppt_x</p:attrName>
+                                        </p:attrNameLst>
+                                      </p:cBhvr>
+                                      <p:tavLst>
+                                        <p:tav tm="0">
+                                          <p:val>
+                                            <p:strVal val="#ppt_x"/>
+                                          </p:val>
+                                        </p:tav>
+                                        <p:tav tm="100000">
+                                          <p:val>
+                                            <p:strVal val="#ppt_x"/>
+                                          </p:val>
+                                        </p:tav>
+                                      </p:tavLst>
+                                    </p:anim>
+                                    <p:anim calcmode="lin" valueType="num">
+                                      <p:cBhvr additive="base">
+                                        <p:cTn id="18" dur="500" fill="hold"/>
+                                        <p:tgtEl>
+                                          <p:spTgt spid="3">
+                                            <p:txEl>
+                                              <p:pRg st="4" end="4"/>
+                                            </p:txEl>
+                                          </p:spTgt>
+                                        </p:tgtEl>
+                                        <p:attrNameLst>
+                                          <p:attrName>ppt_y</p:attrName>
+                                        </p:attrNameLst>
+                                      </p:cBhvr>
+                                      <p:tavLst>
+                                        <p:tav tm="0">
+                                          <p:val>
+                                            <p:strVal val="1+#ppt_h/2"/>
+                                          </p:val>
+                                        </p:tav>
+                                        <p:tav tm="100000">
+                                          <p:val>
+                                            <p:strVal val="#ppt_y"/>
+                                          </p:val>
+                                        </p:tav>
+                                      </p:tavLst>
+                                    </p:anim>
+                                  </p:childTnLst>
+                                </p:cTn>
+                              </p:par>
+                              <p:par>
+                                <p:cTn id="19" presetID="2" presetClass="entr" presetSubtype="4" fill="hold" nodeType="withEffect">
+                                  <p:stCondLst>
+                                    <p:cond delay="0"/>
+                                  </p:stCondLst>
+                                  <p:childTnLst>
+                                    <p:set>
+                                      <p:cBhvr>
+                                        <p:cTn id="20" dur="1" fill="hold">
+                                          <p:stCondLst>
+                                            <p:cond delay="0"/>
+                                          </p:stCondLst>
+                                        </p:cTn>
+                                        <p:tgtEl>
+                                          <p:spTgt spid="3">
+                                            <p:txEl>
+                                              <p:pRg st="5" end="5"/>
+                                            </p:txEl>
+                                          </p:spTgt>
+                                        </p:tgtEl>
+                                        <p:attrNameLst>
+                                          <p:attrName>style.visibility</p:attrName>
+                                        </p:attrNameLst>
+                                      </p:cBhvr>
+                                      <p:to>
+                                        <p:strVal val="visible"/>
+                                      </p:to>
+                                    </p:set>
+                                    <p:anim calcmode="lin" valueType="num">
+                                      <p:cBhvr additive="base">
+                                        <p:cTn id="21" dur="500" fill="hold"/>
+                                        <p:tgtEl>
+                                          <p:spTgt spid="3">
+                                            <p:txEl>
+                                              <p:pRg st="5" end="5"/>
+                                            </p:txEl>
+                                          </p:spTgt>
+                                        </p:tgtEl>
+                                        <p:attrNameLst>
+                                          <p:attrName>ppt_x</p:attrName>
+                                        </p:attrNameLst>
+                                      </p:cBhvr>
+                                      <p:tavLst>
+                                        <p:tav tm="0">
+                                          <p:val>
+                                            <p:strVal val="#ppt_x"/>
+                                          </p:val>
+                                        </p:tav>
+                                        <p:tav tm="100000">
+                                          <p:val>
+                                            <p:strVal val="#ppt_x"/>
+                                          </p:val>
+                                        </p:tav>
+                                      </p:tavLst>
+                                    </p:anim>
+                                    <p:anim calcmode="lin" valueType="num">
+                                      <p:cBhvr additive="base">
+                                        <p:cTn id="22" dur="500" fill="hold"/>
+                                        <p:tgtEl>
+                                          <p:spTgt spid="3">
+                                            <p:txEl>
+                                              <p:pRg st="5" end="5"/>
+                                            </p:txEl>
+                                          </p:spTgt>
+                                        </p:tgtEl>
+                                        <p:attrNameLst>
+                                          <p:attrName>ppt_y</p:attrName>
+                                        </p:attrNameLst>
+                                      </p:cBhvr>
+                                      <p:tavLst>
+                                        <p:tav tm="0">
+                                          <p:val>
+                                            <p:strVal val="1+#ppt_h/2"/>
+                                          </p:val>
+                                        </p:tav>
+                                        <p:tav tm="100000">
+                                          <p:val>
+                                            <p:strVal val="#ppt_y"/>
+                                          </p:val>
+                                        </p:tav>
+                                      </p:tavLst>
+                                    </p:anim>
+                                  </p:childTnLst>
+                                </p:cTn>
+                              </p:par>
+                              <p:par>
+                                <p:cTn id="23" presetID="2" presetClass="entr" presetSubtype="4" fill="hold" nodeType="withEffect">
+                                  <p:stCondLst>
+                                    <p:cond delay="0"/>
+                                  </p:stCondLst>
+                                  <p:childTnLst>
+                                    <p:set>
+                                      <p:cBhvr>
+                                        <p:cTn id="24" dur="1" fill="hold">
+                                          <p:stCondLst>
+                                            <p:cond delay="0"/>
+                                          </p:stCondLst>
+                                        </p:cTn>
+                                        <p:tgtEl>
+                                          <p:spTgt spid="3">
+                                            <p:txEl>
+                                              <p:pRg st="6" end="6"/>
+                                            </p:txEl>
+                                          </p:spTgt>
+                                        </p:tgtEl>
+                                        <p:attrNameLst>
+                                          <p:attrName>style.visibility</p:attrName>
+                                        </p:attrNameLst>
+                                      </p:cBhvr>
+                                      <p:to>
+                                        <p:strVal val="visible"/>
+                                      </p:to>
+                                    </p:set>
+                                    <p:anim calcmode="lin" valueType="num">
+                                      <p:cBhvr additive="base">
+                                        <p:cTn id="25" dur="500" fill="hold"/>
+                                        <p:tgtEl>
+                                          <p:spTgt spid="3">
+                                            <p:txEl>
+                                              <p:pRg st="6" end="6"/>
+                                            </p:txEl>
+                                          </p:spTgt>
+                                        </p:tgtEl>
+                                        <p:attrNameLst>
+                                          <p:attrName>ppt_x</p:attrName>
+                                        </p:attrNameLst>
+                                      </p:cBhvr>
+                                      <p:tavLst>
+                                        <p:tav tm="0">
+                                          <p:val>
+                                            <p:strVal val="#ppt_x"/>
+                                          </p:val>
+                                        </p:tav>
+                                        <p:tav tm="100000">
+                                          <p:val>
+                                            <p:strVal val="#ppt_x"/>
+                                          </p:val>
+                                        </p:tav>
+                                      </p:tavLst>
+                                    </p:anim>
+                                    <p:anim calcmode="lin" valueType="num">
+                                      <p:cBhvr additive="base">
+                                        <p:cTn id="26" dur="500" fill="hold"/>
+                                        <p:tgtEl>
+                                          <p:spTgt spid="3">
+                                            <p:txEl>
+                                              <p:pRg st="6" end="6"/>
+                                            </p:txEl>
+                                          </p:spTgt>
+                                        </p:tgtEl>
+                                        <p:attrNameLst>
+                                          <p:attrName>ppt_y</p:attrName>
+                                        </p:attrNameLst>
+                                      </p:cBhvr>
+                                      <p:tavLst>
+                                        <p:tav tm="0">
+                                          <p:val>
+                                            <p:strVal val="1+#ppt_h/2"/>
+                                          </p:val>
+                                        </p:tav>
+                                        <p:tav tm="100000">
+                                          <p:val>
+                                            <p:strVal val="#ppt_y"/>
+                                          </p:val>
+                                        </p:tav>
+                                      </p:tavLst>
+                                    </p:anim>
+                                  </p:childTnLst>
+                                </p:cTn>
+                              </p:par>
+                              <p:par>
+                                <p:cTn id="27" presetID="2" presetClass="entr" presetSubtype="4" fill="hold" nodeType="withEffect">
+                                  <p:stCondLst>
+                                    <p:cond delay="0"/>
+                                  </p:stCondLst>
+                                  <p:childTnLst>
+                                    <p:set>
+                                      <p:cBhvr>
+                                        <p:cTn id="28" dur="1" fill="hold">
+                                          <p:stCondLst>
+                                            <p:cond delay="0"/>
+                                          </p:stCondLst>
+                                        </p:cTn>
+                                        <p:tgtEl>
+                                          <p:spTgt spid="3">
+                                            <p:txEl>
+                                              <p:pRg st="7" end="7"/>
+                                            </p:txEl>
+                                          </p:spTgt>
+                                        </p:tgtEl>
+                                        <p:attrNameLst>
+                                          <p:attrName>style.visibility</p:attrName>
+                                        </p:attrNameLst>
+                                      </p:cBhvr>
+                                      <p:to>
+                                        <p:strVal val="visible"/>
+                                      </p:to>
+                                    </p:set>
+                                    <p:anim calcmode="lin" valueType="num">
+                                      <p:cBhvr additive="base">
+                                        <p:cTn id="29" dur="500" fill="hold"/>
+                                        <p:tgtEl>
+                                          <p:spTgt spid="3">
+                                            <p:txEl>
+                                              <p:pRg st="7" end="7"/>
+                                            </p:txEl>
+                                          </p:spTgt>
+                                        </p:tgtEl>
+                                        <p:attrNameLst>
+                                          <p:attrName>ppt_x</p:attrName>
+                                        </p:attrNameLst>
+                                      </p:cBhvr>
+                                      <p:tavLst>
+                                        <p:tav tm="0">
+                                          <p:val>
+                                            <p:strVal val="#ppt_x"/>
+                                          </p:val>
+                                        </p:tav>
+                                        <p:tav tm="100000">
+                                          <p:val>
+                                            <p:strVal val="#ppt_x"/>
+                                          </p:val>
+                                        </p:tav>
+                                      </p:tavLst>
+                                    </p:anim>
+                                    <p:anim calcmode="lin" valueType="num">
+                                      <p:cBhvr additive="base">
+                                        <p:cTn id="30" dur="500" fill="hold"/>
+                                        <p:tgtEl>
+                                          <p:spTgt spid="3">
+                                            <p:txEl>
+                                              <p:pRg st="7" end="7"/>
+                                            </p:txEl>
+                                          </p:spTgt>
+                                        </p:tgtEl>
+                                        <p:attrNameLst>
+                                          <p:attrName>ppt_y</p:attrName>
+                                        </p:attrNameLst>
+                                      </p:cBhvr>
+                                      <p:tavLst>
+                                        <p:tav tm="0">
+                                          <p:val>
+                                            <p:strVal val="1+#ppt_h/2"/>
+                                          </p:val>
+                                        </p:tav>
+                                        <p:tav tm="100000">
+                                          <p:val>
+                                            <p:strVal val="#ppt_y"/>
+                                          </p:val>
+                                        </p:tav>
+                                      </p:tavLst>
+                                    </p:anim>
+                                  </p:childTnLst>
+                                </p:cTn>
+                              </p:par>
+                              <p:par>
+                                <p:cTn id="31" presetID="2" presetClass="entr" presetSubtype="4" fill="hold" nodeType="withEffect">
+                                  <p:stCondLst>
+                                    <p:cond delay="0"/>
+                                  </p:stCondLst>
+                                  <p:childTnLst>
+                                    <p:set>
+                                      <p:cBhvr>
+                                        <p:cTn id="32" dur="1" fill="hold">
+                                          <p:stCondLst>
+                                            <p:cond delay="0"/>
+                                          </p:stCondLst>
+                                        </p:cTn>
+                                        <p:tgtEl>
+                                          <p:spTgt spid="3">
+                                            <p:txEl>
+                                              <p:pRg st="8" end="8"/>
+                                            </p:txEl>
+                                          </p:spTgt>
+                                        </p:tgtEl>
+                                        <p:attrNameLst>
+                                          <p:attrName>style.visibility</p:attrName>
+                                        </p:attrNameLst>
+                                      </p:cBhvr>
+                                      <p:to>
+                                        <p:strVal val="visible"/>
+                                      </p:to>
+                                    </p:set>
+                                    <p:anim calcmode="lin" valueType="num">
+                                      <p:cBhvr additive="base">
+                                        <p:cTn id="33" dur="500" fill="hold"/>
+                                        <p:tgtEl>
+                                          <p:spTgt spid="3">
+                                            <p:txEl>
+                                              <p:pRg st="8" end="8"/>
+                                            </p:txEl>
+                                          </p:spTgt>
+                                        </p:tgtEl>
+                                        <p:attrNameLst>
+                                          <p:attrName>ppt_x</p:attrName>
+                                        </p:attrNameLst>
+                                      </p:cBhvr>
+                                      <p:tavLst>
+                                        <p:tav tm="0">
+                                          <p:val>
+                                            <p:strVal val="#ppt_x"/>
+                                          </p:val>
+                                        </p:tav>
+                                        <p:tav tm="100000">
+                                          <p:val>
+                                            <p:strVal val="#ppt_x"/>
+                                          </p:val>
+                                        </p:tav>
+                                      </p:tavLst>
+                                    </p:anim>
+                                    <p:anim calcmode="lin" valueType="num">
+                                      <p:cBhvr additive="base">
+                                        <p:cTn id="34" dur="500" fill="hold"/>
+                                        <p:tgtEl>
+                                          <p:spTgt spid="3">
+                                            <p:txEl>
+                                              <p:pRg st="8" end="8"/>
+                                            </p:txEl>
+                                          </p:spTgt>
+                                        </p:tgtEl>
+                                        <p:attrNameLst>
+                                          <p:attrName>ppt_y</p:attrName>
+                                        </p:attrNameLst>
+                                      </p:cBhvr>
+                                      <p:tavLst>
+                                        <p:tav tm="0">
+                                          <p:val>
+                                            <p:strVal val="1+#ppt_h/2"/>
+                                          </p:val>
+                                        </p:tav>
+                                        <p:tav tm="100000">
+                                          <p:val>
+                                            <p:strVal val="#ppt_y"/>
+                                          </p:val>
+                                        </p:tav>
+                                      </p:tavLst>
+                                    </p:anim>
+                                  </p:childTnLst>
+                                </p:cTn>
+                              </p:par>
+                              <p:par>
+                                <p:cTn id="35" presetID="2" presetClass="entr" presetSubtype="4" fill="hold" nodeType="withEffect">
+                                  <p:stCondLst>
+                                    <p:cond delay="0"/>
+                                  </p:stCondLst>
+                                  <p:childTnLst>
+                                    <p:set>
+                                      <p:cBhvr>
+                                        <p:cTn id="36" dur="1" fill="hold">
+                                          <p:stCondLst>
+                                            <p:cond delay="0"/>
+                                          </p:stCondLst>
+                                        </p:cTn>
+                                        <p:tgtEl>
+                                          <p:spTgt spid="3">
+                                            <p:txEl>
+                                              <p:pRg st="9" end="9"/>
+                                            </p:txEl>
+                                          </p:spTgt>
+                                        </p:tgtEl>
+                                        <p:attrNameLst>
+                                          <p:attrName>style.visibility</p:attrName>
+                                        </p:attrNameLst>
+                                      </p:cBhvr>
+                                      <p:to>
+                                        <p:strVal val="visible"/>
+                                      </p:to>
+                                    </p:set>
+                                    <p:anim calcmode="lin" valueType="num">
+                                      <p:cBhvr additive="base">
+                                        <p:cTn id="37" dur="500" fill="hold"/>
+                                        <p:tgtEl>
+                                          <p:spTgt spid="3">
+                                            <p:txEl>
+                                              <p:pRg st="9" end="9"/>
+                                            </p:txEl>
+                                          </p:spTgt>
+                                        </p:tgtEl>
+                                        <p:attrNameLst>
+                                          <p:attrName>ppt_x</p:attrName>
+                                        </p:attrNameLst>
+                                      </p:cBhvr>
+                                      <p:tavLst>
+                                        <p:tav tm="0">
+                                          <p:val>
+                                            <p:strVal val="#ppt_x"/>
+                                          </p:val>
+                                        </p:tav>
+                                        <p:tav tm="100000">
+                                          <p:val>
+                                            <p:strVal val="#ppt_x"/>
+                                          </p:val>
+                                        </p:tav>
+                                      </p:tavLst>
+                                    </p:anim>
+                                    <p:anim calcmode="lin" valueType="num">
+                                      <p:cBhvr additive="base">
+                                        <p:cTn id="38" dur="500" fill="hold"/>
+                                        <p:tgtEl>
+                                          <p:spTgt spid="3">
+                                            <p:txEl>
+                                              <p:pRg st="9" end="9"/>
+                                            </p:txEl>
+                                          </p:spTgt>
+                                        </p:tgtEl>
+                                        <p:attrNameLst>
+                                          <p:attrName>ppt_y</p:attrName>
+                                        </p:attrNameLst>
+                                      </p:cBhvr>
+                                      <p:tavLst>
+                                        <p:tav tm="0">
+                                          <p:val>
+                                            <p:strVal val="1+#ppt_h/2"/>
+                                          </p:val>
+                                        </p:tav>
+                                        <p:tav tm="100000">
+                                          <p:val>
+                                            <p:strVal val="#ppt_y"/>
+                                          </p:val>
+                                        </p:tav>
+                                      </p:tavLst>
+                                    </p:anim>
+                                  </p:childTnLst>
+                                </p:cTn>
+                              </p:par>
+                            </p:childTnLst>
+                          </p:cTn>
+                        </p:par>
+                      </p:childTnLst>
+                    </p:cTn>
+                  </p:par>
+                </p:childTnLst>
+              </p:cTn>
+              <p:prevCondLst>
+                <p:cond evt="onPrev" delay="0">
+                  <p:tgtEl>
+                    <p:sldTgt/>
+                  </p:tgtEl>
+                </p:cond>
+              </p:prevCondLst>
+              <p:nextCondLst>
+                <p:cond evt="onNext" delay="0">
+                  <p:tgtEl>
+                    <p:sldTgt/>
+                  </p:tgtEl>
+                </p:cond>
+              </p:nextCondLst>
+            </p:seq>
+          </p:childTnLst>
+        </p:cTn>
+      </p:par>
+    </p:tnLst>
+  </p:timing>
 </p:sld>
 </file>
 

</xml_diff>